<commit_message>
created first image series allows for connections to coordinate axis in moving reference frames
</commit_message>
<xml_diff>
--- a/slides/minkowski.pptx
+++ b/slides/minkowski.pptx
@@ -6,13 +6,16 @@
     <p:sldMasterId id="2147483798" r:id="rId2"/>
   </p:sldMasterIdLst>
   <p:notesMasterIdLst>
-    <p:notesMasterId r:id="rId7"/>
+    <p:notesMasterId r:id="rId10"/>
   </p:notesMasterIdLst>
   <p:sldIdLst>
     <p:sldId id="256" r:id="rId3"/>
     <p:sldId id="257" r:id="rId4"/>
     <p:sldId id="258" r:id="rId5"/>
-    <p:sldId id="259" r:id="rId6"/>
+    <p:sldId id="260" r:id="rId6"/>
+    <p:sldId id="261" r:id="rId7"/>
+    <p:sldId id="262" r:id="rId8"/>
+    <p:sldId id="259" r:id="rId9"/>
   </p:sldIdLst>
   <p:sldSz cx="12192000" cy="6858000"/>
   <p:notesSz cx="6858000" cy="9144000"/>
@@ -201,7 +204,7 @@
           <a:p>
             <a:fld id="{FE946714-66A9-4331-9687-D7DE69600F8C}" type="datetimeFigureOut">
               <a:rPr lang="de-DE" smtClean="0"/>
-              <a:t>20.03.2025</a:t>
+              <a:t>21.03.2025</a:t>
             </a:fld>
             <a:endParaRPr lang="de-DE"/>
           </a:p>
@@ -800,7 +803,7 @@
           <a:p>
             <a:fld id="{BC81DDBC-4466-4E4D-8348-9E61A07BBB23}" type="datetime2">
               <a:rPr lang="en-CA" smtClean="0"/>
-              <a:t>Thursday, March 20, 2025</a:t>
+              <a:t>Friday, March 21, 2025</a:t>
             </a:fld>
             <a:endParaRPr lang="de-DE"/>
           </a:p>
@@ -1209,7 +1212,7 @@
           <a:p>
             <a:fld id="{4A011472-C2FB-4557-976A-45B9E45E41B8}" type="datetime2">
               <a:rPr lang="en-CA" smtClean="0"/>
-              <a:t>Thursday, March 20, 2025</a:t>
+              <a:t>Friday, March 21, 2025</a:t>
             </a:fld>
             <a:endParaRPr lang="de-DE"/>
           </a:p>
@@ -1497,7 +1500,7 @@
           <a:p>
             <a:fld id="{0AB1A5E8-2D2A-4061-8930-BA891F6E5824}" type="datetime2">
               <a:rPr lang="en-CA" smtClean="0"/>
-              <a:t>Thursday, March 20, 2025</a:t>
+              <a:t>Friday, March 21, 2025</a:t>
             </a:fld>
             <a:endParaRPr lang="de-DE"/>
           </a:p>
@@ -1726,7 +1729,7 @@
           <a:p>
             <a:fld id="{5FB79B12-0087-499C-8708-C48C1D5EFD8A}" type="datetime2">
               <a:rPr lang="en-CA" smtClean="0"/>
-              <a:t>Thursday, March 20, 2025</a:t>
+              <a:t>Friday, March 21, 2025</a:t>
             </a:fld>
             <a:endParaRPr lang="de-DE"/>
           </a:p>
@@ -1960,7 +1963,7 @@
           <a:p>
             <a:fld id="{1F664A41-A95B-4B58-B281-ED13D91A7603}" type="datetime2">
               <a:rPr lang="en-CA" smtClean="0"/>
-              <a:t>Thursday, March 20, 2025</a:t>
+              <a:t>Friday, March 21, 2025</a:t>
             </a:fld>
             <a:endParaRPr lang="de-DE"/>
           </a:p>
@@ -2122,7 +2125,7 @@
           <a:p>
             <a:fld id="{12F3EEEF-9270-448B-8799-2AA9B50D0F5B}" type="datetime2">
               <a:rPr lang="en-CA" smtClean="0"/>
-              <a:t>Thursday, March 20, 2025</a:t>
+              <a:t>Friday, March 21, 2025</a:t>
             </a:fld>
             <a:endParaRPr lang="de-DE" dirty="0"/>
           </a:p>
@@ -2394,7 +2397,7 @@
           <a:p>
             <a:fld id="{19A37E33-DCA0-4C7F-A116-3D7ECA99B758}" type="datetime2">
               <a:rPr lang="en-CA" smtClean="0"/>
-              <a:t>Thursday, March 20, 2025</a:t>
+              <a:t>Friday, March 21, 2025</a:t>
             </a:fld>
             <a:endParaRPr lang="de-DE"/>
           </a:p>
@@ -2700,7 +2703,7 @@
           <a:p>
             <a:fld id="{5B55F0DF-0DE4-46A6-89EE-D85721A78BFF}" type="datetime2">
               <a:rPr lang="en-CA" smtClean="0"/>
-              <a:t>Thursday, March 20, 2025</a:t>
+              <a:t>Friday, March 21, 2025</a:t>
             </a:fld>
             <a:endParaRPr lang="de-DE"/>
           </a:p>
@@ -3001,7 +3004,7 @@
           <a:p>
             <a:fld id="{E996B742-5549-4C1E-A4A7-964958457E23}" type="datetime2">
               <a:rPr lang="en-CA" smtClean="0"/>
-              <a:t>Thursday, March 20, 2025</a:t>
+              <a:t>Friday, March 21, 2025</a:t>
             </a:fld>
             <a:endParaRPr lang="de-DE"/>
           </a:p>
@@ -3168,7 +3171,7 @@
           <a:p>
             <a:fld id="{E6E52A30-8CC1-4184-BF4D-47E2B21E4EAF}" type="datetime2">
               <a:rPr lang="en-CA" smtClean="0"/>
-              <a:t>Thursday, March 20, 2025</a:t>
+              <a:t>Friday, March 21, 2025</a:t>
             </a:fld>
             <a:endParaRPr lang="de-DE"/>
           </a:p>
@@ -3328,7 +3331,7 @@
           <a:p>
             <a:fld id="{32A64B94-830A-44DB-B256-EB4AB7B8943B}" type="datetime2">
               <a:rPr lang="en-CA" smtClean="0"/>
-              <a:t>Thursday, March 20, 2025</a:t>
+              <a:t>Friday, March 21, 2025</a:t>
             </a:fld>
             <a:endParaRPr lang="de-DE"/>
           </a:p>
@@ -3749,7 +3752,7 @@
           <a:p>
             <a:fld id="{4BA684CD-BF8B-4444-AC4B-E9077F770D42}" type="datetime2">
               <a:rPr lang="en-CA" smtClean="0"/>
-              <a:t>Thursday, March 20, 2025</a:t>
+              <a:t>Friday, March 21, 2025</a:t>
             </a:fld>
             <a:endParaRPr lang="de-DE"/>
           </a:p>
@@ -3843,7 +3846,7 @@
           <a:p>
             <a:fld id="{B72ED8E9-D70F-45C4-8048-A836134AE31C}" type="datetime2">
               <a:rPr lang="en-CA" smtClean="0"/>
-              <a:t>Thursday, March 20, 2025</a:t>
+              <a:t>Friday, March 21, 2025</a:t>
             </a:fld>
             <a:endParaRPr lang="de-DE"/>
           </a:p>
@@ -4004,7 +4007,7 @@
           <a:p>
             <a:fld id="{E2FEC878-C261-4EEC-84F8-2911246240CC}" type="datetime2">
               <a:rPr lang="en-CA" smtClean="0"/>
-              <a:t>Thursday, March 20, 2025</a:t>
+              <a:t>Friday, March 21, 2025</a:t>
             </a:fld>
             <a:endParaRPr lang="de-DE"/>
           </a:p>
@@ -5079,7 +5082,7 @@
           <a:p>
             <a:fld id="{5B784850-771A-44E0-8EA9-A966A4C42E11}" type="datetime2">
               <a:rPr lang="en-CA" smtClean="0"/>
-              <a:t>Thursday, March 20, 2025</a:t>
+              <a:t>Friday, March 21, 2025</a:t>
             </a:fld>
             <a:endParaRPr lang="de-DE" dirty="0"/>
           </a:p>
@@ -6775,7 +6778,7 @@
           <a:p>
             <a:fld id="{19A37E33-DCA0-4C7F-A116-3D7ECA99B758}" type="datetime2">
               <a:rPr lang="en-CA" smtClean="0"/>
-              <a:t>Thursday, March 20, 2025</a:t>
+              <a:t>Friday, March 21, 2025</a:t>
             </a:fld>
             <a:endParaRPr lang="de-DE"/>
           </a:p>
@@ -6881,15 +6884,11 @@
           </p:nvPr>
         </p:nvPicPr>
         <p:blipFill>
-          <a:blip r:embed="rId2">
-            <a:extLst>
-              <a:ext uri="{96DAC541-7B7A-43D3-8B79-37D633B846F1}">
-                <asvg:svgBlip xmlns:asvg="http://schemas.microsoft.com/office/drawing/2016/SVG/main" r:embed="rId3"/>
-              </a:ext>
-            </a:extLst>
-          </a:blip>
+          <a:blip r:link="rId2"/>
           <a:srcRect/>
-          <a:stretch/>
+          <a:stretch>
+            <a:fillRect/>
+          </a:stretch>
         </p:blipFill>
         <p:spPr>
           <a:xfrm>
@@ -6912,6 +6911,276 @@
 </file>
 
 <file path=ppt/slides/slide4.xml><?xml version="1.0" encoding="utf-8"?>
+<p:sld xmlns:a="http://schemas.openxmlformats.org/drawingml/2006/main" xmlns:r="http://schemas.openxmlformats.org/officeDocument/2006/relationships" xmlns:p="http://schemas.openxmlformats.org/presentationml/2006/main">
+  <p:cSld>
+    <p:spTree>
+      <p:nvGrpSpPr>
+        <p:cNvPr id="1" name="">
+          <a:extLst>
+            <a:ext uri="{FF2B5EF4-FFF2-40B4-BE49-F238E27FC236}">
+              <a16:creationId xmlns:a16="http://schemas.microsoft.com/office/drawing/2014/main" id="{ECA75F3D-C067-F07F-01E1-A2C97B7E300A}"/>
+            </a:ext>
+          </a:extLst>
+        </p:cNvPr>
+        <p:cNvGrpSpPr/>
+        <p:nvPr/>
+      </p:nvGrpSpPr>
+      <p:grpSpPr>
+        <a:xfrm>
+          <a:off x="0" y="0"/>
+          <a:ext cx="0" cy="0"/>
+          <a:chOff x="0" y="0"/>
+          <a:chExt cx="0" cy="0"/>
+        </a:xfrm>
+      </p:grpSpPr>
+      <p:pic>
+        <p:nvPicPr>
+          <p:cNvPr id="4" name="Content Placeholder 3">
+            <a:extLst>
+              <a:ext uri="{FF2B5EF4-FFF2-40B4-BE49-F238E27FC236}">
+                <a16:creationId xmlns:a16="http://schemas.microsoft.com/office/drawing/2014/main" id="{CE63BCCF-9627-37EA-70AE-96BC7FA375BF}"/>
+              </a:ext>
+            </a:extLst>
+          </p:cNvPr>
+          <p:cNvPicPr>
+            <a:picLocks noGrp="1" noChangeAspect="1"/>
+          </p:cNvPicPr>
+          <p:nvPr>
+            <p:ph idx="1"/>
+          </p:nvPr>
+        </p:nvPicPr>
+        <p:blipFill>
+          <a:blip r:link="rId2"/>
+          <a:srcRect/>
+          <a:stretch>
+            <a:fillRect/>
+          </a:stretch>
+        </p:blipFill>
+        <p:spPr>
+          <a:xfrm>
+            <a:off x="439948" y="-422692"/>
+            <a:ext cx="7556740" cy="7556740"/>
+          </a:xfrm>
+        </p:spPr>
+      </p:pic>
+      <p:sp>
+        <p:nvSpPr>
+          <p:cNvPr id="2" name="TextBox 1">
+            <a:extLst>
+              <a:ext uri="{FF2B5EF4-FFF2-40B4-BE49-F238E27FC236}">
+                <a16:creationId xmlns:a16="http://schemas.microsoft.com/office/drawing/2014/main" id="{63F2C111-F291-2C52-453C-26534E9C5350}"/>
+              </a:ext>
+            </a:extLst>
+          </p:cNvPr>
+          <p:cNvSpPr txBox="1"/>
+          <p:nvPr/>
+        </p:nvSpPr>
+        <p:spPr>
+          <a:xfrm>
+            <a:off x="8672601" y="278296"/>
+            <a:ext cx="2300199" cy="923330"/>
+          </a:xfrm>
+          <a:prstGeom prst="rect">
+            <a:avLst/>
+          </a:prstGeom>
+          <a:noFill/>
+        </p:spPr>
+        <p:txBody>
+          <a:bodyPr wrap="square" rtlCol="0">
+            <a:spAutoFit/>
+          </a:bodyPr>
+          <a:lstStyle/>
+          <a:p>
+            <a:r>
+              <a:rPr lang="en-US" dirty="0">
+                <a:solidFill>
+                  <a:schemeClr val="bg1"/>
+                </a:solidFill>
+              </a:rPr>
+              <a:t>An event at </a:t>
+            </a:r>
+          </a:p>
+          <a:p>
+            <a:r>
+              <a:rPr lang="en-US" dirty="0">
+                <a:solidFill>
+                  <a:schemeClr val="bg1"/>
+                </a:solidFill>
+              </a:rPr>
+              <a:t>z 	= 1</a:t>
+            </a:r>
+          </a:p>
+          <a:p>
+            <a:r>
+              <a:rPr lang="en-US" dirty="0" err="1">
+                <a:solidFill>
+                  <a:schemeClr val="bg1"/>
+                </a:solidFill>
+              </a:rPr>
+              <a:t>ct</a:t>
+            </a:r>
+            <a:r>
+              <a:rPr lang="en-US" dirty="0">
+                <a:solidFill>
+                  <a:schemeClr val="bg1"/>
+                </a:solidFill>
+              </a:rPr>
+              <a:t>	= 1</a:t>
+            </a:r>
+            <a:endParaRPr lang="en-CH" dirty="0">
+              <a:solidFill>
+                <a:schemeClr val="bg1"/>
+              </a:solidFill>
+            </a:endParaRPr>
+          </a:p>
+        </p:txBody>
+      </p:sp>
+    </p:spTree>
+    <p:extLst>
+      <p:ext uri="{BB962C8B-B14F-4D97-AF65-F5344CB8AC3E}">
+        <p14:creationId xmlns:p14="http://schemas.microsoft.com/office/powerpoint/2010/main" val="1341759755"/>
+      </p:ext>
+    </p:extLst>
+  </p:cSld>
+  <p:clrMapOvr>
+    <a:masterClrMapping/>
+  </p:clrMapOvr>
+</p:sld>
+</file>
+
+<file path=ppt/slides/slide5.xml><?xml version="1.0" encoding="utf-8"?>
+<p:sld xmlns:a="http://schemas.openxmlformats.org/drawingml/2006/main" xmlns:r="http://schemas.openxmlformats.org/officeDocument/2006/relationships" xmlns:p="http://schemas.openxmlformats.org/presentationml/2006/main">
+  <p:cSld>
+    <p:spTree>
+      <p:nvGrpSpPr>
+        <p:cNvPr id="1" name="">
+          <a:extLst>
+            <a:ext uri="{FF2B5EF4-FFF2-40B4-BE49-F238E27FC236}">
+              <a16:creationId xmlns:a16="http://schemas.microsoft.com/office/drawing/2014/main" id="{4E3A5333-7ECB-56F6-0F76-15F8C3987DA9}"/>
+            </a:ext>
+          </a:extLst>
+        </p:cNvPr>
+        <p:cNvGrpSpPr/>
+        <p:nvPr/>
+      </p:nvGrpSpPr>
+      <p:grpSpPr>
+        <a:xfrm>
+          <a:off x="0" y="0"/>
+          <a:ext cx="0" cy="0"/>
+          <a:chOff x="0" y="0"/>
+          <a:chExt cx="0" cy="0"/>
+        </a:xfrm>
+      </p:grpSpPr>
+      <p:pic>
+        <p:nvPicPr>
+          <p:cNvPr id="4" name="Content Placeholder 3">
+            <a:extLst>
+              <a:ext uri="{FF2B5EF4-FFF2-40B4-BE49-F238E27FC236}">
+                <a16:creationId xmlns:a16="http://schemas.microsoft.com/office/drawing/2014/main" id="{A9174196-8C4F-894C-F057-BA428C8722D0}"/>
+              </a:ext>
+            </a:extLst>
+          </p:cNvPr>
+          <p:cNvPicPr>
+            <a:picLocks noGrp="1" noChangeAspect="1"/>
+          </p:cNvPicPr>
+          <p:nvPr>
+            <p:ph idx="1"/>
+          </p:nvPr>
+        </p:nvPicPr>
+        <p:blipFill>
+          <a:blip r:link="rId2"/>
+          <a:srcRect/>
+          <a:stretch>
+            <a:fillRect/>
+          </a:stretch>
+        </p:blipFill>
+        <p:spPr>
+          <a:xfrm>
+            <a:off x="439948" y="-422692"/>
+            <a:ext cx="7556740" cy="7556740"/>
+          </a:xfrm>
+        </p:spPr>
+      </p:pic>
+    </p:spTree>
+    <p:extLst>
+      <p:ext uri="{BB962C8B-B14F-4D97-AF65-F5344CB8AC3E}">
+        <p14:creationId xmlns:p14="http://schemas.microsoft.com/office/powerpoint/2010/main" val="2469453100"/>
+      </p:ext>
+    </p:extLst>
+  </p:cSld>
+  <p:clrMapOvr>
+    <a:masterClrMapping/>
+  </p:clrMapOvr>
+</p:sld>
+</file>
+
+<file path=ppt/slides/slide6.xml><?xml version="1.0" encoding="utf-8"?>
+<p:sld xmlns:a="http://schemas.openxmlformats.org/drawingml/2006/main" xmlns:r="http://schemas.openxmlformats.org/officeDocument/2006/relationships" xmlns:p="http://schemas.openxmlformats.org/presentationml/2006/main">
+  <p:cSld>
+    <p:spTree>
+      <p:nvGrpSpPr>
+        <p:cNvPr id="1" name="">
+          <a:extLst>
+            <a:ext uri="{FF2B5EF4-FFF2-40B4-BE49-F238E27FC236}">
+              <a16:creationId xmlns:a16="http://schemas.microsoft.com/office/drawing/2014/main" id="{5E170449-BA57-C04C-4200-A8CF8F3A7E78}"/>
+            </a:ext>
+          </a:extLst>
+        </p:cNvPr>
+        <p:cNvGrpSpPr/>
+        <p:nvPr/>
+      </p:nvGrpSpPr>
+      <p:grpSpPr>
+        <a:xfrm>
+          <a:off x="0" y="0"/>
+          <a:ext cx="0" cy="0"/>
+          <a:chOff x="0" y="0"/>
+          <a:chExt cx="0" cy="0"/>
+        </a:xfrm>
+      </p:grpSpPr>
+      <p:pic>
+        <p:nvPicPr>
+          <p:cNvPr id="4" name="Content Placeholder 3">
+            <a:extLst>
+              <a:ext uri="{FF2B5EF4-FFF2-40B4-BE49-F238E27FC236}">
+                <a16:creationId xmlns:a16="http://schemas.microsoft.com/office/drawing/2014/main" id="{01F24675-C23C-43FC-E722-FDAEAC09ADE2}"/>
+              </a:ext>
+            </a:extLst>
+          </p:cNvPr>
+          <p:cNvPicPr>
+            <a:picLocks noGrp="1" noChangeAspect="1"/>
+          </p:cNvPicPr>
+          <p:nvPr>
+            <p:ph idx="1"/>
+          </p:nvPr>
+        </p:nvPicPr>
+        <p:blipFill>
+          <a:blip r:link="rId2"/>
+          <a:srcRect/>
+          <a:stretch>
+            <a:fillRect/>
+          </a:stretch>
+        </p:blipFill>
+        <p:spPr>
+          <a:xfrm>
+            <a:off x="439948" y="-422692"/>
+            <a:ext cx="7556740" cy="7556740"/>
+          </a:xfrm>
+        </p:spPr>
+      </p:pic>
+    </p:spTree>
+    <p:extLst>
+      <p:ext uri="{BB962C8B-B14F-4D97-AF65-F5344CB8AC3E}">
+        <p14:creationId xmlns:p14="http://schemas.microsoft.com/office/powerpoint/2010/main" val="1932363575"/>
+      </p:ext>
+    </p:extLst>
+  </p:cSld>
+  <p:clrMapOvr>
+    <a:masterClrMapping/>
+  </p:clrMapOvr>
+</p:sld>
+</file>
+
+<file path=ppt/slides/slide7.xml><?xml version="1.0" encoding="utf-8"?>
 <p:sld xmlns:a="http://schemas.openxmlformats.org/drawingml/2006/main" xmlns:r="http://schemas.openxmlformats.org/officeDocument/2006/relationships" xmlns:p="http://schemas.openxmlformats.org/presentationml/2006/main">
   <p:cSld>
     <p:spTree>
@@ -6951,13 +7220,8 @@
           </p:nvPr>
         </p:nvPicPr>
         <p:blipFill>
-          <a:blip r:embed="rId2">
-            <a:extLst>
-              <a:ext uri="{96DAC541-7B7A-43D3-8B79-37D633B846F1}">
-                <asvg:svgBlip xmlns:asvg="http://schemas.microsoft.com/office/drawing/2016/SVG/main" r:link="rId3"/>
-              </a:ext>
-            </a:extLst>
-          </a:blip>
+          <a:blip r:link="rId2"/>
+          <a:srcRect/>
           <a:stretch>
             <a:fillRect/>
           </a:stretch>

</xml_diff>

<commit_message>
created second image series
</commit_message>
<xml_diff>
--- a/slides/minkowski.pptx
+++ b/slides/minkowski.pptx
@@ -6,7 +6,7 @@
     <p:sldMasterId id="2147483798" r:id="rId2"/>
   </p:sldMasterIdLst>
   <p:notesMasterIdLst>
-    <p:notesMasterId r:id="rId10"/>
+    <p:notesMasterId r:id="rId13"/>
   </p:notesMasterIdLst>
   <p:sldIdLst>
     <p:sldId id="256" r:id="rId3"/>
@@ -15,7 +15,10 @@
     <p:sldId id="260" r:id="rId6"/>
     <p:sldId id="261" r:id="rId7"/>
     <p:sldId id="262" r:id="rId8"/>
-    <p:sldId id="259" r:id="rId9"/>
+    <p:sldId id="263" r:id="rId9"/>
+    <p:sldId id="264" r:id="rId10"/>
+    <p:sldId id="265" r:id="rId11"/>
+    <p:sldId id="259" r:id="rId12"/>
   </p:sldIdLst>
   <p:sldSz cx="12192000" cy="6858000"/>
   <p:notesSz cx="6858000" cy="9144000"/>
@@ -5937,6 +5940,72 @@
     <p:extLst>
       <p:ext uri="{BB962C8B-B14F-4D97-AF65-F5344CB8AC3E}">
         <p14:creationId xmlns:p14="http://schemas.microsoft.com/office/powerpoint/2010/main" val="1013428175"/>
+      </p:ext>
+    </p:extLst>
+  </p:cSld>
+  <p:clrMapOvr>
+    <a:masterClrMapping/>
+  </p:clrMapOvr>
+</p:sld>
+</file>
+
+<file path=ppt/slides/slide10.xml><?xml version="1.0" encoding="utf-8"?>
+<p:sld xmlns:a="http://schemas.openxmlformats.org/drawingml/2006/main" xmlns:r="http://schemas.openxmlformats.org/officeDocument/2006/relationships" xmlns:p="http://schemas.openxmlformats.org/presentationml/2006/main">
+  <p:cSld>
+    <p:spTree>
+      <p:nvGrpSpPr>
+        <p:cNvPr id="1" name="">
+          <a:extLst>
+            <a:ext uri="{FF2B5EF4-FFF2-40B4-BE49-F238E27FC236}">
+              <a16:creationId xmlns:a16="http://schemas.microsoft.com/office/drawing/2014/main" id="{78433A00-2C99-2075-FCE1-683B869DA7A7}"/>
+            </a:ext>
+          </a:extLst>
+        </p:cNvPr>
+        <p:cNvGrpSpPr/>
+        <p:nvPr/>
+      </p:nvGrpSpPr>
+      <p:grpSpPr>
+        <a:xfrm>
+          <a:off x="0" y="0"/>
+          <a:ext cx="0" cy="0"/>
+          <a:chOff x="0" y="0"/>
+          <a:chExt cx="0" cy="0"/>
+        </a:xfrm>
+      </p:grpSpPr>
+      <p:pic>
+        <p:nvPicPr>
+          <p:cNvPr id="4" name="Content Placeholder 3">
+            <a:extLst>
+              <a:ext uri="{FF2B5EF4-FFF2-40B4-BE49-F238E27FC236}">
+                <a16:creationId xmlns:a16="http://schemas.microsoft.com/office/drawing/2014/main" id="{54F5FABB-B0FA-DCB2-041A-419C82B20932}"/>
+              </a:ext>
+            </a:extLst>
+          </p:cNvPr>
+          <p:cNvPicPr>
+            <a:picLocks noGrp="1" noChangeAspect="1"/>
+          </p:cNvPicPr>
+          <p:nvPr>
+            <p:ph idx="1"/>
+          </p:nvPr>
+        </p:nvPicPr>
+        <p:blipFill>
+          <a:blip r:link="rId2"/>
+          <a:srcRect/>
+          <a:stretch>
+            <a:fillRect/>
+          </a:stretch>
+        </p:blipFill>
+        <p:spPr>
+          <a:xfrm>
+            <a:off x="439948" y="-422692"/>
+            <a:ext cx="7556740" cy="7556740"/>
+          </a:xfrm>
+        </p:spPr>
+      </p:pic>
+    </p:spTree>
+    <p:extLst>
+      <p:ext uri="{BB962C8B-B14F-4D97-AF65-F5344CB8AC3E}">
+        <p14:creationId xmlns:p14="http://schemas.microsoft.com/office/powerpoint/2010/main" val="4206889277"/>
       </p:ext>
     </p:extLst>
   </p:cSld>
@@ -6780,7 +6849,7 @@
               <a:rPr lang="en-CA" smtClean="0"/>
               <a:t>Friday, March 21, 2025</a:t>
             </a:fld>
-            <a:endParaRPr lang="de-DE"/>
+            <a:endParaRPr lang="de-DE" dirty="0"/>
           </a:p>
         </p:txBody>
       </p:sp>
@@ -6833,7 +6902,10 @@
           <a:bodyPr/>
           <a:lstStyle/>
           <a:p>
-            <a:endParaRPr lang="de-DE" dirty="0"/>
+            <a:r>
+              <a:rPr lang="de-DE" dirty="0"/>
+              <a:t>Einführung</a:t>
+            </a:r>
           </a:p>
         </p:txBody>
       </p:sp>
@@ -6977,8 +7049,8 @@
         </p:nvSpPr>
         <p:spPr>
           <a:xfrm>
-            <a:off x="8672601" y="278296"/>
-            <a:ext cx="2300199" cy="923330"/>
+            <a:off x="8547652" y="153348"/>
+            <a:ext cx="3475855" cy="923330"/>
           </a:xfrm>
           <a:prstGeom prst="rect">
             <a:avLst/>
@@ -6997,8 +7069,53 @@
                   <a:schemeClr val="bg1"/>
                 </a:solidFill>
               </a:rPr>
-              <a:t>An event at </a:t>
-            </a:r>
+              <a:t>Ein </a:t>
+            </a:r>
+            <a:r>
+              <a:rPr lang="en-US" dirty="0" err="1">
+                <a:solidFill>
+                  <a:schemeClr val="bg1"/>
+                </a:solidFill>
+              </a:rPr>
+              <a:t>Ereignis</a:t>
+            </a:r>
+            <a:r>
+              <a:rPr lang="en-US" dirty="0">
+                <a:solidFill>
+                  <a:schemeClr val="bg1"/>
+                </a:solidFill>
+              </a:rPr>
+              <a:t> </a:t>
+            </a:r>
+            <a:r>
+              <a:rPr lang="en-US" dirty="0" err="1">
+                <a:solidFill>
+                  <a:schemeClr val="bg1"/>
+                </a:solidFill>
+              </a:rPr>
+              <a:t>mit</a:t>
+            </a:r>
+            <a:r>
+              <a:rPr lang="en-US" dirty="0">
+                <a:solidFill>
+                  <a:schemeClr val="bg1"/>
+                </a:solidFill>
+              </a:rPr>
+              <a:t> Ort und </a:t>
+            </a:r>
+            <a:r>
+              <a:rPr lang="en-US" dirty="0" err="1">
+                <a:solidFill>
+                  <a:schemeClr val="bg1"/>
+                </a:solidFill>
+              </a:rPr>
+              <a:t>Zeitpunkt</a:t>
+            </a:r>
+            <a:endParaRPr lang="en-US" dirty="0">
+              <a:solidFill>
+                <a:schemeClr val="bg1"/>
+              </a:solidFill>
+            </a:endParaRPr>
           </a:p>
           <a:p>
             <a:r>
@@ -7025,7 +7142,7 @@
                   <a:schemeClr val="bg1"/>
                 </a:solidFill>
               </a:rPr>
-              <a:t>	= 1</a:t>
+              <a:t>	= 2</a:t>
             </a:r>
             <a:endParaRPr lang="en-CH" dirty="0">
               <a:solidFill>
@@ -7101,6 +7218,236 @@
           </a:xfrm>
         </p:spPr>
       </p:pic>
+      <p:sp>
+        <p:nvSpPr>
+          <p:cNvPr id="3" name="TextBox 2">
+            <a:extLst>
+              <a:ext uri="{FF2B5EF4-FFF2-40B4-BE49-F238E27FC236}">
+                <a16:creationId xmlns:a16="http://schemas.microsoft.com/office/drawing/2014/main" id="{CDD10BD1-7356-F130-A708-E691778DE73F}"/>
+              </a:ext>
+            </a:extLst>
+          </p:cNvPr>
+          <p:cNvSpPr txBox="1"/>
+          <p:nvPr/>
+        </p:nvSpPr>
+        <p:spPr>
+          <a:xfrm>
+            <a:off x="8547652" y="153348"/>
+            <a:ext cx="3475855" cy="1754326"/>
+          </a:xfrm>
+          <a:prstGeom prst="rect">
+            <a:avLst/>
+          </a:prstGeom>
+          <a:noFill/>
+        </p:spPr>
+        <p:txBody>
+          <a:bodyPr wrap="square" rtlCol="0">
+            <a:spAutoFit/>
+          </a:bodyPr>
+          <a:lstStyle/>
+          <a:p>
+            <a:r>
+              <a:rPr lang="en-US" dirty="0">
+                <a:solidFill>
+                  <a:schemeClr val="bg1"/>
+                </a:solidFill>
+              </a:rPr>
+              <a:t>Ein </a:t>
+            </a:r>
+            <a:r>
+              <a:rPr lang="en-US" dirty="0" err="1">
+                <a:solidFill>
+                  <a:schemeClr val="bg1"/>
+                </a:solidFill>
+              </a:rPr>
+              <a:t>Ereignis</a:t>
+            </a:r>
+            <a:r>
+              <a:rPr lang="en-US" dirty="0">
+                <a:solidFill>
+                  <a:schemeClr val="bg1"/>
+                </a:solidFill>
+              </a:rPr>
+              <a:t> </a:t>
+            </a:r>
+            <a:r>
+              <a:rPr lang="en-US" dirty="0" err="1">
+                <a:solidFill>
+                  <a:schemeClr val="bg1"/>
+                </a:solidFill>
+              </a:rPr>
+              <a:t>mit</a:t>
+            </a:r>
+            <a:r>
+              <a:rPr lang="en-US" dirty="0">
+                <a:solidFill>
+                  <a:schemeClr val="bg1"/>
+                </a:solidFill>
+              </a:rPr>
+              <a:t> Ort und </a:t>
+            </a:r>
+            <a:r>
+              <a:rPr lang="en-US" dirty="0" err="1">
+                <a:solidFill>
+                  <a:schemeClr val="bg1"/>
+                </a:solidFill>
+              </a:rPr>
+              <a:t>Zeitpunkt</a:t>
+            </a:r>
+            <a:endParaRPr lang="en-US" dirty="0">
+              <a:solidFill>
+                <a:schemeClr val="bg1"/>
+              </a:solidFill>
+            </a:endParaRPr>
+          </a:p>
+          <a:p>
+            <a:r>
+              <a:rPr lang="en-US" dirty="0">
+                <a:solidFill>
+                  <a:schemeClr val="bg1"/>
+                </a:solidFill>
+              </a:rPr>
+              <a:t>z 	= 1</a:t>
+            </a:r>
+          </a:p>
+          <a:p>
+            <a:r>
+              <a:rPr lang="en-US" dirty="0" err="1">
+                <a:solidFill>
+                  <a:schemeClr val="bg1"/>
+                </a:solidFill>
+              </a:rPr>
+              <a:t>ct</a:t>
+            </a:r>
+            <a:r>
+              <a:rPr lang="en-US" dirty="0">
+                <a:solidFill>
+                  <a:schemeClr val="bg1"/>
+                </a:solidFill>
+              </a:rPr>
+              <a:t>	= 2</a:t>
+            </a:r>
+          </a:p>
+          <a:p>
+            <a:endParaRPr lang="en-US" dirty="0">
+              <a:solidFill>
+                <a:schemeClr val="bg1"/>
+              </a:solidFill>
+            </a:endParaRPr>
+          </a:p>
+          <a:p>
+            <a:r>
+              <a:rPr lang="en-US" dirty="0" err="1">
+                <a:solidFill>
+                  <a:schemeClr val="bg1"/>
+                </a:solidFill>
+              </a:rPr>
+              <a:t>Verbindung</a:t>
+            </a:r>
+            <a:r>
+              <a:rPr lang="en-US" dirty="0">
+                <a:solidFill>
+                  <a:schemeClr val="bg1"/>
+                </a:solidFill>
+              </a:rPr>
+              <a:t> </a:t>
+            </a:r>
+            <a:r>
+              <a:rPr lang="en-US" dirty="0" err="1">
+                <a:solidFill>
+                  <a:schemeClr val="bg1"/>
+                </a:solidFill>
+              </a:rPr>
+              <a:t>zu</a:t>
+            </a:r>
+            <a:r>
+              <a:rPr lang="en-US" dirty="0">
+                <a:solidFill>
+                  <a:schemeClr val="bg1"/>
+                </a:solidFill>
+              </a:rPr>
+              <a:t> den </a:t>
+            </a:r>
+            <a:r>
+              <a:rPr lang="en-US" dirty="0" err="1">
+                <a:solidFill>
+                  <a:schemeClr val="bg1"/>
+                </a:solidFill>
+              </a:rPr>
+              <a:t>Koordinaten</a:t>
+            </a:r>
+            <a:r>
+              <a:rPr lang="en-US" dirty="0">
+                <a:solidFill>
+                  <a:schemeClr val="bg1"/>
+                </a:solidFill>
+              </a:rPr>
+              <a:t>- </a:t>
+            </a:r>
+            <a:r>
+              <a:rPr lang="en-US" dirty="0" err="1">
+                <a:solidFill>
+                  <a:schemeClr val="bg1"/>
+                </a:solidFill>
+              </a:rPr>
+              <a:t>achsen</a:t>
+            </a:r>
+            <a:r>
+              <a:rPr lang="en-US" dirty="0">
+                <a:solidFill>
+                  <a:schemeClr val="bg1"/>
+                </a:solidFill>
+              </a:rPr>
+              <a:t> </a:t>
+            </a:r>
+            <a:r>
+              <a:rPr lang="en-US" dirty="0" err="1">
+                <a:solidFill>
+                  <a:schemeClr val="bg1"/>
+                </a:solidFill>
+              </a:rPr>
+              <a:t>zum</a:t>
+            </a:r>
+            <a:r>
+              <a:rPr lang="en-US" dirty="0">
+                <a:solidFill>
+                  <a:schemeClr val="bg1"/>
+                </a:solidFill>
+              </a:rPr>
+              <a:t> </a:t>
+            </a:r>
+            <a:r>
+              <a:rPr lang="en-US" dirty="0" err="1">
+                <a:solidFill>
+                  <a:schemeClr val="bg1"/>
+                </a:solidFill>
+              </a:rPr>
+              <a:t>Ablesen</a:t>
+            </a:r>
+            <a:r>
+              <a:rPr lang="en-US" dirty="0">
+                <a:solidFill>
+                  <a:schemeClr val="bg1"/>
+                </a:solidFill>
+              </a:rPr>
+              <a:t> der </a:t>
+            </a:r>
+            <a:r>
+              <a:rPr lang="en-US" dirty="0" err="1">
+                <a:solidFill>
+                  <a:schemeClr val="bg1"/>
+                </a:solidFill>
+              </a:rPr>
+              <a:t>Werte</a:t>
+            </a:r>
+            <a:endParaRPr lang="en-CH" dirty="0">
+              <a:solidFill>
+                <a:schemeClr val="bg1"/>
+              </a:solidFill>
+            </a:endParaRPr>
+          </a:p>
+        </p:txBody>
+      </p:sp>
     </p:spTree>
     <p:extLst>
       <p:ext uri="{BB962C8B-B14F-4D97-AF65-F5344CB8AC3E}">
@@ -7167,6 +7514,415 @@
           </a:xfrm>
         </p:spPr>
       </p:pic>
+      <p:sp>
+        <p:nvSpPr>
+          <p:cNvPr id="3" name="TextBox 2">
+            <a:extLst>
+              <a:ext uri="{FF2B5EF4-FFF2-40B4-BE49-F238E27FC236}">
+                <a16:creationId xmlns:a16="http://schemas.microsoft.com/office/drawing/2014/main" id="{538B05DF-B9E2-7032-6C64-AF015E305838}"/>
+              </a:ext>
+            </a:extLst>
+          </p:cNvPr>
+          <p:cNvSpPr txBox="1"/>
+          <p:nvPr/>
+        </p:nvSpPr>
+        <p:spPr>
+          <a:xfrm>
+            <a:off x="8547652" y="153348"/>
+            <a:ext cx="3475855" cy="923330"/>
+          </a:xfrm>
+          <a:prstGeom prst="rect">
+            <a:avLst/>
+          </a:prstGeom>
+          <a:noFill/>
+        </p:spPr>
+        <p:txBody>
+          <a:bodyPr wrap="square" rtlCol="0">
+            <a:spAutoFit/>
+          </a:bodyPr>
+          <a:lstStyle/>
+          <a:p>
+            <a:r>
+              <a:rPr lang="en-US" dirty="0">
+                <a:solidFill>
+                  <a:schemeClr val="bg1"/>
+                </a:solidFill>
+              </a:rPr>
+              <a:t>Ein </a:t>
+            </a:r>
+            <a:r>
+              <a:rPr lang="en-US" dirty="0" err="1">
+                <a:solidFill>
+                  <a:schemeClr val="bg1"/>
+                </a:solidFill>
+              </a:rPr>
+              <a:t>Ereignis</a:t>
+            </a:r>
+            <a:r>
+              <a:rPr lang="en-US" dirty="0">
+                <a:solidFill>
+                  <a:schemeClr val="bg1"/>
+                </a:solidFill>
+              </a:rPr>
+              <a:t> </a:t>
+            </a:r>
+            <a:r>
+              <a:rPr lang="en-US" dirty="0" err="1">
+                <a:solidFill>
+                  <a:schemeClr val="bg1"/>
+                </a:solidFill>
+              </a:rPr>
+              <a:t>mit</a:t>
+            </a:r>
+            <a:r>
+              <a:rPr lang="en-US" dirty="0">
+                <a:solidFill>
+                  <a:schemeClr val="bg1"/>
+                </a:solidFill>
+              </a:rPr>
+              <a:t> Ort und </a:t>
+            </a:r>
+            <a:r>
+              <a:rPr lang="en-US" dirty="0" err="1">
+                <a:solidFill>
+                  <a:schemeClr val="bg1"/>
+                </a:solidFill>
+              </a:rPr>
+              <a:t>Zeitpunkt</a:t>
+            </a:r>
+            <a:endParaRPr lang="en-US" dirty="0">
+              <a:solidFill>
+                <a:schemeClr val="bg1"/>
+              </a:solidFill>
+            </a:endParaRPr>
+          </a:p>
+          <a:p>
+            <a:r>
+              <a:rPr lang="en-US" dirty="0">
+                <a:solidFill>
+                  <a:schemeClr val="bg1"/>
+                </a:solidFill>
+              </a:rPr>
+              <a:t>z 	= 1</a:t>
+            </a:r>
+          </a:p>
+          <a:p>
+            <a:r>
+              <a:rPr lang="en-US" dirty="0" err="1">
+                <a:solidFill>
+                  <a:schemeClr val="bg1"/>
+                </a:solidFill>
+              </a:rPr>
+              <a:t>ct</a:t>
+            </a:r>
+            <a:r>
+              <a:rPr lang="en-US" dirty="0">
+                <a:solidFill>
+                  <a:schemeClr val="bg1"/>
+                </a:solidFill>
+              </a:rPr>
+              <a:t>	= 2</a:t>
+            </a:r>
+            <a:endParaRPr lang="en-CH" dirty="0">
+              <a:solidFill>
+                <a:schemeClr val="bg1"/>
+              </a:solidFill>
+            </a:endParaRPr>
+          </a:p>
+        </p:txBody>
+      </p:sp>
+      <p:sp>
+        <p:nvSpPr>
+          <p:cNvPr id="5" name="TextBox 4">
+            <a:extLst>
+              <a:ext uri="{FF2B5EF4-FFF2-40B4-BE49-F238E27FC236}">
+                <a16:creationId xmlns:a16="http://schemas.microsoft.com/office/drawing/2014/main" id="{2E0203C9-3BCB-351B-5F39-37B652961F47}"/>
+              </a:ext>
+            </a:extLst>
+          </p:cNvPr>
+          <p:cNvSpPr txBox="1"/>
+          <p:nvPr/>
+        </p:nvSpPr>
+        <p:spPr>
+          <a:xfrm>
+            <a:off x="8547652" y="153348"/>
+            <a:ext cx="3475855" cy="2585323"/>
+          </a:xfrm>
+          <a:prstGeom prst="rect">
+            <a:avLst/>
+          </a:prstGeom>
+          <a:noFill/>
+        </p:spPr>
+        <p:txBody>
+          <a:bodyPr wrap="square" rtlCol="0">
+            <a:spAutoFit/>
+          </a:bodyPr>
+          <a:lstStyle/>
+          <a:p>
+            <a:r>
+              <a:rPr lang="en-US" dirty="0">
+                <a:solidFill>
+                  <a:schemeClr val="bg1"/>
+                </a:solidFill>
+              </a:rPr>
+              <a:t>Ein </a:t>
+            </a:r>
+            <a:r>
+              <a:rPr lang="en-US" dirty="0" err="1">
+                <a:solidFill>
+                  <a:schemeClr val="bg1"/>
+                </a:solidFill>
+              </a:rPr>
+              <a:t>Ereignis</a:t>
+            </a:r>
+            <a:r>
+              <a:rPr lang="en-US" dirty="0">
+                <a:solidFill>
+                  <a:schemeClr val="bg1"/>
+                </a:solidFill>
+              </a:rPr>
+              <a:t> </a:t>
+            </a:r>
+            <a:r>
+              <a:rPr lang="en-US" dirty="0" err="1">
+                <a:solidFill>
+                  <a:schemeClr val="bg1"/>
+                </a:solidFill>
+              </a:rPr>
+              <a:t>mit</a:t>
+            </a:r>
+            <a:r>
+              <a:rPr lang="en-US" dirty="0">
+                <a:solidFill>
+                  <a:schemeClr val="bg1"/>
+                </a:solidFill>
+              </a:rPr>
+              <a:t> Ort und </a:t>
+            </a:r>
+            <a:r>
+              <a:rPr lang="en-US" dirty="0" err="1">
+                <a:solidFill>
+                  <a:schemeClr val="bg1"/>
+                </a:solidFill>
+              </a:rPr>
+              <a:t>Zeitpunkt</a:t>
+            </a:r>
+            <a:endParaRPr lang="en-US" dirty="0">
+              <a:solidFill>
+                <a:schemeClr val="bg1"/>
+              </a:solidFill>
+            </a:endParaRPr>
+          </a:p>
+          <a:p>
+            <a:r>
+              <a:rPr lang="en-US" dirty="0">
+                <a:solidFill>
+                  <a:schemeClr val="bg1"/>
+                </a:solidFill>
+              </a:rPr>
+              <a:t>z 	= 1</a:t>
+            </a:r>
+          </a:p>
+          <a:p>
+            <a:r>
+              <a:rPr lang="en-US" dirty="0" err="1">
+                <a:solidFill>
+                  <a:schemeClr val="bg1"/>
+                </a:solidFill>
+              </a:rPr>
+              <a:t>ct</a:t>
+            </a:r>
+            <a:r>
+              <a:rPr lang="en-US" dirty="0">
+                <a:solidFill>
+                  <a:schemeClr val="bg1"/>
+                </a:solidFill>
+              </a:rPr>
+              <a:t>	= 2</a:t>
+            </a:r>
+          </a:p>
+          <a:p>
+            <a:endParaRPr lang="en-US" dirty="0">
+              <a:solidFill>
+                <a:schemeClr val="bg1"/>
+              </a:solidFill>
+            </a:endParaRPr>
+          </a:p>
+          <a:p>
+            <a:r>
+              <a:rPr lang="en-US" dirty="0" err="1">
+                <a:solidFill>
+                  <a:schemeClr val="bg1"/>
+                </a:solidFill>
+              </a:rPr>
+              <a:t>Verbindung</a:t>
+            </a:r>
+            <a:r>
+              <a:rPr lang="en-US" dirty="0">
+                <a:solidFill>
+                  <a:schemeClr val="bg1"/>
+                </a:solidFill>
+              </a:rPr>
+              <a:t> </a:t>
+            </a:r>
+            <a:r>
+              <a:rPr lang="en-US" dirty="0" err="1">
+                <a:solidFill>
+                  <a:schemeClr val="bg1"/>
+                </a:solidFill>
+              </a:rPr>
+              <a:t>zu</a:t>
+            </a:r>
+            <a:r>
+              <a:rPr lang="en-US" dirty="0">
+                <a:solidFill>
+                  <a:schemeClr val="bg1"/>
+                </a:solidFill>
+              </a:rPr>
+              <a:t> den </a:t>
+            </a:r>
+            <a:r>
+              <a:rPr lang="en-US" dirty="0" err="1">
+                <a:solidFill>
+                  <a:schemeClr val="bg1"/>
+                </a:solidFill>
+              </a:rPr>
+              <a:t>Koordinaten</a:t>
+            </a:r>
+            <a:r>
+              <a:rPr lang="en-US" dirty="0">
+                <a:solidFill>
+                  <a:schemeClr val="bg1"/>
+                </a:solidFill>
+              </a:rPr>
+              <a:t>- </a:t>
+            </a:r>
+            <a:r>
+              <a:rPr lang="en-US" dirty="0" err="1">
+                <a:solidFill>
+                  <a:schemeClr val="bg1"/>
+                </a:solidFill>
+              </a:rPr>
+              <a:t>achsen</a:t>
+            </a:r>
+            <a:r>
+              <a:rPr lang="en-US" dirty="0">
+                <a:solidFill>
+                  <a:schemeClr val="bg1"/>
+                </a:solidFill>
+              </a:rPr>
+              <a:t> </a:t>
+            </a:r>
+            <a:r>
+              <a:rPr lang="en-US" dirty="0" err="1">
+                <a:solidFill>
+                  <a:schemeClr val="bg1"/>
+                </a:solidFill>
+              </a:rPr>
+              <a:t>zum</a:t>
+            </a:r>
+            <a:r>
+              <a:rPr lang="en-US" dirty="0">
+                <a:solidFill>
+                  <a:schemeClr val="bg1"/>
+                </a:solidFill>
+              </a:rPr>
+              <a:t> </a:t>
+            </a:r>
+            <a:r>
+              <a:rPr lang="en-US" dirty="0" err="1">
+                <a:solidFill>
+                  <a:schemeClr val="bg1"/>
+                </a:solidFill>
+              </a:rPr>
+              <a:t>Ablesen</a:t>
+            </a:r>
+            <a:r>
+              <a:rPr lang="en-US" dirty="0">
+                <a:solidFill>
+                  <a:schemeClr val="bg1"/>
+                </a:solidFill>
+              </a:rPr>
+              <a:t> der </a:t>
+            </a:r>
+            <a:r>
+              <a:rPr lang="en-US" dirty="0" err="1">
+                <a:solidFill>
+                  <a:schemeClr val="bg1"/>
+                </a:solidFill>
+              </a:rPr>
+              <a:t>Werte</a:t>
+            </a:r>
+            <a:endParaRPr lang="en-US" dirty="0">
+              <a:solidFill>
+                <a:schemeClr val="bg1"/>
+              </a:solidFill>
+            </a:endParaRPr>
+          </a:p>
+          <a:p>
+            <a:endParaRPr lang="en-US" dirty="0">
+              <a:solidFill>
+                <a:schemeClr val="bg1"/>
+              </a:solidFill>
+            </a:endParaRPr>
+          </a:p>
+          <a:p>
+            <a:r>
+              <a:rPr lang="en-US" dirty="0" err="1">
+                <a:solidFill>
+                  <a:schemeClr val="bg1"/>
+                </a:solidFill>
+              </a:rPr>
+              <a:t>Messung</a:t>
+            </a:r>
+            <a:r>
+              <a:rPr lang="en-US" dirty="0">
+                <a:solidFill>
+                  <a:schemeClr val="bg1"/>
+                </a:solidFill>
+              </a:rPr>
+              <a:t> der </a:t>
+            </a:r>
+            <a:r>
+              <a:rPr lang="en-US" dirty="0" err="1">
+                <a:solidFill>
+                  <a:schemeClr val="bg1"/>
+                </a:solidFill>
+              </a:rPr>
+              <a:t>Entfernung</a:t>
+            </a:r>
+            <a:r>
+              <a:rPr lang="en-US" dirty="0">
+                <a:solidFill>
+                  <a:schemeClr val="bg1"/>
+                </a:solidFill>
+              </a:rPr>
+              <a:t> </a:t>
+            </a:r>
+            <a:r>
+              <a:rPr lang="en-US" dirty="0" err="1">
+                <a:solidFill>
+                  <a:schemeClr val="bg1"/>
+                </a:solidFill>
+              </a:rPr>
+              <a:t>zum</a:t>
+            </a:r>
+            <a:r>
+              <a:rPr lang="en-US" dirty="0">
+                <a:solidFill>
+                  <a:schemeClr val="bg1"/>
+                </a:solidFill>
+              </a:rPr>
+              <a:t> Ursprung</a:t>
+            </a:r>
+            <a:endParaRPr lang="en-CH" dirty="0">
+              <a:solidFill>
+                <a:schemeClr val="bg1"/>
+              </a:solidFill>
+            </a:endParaRPr>
+          </a:p>
+        </p:txBody>
+      </p:sp>
     </p:spTree>
     <p:extLst>
       <p:ext uri="{BB962C8B-B14F-4D97-AF65-F5344CB8AC3E}">
@@ -7188,7 +7944,7 @@
         <p:cNvPr id="1" name="">
           <a:extLst>
             <a:ext uri="{FF2B5EF4-FFF2-40B4-BE49-F238E27FC236}">
-              <a16:creationId xmlns:a16="http://schemas.microsoft.com/office/drawing/2014/main" id="{78433A00-2C99-2075-FCE1-683B869DA7A7}"/>
+              <a16:creationId xmlns:a16="http://schemas.microsoft.com/office/drawing/2014/main" id="{509DD356-1BF7-6339-338C-0A37424EF992}"/>
             </a:ext>
           </a:extLst>
         </p:cNvPr>
@@ -7208,7 +7964,7 @@
           <p:cNvPr id="4" name="Content Placeholder 3">
             <a:extLst>
               <a:ext uri="{FF2B5EF4-FFF2-40B4-BE49-F238E27FC236}">
-                <a16:creationId xmlns:a16="http://schemas.microsoft.com/office/drawing/2014/main" id="{54F5FABB-B0FA-DCB2-041A-419C82B20932}"/>
+                <a16:creationId xmlns:a16="http://schemas.microsoft.com/office/drawing/2014/main" id="{B5E22809-61F3-49DF-63AD-BA3E474190E9}"/>
               </a:ext>
             </a:extLst>
           </p:cNvPr>
@@ -7233,10 +7989,1470 @@
           </a:xfrm>
         </p:spPr>
       </p:pic>
+      <p:sp>
+        <p:nvSpPr>
+          <p:cNvPr id="3" name="TextBox 2">
+            <a:extLst>
+              <a:ext uri="{FF2B5EF4-FFF2-40B4-BE49-F238E27FC236}">
+                <a16:creationId xmlns:a16="http://schemas.microsoft.com/office/drawing/2014/main" id="{DA64A5E4-3E56-FFEF-4FEF-09E10D0C516D}"/>
+              </a:ext>
+            </a:extLst>
+          </p:cNvPr>
+          <p:cNvSpPr txBox="1"/>
+          <p:nvPr/>
+        </p:nvSpPr>
+        <p:spPr>
+          <a:xfrm>
+            <a:off x="8547652" y="153348"/>
+            <a:ext cx="3475855" cy="923330"/>
+          </a:xfrm>
+          <a:prstGeom prst="rect">
+            <a:avLst/>
+          </a:prstGeom>
+          <a:noFill/>
+        </p:spPr>
+        <p:txBody>
+          <a:bodyPr wrap="square" rtlCol="0">
+            <a:spAutoFit/>
+          </a:bodyPr>
+          <a:lstStyle/>
+          <a:p>
+            <a:r>
+              <a:rPr lang="en-US" dirty="0">
+                <a:solidFill>
+                  <a:schemeClr val="bg1"/>
+                </a:solidFill>
+              </a:rPr>
+              <a:t>Ein </a:t>
+            </a:r>
+            <a:r>
+              <a:rPr lang="en-US" dirty="0" err="1">
+                <a:solidFill>
+                  <a:schemeClr val="bg1"/>
+                </a:solidFill>
+              </a:rPr>
+              <a:t>Ereignis</a:t>
+            </a:r>
+            <a:r>
+              <a:rPr lang="en-US" dirty="0">
+                <a:solidFill>
+                  <a:schemeClr val="bg1"/>
+                </a:solidFill>
+              </a:rPr>
+              <a:t> </a:t>
+            </a:r>
+            <a:r>
+              <a:rPr lang="en-US" dirty="0" err="1">
+                <a:solidFill>
+                  <a:schemeClr val="bg1"/>
+                </a:solidFill>
+              </a:rPr>
+              <a:t>mit</a:t>
+            </a:r>
+            <a:r>
+              <a:rPr lang="en-US" dirty="0">
+                <a:solidFill>
+                  <a:schemeClr val="bg1"/>
+                </a:solidFill>
+              </a:rPr>
+              <a:t> Ort und </a:t>
+            </a:r>
+            <a:r>
+              <a:rPr lang="en-US" dirty="0" err="1">
+                <a:solidFill>
+                  <a:schemeClr val="bg1"/>
+                </a:solidFill>
+              </a:rPr>
+              <a:t>Zeitpunkt</a:t>
+            </a:r>
+            <a:endParaRPr lang="en-US" dirty="0">
+              <a:solidFill>
+                <a:schemeClr val="bg1"/>
+              </a:solidFill>
+            </a:endParaRPr>
+          </a:p>
+          <a:p>
+            <a:r>
+              <a:rPr lang="en-US" dirty="0">
+                <a:solidFill>
+                  <a:schemeClr val="bg1"/>
+                </a:solidFill>
+              </a:rPr>
+              <a:t>z 	= 1</a:t>
+            </a:r>
+          </a:p>
+          <a:p>
+            <a:r>
+              <a:rPr lang="en-US" dirty="0" err="1">
+                <a:solidFill>
+                  <a:schemeClr val="bg1"/>
+                </a:solidFill>
+              </a:rPr>
+              <a:t>ct</a:t>
+            </a:r>
+            <a:r>
+              <a:rPr lang="en-US" dirty="0">
+                <a:solidFill>
+                  <a:schemeClr val="bg1"/>
+                </a:solidFill>
+              </a:rPr>
+              <a:t>	= 2</a:t>
+            </a:r>
+            <a:endParaRPr lang="en-CH" dirty="0">
+              <a:solidFill>
+                <a:schemeClr val="bg1"/>
+              </a:solidFill>
+            </a:endParaRPr>
+          </a:p>
+        </p:txBody>
+      </p:sp>
+      <p:sp>
+        <p:nvSpPr>
+          <p:cNvPr id="5" name="TextBox 4">
+            <a:extLst>
+              <a:ext uri="{FF2B5EF4-FFF2-40B4-BE49-F238E27FC236}">
+                <a16:creationId xmlns:a16="http://schemas.microsoft.com/office/drawing/2014/main" id="{0DF893C6-E993-9B27-59F6-74AFEB9BA0FD}"/>
+              </a:ext>
+            </a:extLst>
+          </p:cNvPr>
+          <p:cNvSpPr txBox="1"/>
+          <p:nvPr/>
+        </p:nvSpPr>
+        <p:spPr>
+          <a:xfrm>
+            <a:off x="8547652" y="153348"/>
+            <a:ext cx="3475855" cy="2585323"/>
+          </a:xfrm>
+          <a:prstGeom prst="rect">
+            <a:avLst/>
+          </a:prstGeom>
+          <a:noFill/>
+        </p:spPr>
+        <p:txBody>
+          <a:bodyPr wrap="square" rtlCol="0">
+            <a:spAutoFit/>
+          </a:bodyPr>
+          <a:lstStyle/>
+          <a:p>
+            <a:r>
+              <a:rPr lang="en-US" dirty="0">
+                <a:solidFill>
+                  <a:schemeClr val="bg1"/>
+                </a:solidFill>
+              </a:rPr>
+              <a:t>Ein </a:t>
+            </a:r>
+            <a:r>
+              <a:rPr lang="en-US" dirty="0" err="1">
+                <a:solidFill>
+                  <a:schemeClr val="bg1"/>
+                </a:solidFill>
+              </a:rPr>
+              <a:t>Ereignis</a:t>
+            </a:r>
+            <a:r>
+              <a:rPr lang="en-US" dirty="0">
+                <a:solidFill>
+                  <a:schemeClr val="bg1"/>
+                </a:solidFill>
+              </a:rPr>
+              <a:t> </a:t>
+            </a:r>
+            <a:r>
+              <a:rPr lang="en-US" dirty="0" err="1">
+                <a:solidFill>
+                  <a:schemeClr val="bg1"/>
+                </a:solidFill>
+              </a:rPr>
+              <a:t>mit</a:t>
+            </a:r>
+            <a:r>
+              <a:rPr lang="en-US" dirty="0">
+                <a:solidFill>
+                  <a:schemeClr val="bg1"/>
+                </a:solidFill>
+              </a:rPr>
+              <a:t> Ort und </a:t>
+            </a:r>
+            <a:r>
+              <a:rPr lang="en-US" dirty="0" err="1">
+                <a:solidFill>
+                  <a:schemeClr val="bg1"/>
+                </a:solidFill>
+              </a:rPr>
+              <a:t>Zeitpunkt</a:t>
+            </a:r>
+            <a:r>
+              <a:rPr lang="en-US" dirty="0">
+                <a:solidFill>
+                  <a:schemeClr val="bg1"/>
+                </a:solidFill>
+              </a:rPr>
+              <a:t>:</a:t>
+            </a:r>
+          </a:p>
+          <a:p>
+            <a:r>
+              <a:rPr lang="en-US" dirty="0">
+                <a:solidFill>
+                  <a:schemeClr val="bg1"/>
+                </a:solidFill>
+              </a:rPr>
+              <a:t>z 	= 1</a:t>
+            </a:r>
+          </a:p>
+          <a:p>
+            <a:r>
+              <a:rPr lang="en-US" dirty="0" err="1">
+                <a:solidFill>
+                  <a:schemeClr val="bg1"/>
+                </a:solidFill>
+              </a:rPr>
+              <a:t>ct</a:t>
+            </a:r>
+            <a:r>
+              <a:rPr lang="en-US" dirty="0">
+                <a:solidFill>
+                  <a:schemeClr val="bg1"/>
+                </a:solidFill>
+              </a:rPr>
+              <a:t>	= 2</a:t>
+            </a:r>
+          </a:p>
+          <a:p>
+            <a:endParaRPr lang="en-US" dirty="0">
+              <a:solidFill>
+                <a:schemeClr val="bg1"/>
+              </a:solidFill>
+            </a:endParaRPr>
+          </a:p>
+          <a:p>
+            <a:r>
+              <a:rPr lang="en-US" dirty="0">
+                <a:solidFill>
+                  <a:schemeClr val="bg1"/>
+                </a:solidFill>
+              </a:rPr>
+              <a:t>Ein </a:t>
+            </a:r>
+            <a:r>
+              <a:rPr lang="en-US" dirty="0" err="1">
+                <a:solidFill>
+                  <a:schemeClr val="bg1"/>
+                </a:solidFill>
+              </a:rPr>
+              <a:t>zeites</a:t>
+            </a:r>
+            <a:r>
+              <a:rPr lang="en-US" dirty="0">
+                <a:solidFill>
+                  <a:schemeClr val="bg1"/>
+                </a:solidFill>
+              </a:rPr>
+              <a:t> </a:t>
+            </a:r>
+            <a:r>
+              <a:rPr lang="en-US" dirty="0" err="1">
+                <a:solidFill>
+                  <a:schemeClr val="bg1"/>
+                </a:solidFill>
+              </a:rPr>
+              <a:t>Ereignis</a:t>
+            </a:r>
+            <a:r>
+              <a:rPr lang="en-US" dirty="0">
+                <a:solidFill>
+                  <a:schemeClr val="bg1"/>
+                </a:solidFill>
+              </a:rPr>
+              <a:t> </a:t>
+            </a:r>
+            <a:r>
+              <a:rPr lang="en-US" dirty="0" err="1">
+                <a:solidFill>
+                  <a:schemeClr val="bg1"/>
+                </a:solidFill>
+              </a:rPr>
+              <a:t>mit</a:t>
+            </a:r>
+            <a:r>
+              <a:rPr lang="en-US" dirty="0">
+                <a:solidFill>
+                  <a:schemeClr val="bg1"/>
+                </a:solidFill>
+              </a:rPr>
+              <a:t> Ort und </a:t>
+            </a:r>
+            <a:r>
+              <a:rPr lang="en-US" dirty="0" err="1">
+                <a:solidFill>
+                  <a:schemeClr val="bg1"/>
+                </a:solidFill>
+              </a:rPr>
+              <a:t>Zeitpunkt</a:t>
+            </a:r>
+            <a:r>
+              <a:rPr lang="en-US" dirty="0">
+                <a:solidFill>
+                  <a:schemeClr val="bg1"/>
+                </a:solidFill>
+              </a:rPr>
+              <a:t>:</a:t>
+            </a:r>
+          </a:p>
+          <a:p>
+            <a:r>
+              <a:rPr lang="en-US" dirty="0">
+                <a:solidFill>
+                  <a:schemeClr val="bg1"/>
+                </a:solidFill>
+              </a:rPr>
+              <a:t>z 	= 3</a:t>
+            </a:r>
+          </a:p>
+          <a:p>
+            <a:r>
+              <a:rPr lang="en-US" dirty="0" err="1">
+                <a:solidFill>
+                  <a:schemeClr val="bg1"/>
+                </a:solidFill>
+              </a:rPr>
+              <a:t>ct</a:t>
+            </a:r>
+            <a:r>
+              <a:rPr lang="en-US" dirty="0">
+                <a:solidFill>
+                  <a:schemeClr val="bg1"/>
+                </a:solidFill>
+              </a:rPr>
+              <a:t>	= 1</a:t>
+            </a:r>
+          </a:p>
+          <a:p>
+            <a:endParaRPr lang="en-CH" dirty="0">
+              <a:solidFill>
+                <a:schemeClr val="bg1"/>
+              </a:solidFill>
+            </a:endParaRPr>
+          </a:p>
+        </p:txBody>
+      </p:sp>
     </p:spTree>
     <p:extLst>
       <p:ext uri="{BB962C8B-B14F-4D97-AF65-F5344CB8AC3E}">
-        <p14:creationId xmlns:p14="http://schemas.microsoft.com/office/powerpoint/2010/main" val="4206889277"/>
+        <p14:creationId xmlns:p14="http://schemas.microsoft.com/office/powerpoint/2010/main" val="3363626777"/>
+      </p:ext>
+    </p:extLst>
+  </p:cSld>
+  <p:clrMapOvr>
+    <a:masterClrMapping/>
+  </p:clrMapOvr>
+</p:sld>
+</file>
+
+<file path=ppt/slides/slide8.xml><?xml version="1.0" encoding="utf-8"?>
+<p:sld xmlns:a="http://schemas.openxmlformats.org/drawingml/2006/main" xmlns:r="http://schemas.openxmlformats.org/officeDocument/2006/relationships" xmlns:p="http://schemas.openxmlformats.org/presentationml/2006/main">
+  <p:cSld>
+    <p:spTree>
+      <p:nvGrpSpPr>
+        <p:cNvPr id="1" name="">
+          <a:extLst>
+            <a:ext uri="{FF2B5EF4-FFF2-40B4-BE49-F238E27FC236}">
+              <a16:creationId xmlns:a16="http://schemas.microsoft.com/office/drawing/2014/main" id="{064B5F2A-4598-BB3E-F832-5E1EF149002B}"/>
+            </a:ext>
+          </a:extLst>
+        </p:cNvPr>
+        <p:cNvGrpSpPr/>
+        <p:nvPr/>
+      </p:nvGrpSpPr>
+      <p:grpSpPr>
+        <a:xfrm>
+          <a:off x="0" y="0"/>
+          <a:ext cx="0" cy="0"/>
+          <a:chOff x="0" y="0"/>
+          <a:chExt cx="0" cy="0"/>
+        </a:xfrm>
+      </p:grpSpPr>
+      <p:pic>
+        <p:nvPicPr>
+          <p:cNvPr id="4" name="Content Placeholder 3">
+            <a:extLst>
+              <a:ext uri="{FF2B5EF4-FFF2-40B4-BE49-F238E27FC236}">
+                <a16:creationId xmlns:a16="http://schemas.microsoft.com/office/drawing/2014/main" id="{03C497DA-A97E-1FB4-1C1A-E966587F5C28}"/>
+              </a:ext>
+            </a:extLst>
+          </p:cNvPr>
+          <p:cNvPicPr>
+            <a:picLocks noGrp="1" noChangeAspect="1"/>
+          </p:cNvPicPr>
+          <p:nvPr>
+            <p:ph idx="1"/>
+          </p:nvPr>
+        </p:nvPicPr>
+        <p:blipFill>
+          <a:blip r:link="rId2"/>
+          <a:srcRect/>
+          <a:stretch>
+            <a:fillRect/>
+          </a:stretch>
+        </p:blipFill>
+        <p:spPr>
+          <a:xfrm>
+            <a:off x="439948" y="-422692"/>
+            <a:ext cx="7556740" cy="7556740"/>
+          </a:xfrm>
+        </p:spPr>
+      </p:pic>
+      <p:sp>
+        <p:nvSpPr>
+          <p:cNvPr id="3" name="TextBox 2">
+            <a:extLst>
+              <a:ext uri="{FF2B5EF4-FFF2-40B4-BE49-F238E27FC236}">
+                <a16:creationId xmlns:a16="http://schemas.microsoft.com/office/drawing/2014/main" id="{60BBDFDF-8EA0-E515-BA06-79879A661101}"/>
+              </a:ext>
+            </a:extLst>
+          </p:cNvPr>
+          <p:cNvSpPr txBox="1"/>
+          <p:nvPr/>
+        </p:nvSpPr>
+        <p:spPr>
+          <a:xfrm>
+            <a:off x="8547652" y="153348"/>
+            <a:ext cx="3475855" cy="923330"/>
+          </a:xfrm>
+          <a:prstGeom prst="rect">
+            <a:avLst/>
+          </a:prstGeom>
+          <a:noFill/>
+        </p:spPr>
+        <p:txBody>
+          <a:bodyPr wrap="square" rtlCol="0">
+            <a:spAutoFit/>
+          </a:bodyPr>
+          <a:lstStyle/>
+          <a:p>
+            <a:r>
+              <a:rPr lang="en-US" dirty="0">
+                <a:solidFill>
+                  <a:schemeClr val="bg1"/>
+                </a:solidFill>
+              </a:rPr>
+              <a:t>Ein </a:t>
+            </a:r>
+            <a:r>
+              <a:rPr lang="en-US" dirty="0" err="1">
+                <a:solidFill>
+                  <a:schemeClr val="bg1"/>
+                </a:solidFill>
+              </a:rPr>
+              <a:t>Ereignis</a:t>
+            </a:r>
+            <a:r>
+              <a:rPr lang="en-US" dirty="0">
+                <a:solidFill>
+                  <a:schemeClr val="bg1"/>
+                </a:solidFill>
+              </a:rPr>
+              <a:t> </a:t>
+            </a:r>
+            <a:r>
+              <a:rPr lang="en-US" dirty="0" err="1">
+                <a:solidFill>
+                  <a:schemeClr val="bg1"/>
+                </a:solidFill>
+              </a:rPr>
+              <a:t>mit</a:t>
+            </a:r>
+            <a:r>
+              <a:rPr lang="en-US" dirty="0">
+                <a:solidFill>
+                  <a:schemeClr val="bg1"/>
+                </a:solidFill>
+              </a:rPr>
+              <a:t> Ort und </a:t>
+            </a:r>
+            <a:r>
+              <a:rPr lang="en-US" dirty="0" err="1">
+                <a:solidFill>
+                  <a:schemeClr val="bg1"/>
+                </a:solidFill>
+              </a:rPr>
+              <a:t>Zeitpunkt</a:t>
+            </a:r>
+            <a:endParaRPr lang="en-US" dirty="0">
+              <a:solidFill>
+                <a:schemeClr val="bg1"/>
+              </a:solidFill>
+            </a:endParaRPr>
+          </a:p>
+          <a:p>
+            <a:r>
+              <a:rPr lang="en-US" dirty="0">
+                <a:solidFill>
+                  <a:schemeClr val="bg1"/>
+                </a:solidFill>
+              </a:rPr>
+              <a:t>z 	= 1</a:t>
+            </a:r>
+          </a:p>
+          <a:p>
+            <a:r>
+              <a:rPr lang="en-US" dirty="0" err="1">
+                <a:solidFill>
+                  <a:schemeClr val="bg1"/>
+                </a:solidFill>
+              </a:rPr>
+              <a:t>ct</a:t>
+            </a:r>
+            <a:r>
+              <a:rPr lang="en-US" dirty="0">
+                <a:solidFill>
+                  <a:schemeClr val="bg1"/>
+                </a:solidFill>
+              </a:rPr>
+              <a:t>	= 2</a:t>
+            </a:r>
+            <a:endParaRPr lang="en-CH" dirty="0">
+              <a:solidFill>
+                <a:schemeClr val="bg1"/>
+              </a:solidFill>
+            </a:endParaRPr>
+          </a:p>
+        </p:txBody>
+      </p:sp>
+      <p:sp>
+        <p:nvSpPr>
+          <p:cNvPr id="5" name="TextBox 4">
+            <a:extLst>
+              <a:ext uri="{FF2B5EF4-FFF2-40B4-BE49-F238E27FC236}">
+                <a16:creationId xmlns:a16="http://schemas.microsoft.com/office/drawing/2014/main" id="{91696F9E-BD1F-EEF1-24B0-D42DA7A29D7A}"/>
+              </a:ext>
+            </a:extLst>
+          </p:cNvPr>
+          <p:cNvSpPr txBox="1"/>
+          <p:nvPr/>
+        </p:nvSpPr>
+        <p:spPr>
+          <a:xfrm>
+            <a:off x="8547652" y="153348"/>
+            <a:ext cx="3475855" cy="3139321"/>
+          </a:xfrm>
+          <a:prstGeom prst="rect">
+            <a:avLst/>
+          </a:prstGeom>
+          <a:noFill/>
+        </p:spPr>
+        <p:txBody>
+          <a:bodyPr wrap="square" rtlCol="0">
+            <a:spAutoFit/>
+          </a:bodyPr>
+          <a:lstStyle/>
+          <a:p>
+            <a:r>
+              <a:rPr lang="en-US" dirty="0">
+                <a:solidFill>
+                  <a:schemeClr val="bg1"/>
+                </a:solidFill>
+              </a:rPr>
+              <a:t>Ein </a:t>
+            </a:r>
+            <a:r>
+              <a:rPr lang="en-US" dirty="0" err="1">
+                <a:solidFill>
+                  <a:schemeClr val="bg1"/>
+                </a:solidFill>
+              </a:rPr>
+              <a:t>Ereignis</a:t>
+            </a:r>
+            <a:r>
+              <a:rPr lang="en-US" dirty="0">
+                <a:solidFill>
+                  <a:schemeClr val="bg1"/>
+                </a:solidFill>
+              </a:rPr>
+              <a:t> </a:t>
+            </a:r>
+            <a:r>
+              <a:rPr lang="en-US" dirty="0" err="1">
+                <a:solidFill>
+                  <a:schemeClr val="bg1"/>
+                </a:solidFill>
+              </a:rPr>
+              <a:t>mit</a:t>
+            </a:r>
+            <a:r>
+              <a:rPr lang="en-US" dirty="0">
+                <a:solidFill>
+                  <a:schemeClr val="bg1"/>
+                </a:solidFill>
+              </a:rPr>
+              <a:t> Ort und </a:t>
+            </a:r>
+            <a:r>
+              <a:rPr lang="en-US" dirty="0" err="1">
+                <a:solidFill>
+                  <a:schemeClr val="bg1"/>
+                </a:solidFill>
+              </a:rPr>
+              <a:t>Zeitpunkt</a:t>
+            </a:r>
+            <a:r>
+              <a:rPr lang="en-US" dirty="0">
+                <a:solidFill>
+                  <a:schemeClr val="bg1"/>
+                </a:solidFill>
+              </a:rPr>
+              <a:t>:</a:t>
+            </a:r>
+          </a:p>
+          <a:p>
+            <a:r>
+              <a:rPr lang="en-US" dirty="0">
+                <a:solidFill>
+                  <a:schemeClr val="bg1"/>
+                </a:solidFill>
+              </a:rPr>
+              <a:t>z 	= 1</a:t>
+            </a:r>
+          </a:p>
+          <a:p>
+            <a:r>
+              <a:rPr lang="en-US" dirty="0" err="1">
+                <a:solidFill>
+                  <a:schemeClr val="bg1"/>
+                </a:solidFill>
+              </a:rPr>
+              <a:t>ct</a:t>
+            </a:r>
+            <a:r>
+              <a:rPr lang="en-US" dirty="0">
+                <a:solidFill>
+                  <a:schemeClr val="bg1"/>
+                </a:solidFill>
+              </a:rPr>
+              <a:t>	= 2</a:t>
+            </a:r>
+          </a:p>
+          <a:p>
+            <a:endParaRPr lang="en-US" dirty="0">
+              <a:solidFill>
+                <a:schemeClr val="bg1"/>
+              </a:solidFill>
+            </a:endParaRPr>
+          </a:p>
+          <a:p>
+            <a:r>
+              <a:rPr lang="en-US" dirty="0">
+                <a:solidFill>
+                  <a:schemeClr val="bg1"/>
+                </a:solidFill>
+              </a:rPr>
+              <a:t>Ein </a:t>
+            </a:r>
+            <a:r>
+              <a:rPr lang="en-US" dirty="0" err="1">
+                <a:solidFill>
+                  <a:schemeClr val="bg1"/>
+                </a:solidFill>
+              </a:rPr>
+              <a:t>zeites</a:t>
+            </a:r>
+            <a:r>
+              <a:rPr lang="en-US" dirty="0">
+                <a:solidFill>
+                  <a:schemeClr val="bg1"/>
+                </a:solidFill>
+              </a:rPr>
+              <a:t> </a:t>
+            </a:r>
+            <a:r>
+              <a:rPr lang="en-US" dirty="0" err="1">
+                <a:solidFill>
+                  <a:schemeClr val="bg1"/>
+                </a:solidFill>
+              </a:rPr>
+              <a:t>Ereignis</a:t>
+            </a:r>
+            <a:r>
+              <a:rPr lang="en-US" dirty="0">
+                <a:solidFill>
+                  <a:schemeClr val="bg1"/>
+                </a:solidFill>
+              </a:rPr>
+              <a:t> </a:t>
+            </a:r>
+            <a:r>
+              <a:rPr lang="en-US" dirty="0" err="1">
+                <a:solidFill>
+                  <a:schemeClr val="bg1"/>
+                </a:solidFill>
+              </a:rPr>
+              <a:t>mit</a:t>
+            </a:r>
+            <a:r>
+              <a:rPr lang="en-US" dirty="0">
+                <a:solidFill>
+                  <a:schemeClr val="bg1"/>
+                </a:solidFill>
+              </a:rPr>
+              <a:t> Ort und </a:t>
+            </a:r>
+            <a:r>
+              <a:rPr lang="en-US" dirty="0" err="1">
+                <a:solidFill>
+                  <a:schemeClr val="bg1"/>
+                </a:solidFill>
+              </a:rPr>
+              <a:t>Zeitpunkt</a:t>
+            </a:r>
+            <a:r>
+              <a:rPr lang="en-US" dirty="0">
+                <a:solidFill>
+                  <a:schemeClr val="bg1"/>
+                </a:solidFill>
+              </a:rPr>
+              <a:t>:</a:t>
+            </a:r>
+          </a:p>
+          <a:p>
+            <a:r>
+              <a:rPr lang="en-US" dirty="0">
+                <a:solidFill>
+                  <a:schemeClr val="bg1"/>
+                </a:solidFill>
+              </a:rPr>
+              <a:t>z 	= 3</a:t>
+            </a:r>
+          </a:p>
+          <a:p>
+            <a:r>
+              <a:rPr lang="en-US" dirty="0" err="1">
+                <a:solidFill>
+                  <a:schemeClr val="bg1"/>
+                </a:solidFill>
+              </a:rPr>
+              <a:t>ct</a:t>
+            </a:r>
+            <a:r>
+              <a:rPr lang="en-US" dirty="0">
+                <a:solidFill>
+                  <a:schemeClr val="bg1"/>
+                </a:solidFill>
+              </a:rPr>
+              <a:t>	= 1</a:t>
+            </a:r>
+          </a:p>
+          <a:p>
+            <a:endParaRPr lang="en-US" dirty="0">
+              <a:solidFill>
+                <a:schemeClr val="bg1"/>
+              </a:solidFill>
+            </a:endParaRPr>
+          </a:p>
+          <a:p>
+            <a:r>
+              <a:rPr lang="en-US" dirty="0" err="1">
+                <a:solidFill>
+                  <a:schemeClr val="bg1"/>
+                </a:solidFill>
+              </a:rPr>
+              <a:t>Verbindung</a:t>
+            </a:r>
+            <a:r>
+              <a:rPr lang="en-US" dirty="0">
+                <a:solidFill>
+                  <a:schemeClr val="bg1"/>
+                </a:solidFill>
+              </a:rPr>
+              <a:t> </a:t>
+            </a:r>
+            <a:r>
+              <a:rPr lang="en-US" dirty="0" err="1">
+                <a:solidFill>
+                  <a:schemeClr val="bg1"/>
+                </a:solidFill>
+              </a:rPr>
+              <a:t>zu</a:t>
+            </a:r>
+            <a:r>
+              <a:rPr lang="en-US" dirty="0">
+                <a:solidFill>
+                  <a:schemeClr val="bg1"/>
+                </a:solidFill>
+              </a:rPr>
+              <a:t> den </a:t>
+            </a:r>
+            <a:r>
+              <a:rPr lang="en-US" dirty="0" err="1">
+                <a:solidFill>
+                  <a:schemeClr val="bg1"/>
+                </a:solidFill>
+              </a:rPr>
+              <a:t>Koordinaten</a:t>
+            </a:r>
+            <a:r>
+              <a:rPr lang="en-US" dirty="0">
+                <a:solidFill>
+                  <a:schemeClr val="bg1"/>
+                </a:solidFill>
+              </a:rPr>
+              <a:t>- </a:t>
+            </a:r>
+            <a:r>
+              <a:rPr lang="en-US" dirty="0" err="1">
+                <a:solidFill>
+                  <a:schemeClr val="bg1"/>
+                </a:solidFill>
+              </a:rPr>
+              <a:t>achsen</a:t>
+            </a:r>
+            <a:r>
+              <a:rPr lang="en-US" dirty="0">
+                <a:solidFill>
+                  <a:schemeClr val="bg1"/>
+                </a:solidFill>
+              </a:rPr>
+              <a:t> </a:t>
+            </a:r>
+            <a:r>
+              <a:rPr lang="en-US" dirty="0" err="1">
+                <a:solidFill>
+                  <a:schemeClr val="bg1"/>
+                </a:solidFill>
+              </a:rPr>
+              <a:t>zum</a:t>
+            </a:r>
+            <a:r>
+              <a:rPr lang="en-US" dirty="0">
+                <a:solidFill>
+                  <a:schemeClr val="bg1"/>
+                </a:solidFill>
+              </a:rPr>
+              <a:t> </a:t>
+            </a:r>
+            <a:r>
+              <a:rPr lang="en-US" dirty="0" err="1">
+                <a:solidFill>
+                  <a:schemeClr val="bg1"/>
+                </a:solidFill>
+              </a:rPr>
+              <a:t>Ablesen</a:t>
+            </a:r>
+            <a:r>
+              <a:rPr lang="en-US" dirty="0">
+                <a:solidFill>
+                  <a:schemeClr val="bg1"/>
+                </a:solidFill>
+              </a:rPr>
+              <a:t> der </a:t>
+            </a:r>
+            <a:r>
+              <a:rPr lang="en-US" dirty="0" err="1">
+                <a:solidFill>
+                  <a:schemeClr val="bg1"/>
+                </a:solidFill>
+              </a:rPr>
+              <a:t>Werte</a:t>
+            </a:r>
+            <a:endParaRPr lang="en-CH" dirty="0">
+              <a:solidFill>
+                <a:schemeClr val="bg1"/>
+              </a:solidFill>
+            </a:endParaRPr>
+          </a:p>
+        </p:txBody>
+      </p:sp>
+    </p:spTree>
+    <p:extLst>
+      <p:ext uri="{BB962C8B-B14F-4D97-AF65-F5344CB8AC3E}">
+        <p14:creationId xmlns:p14="http://schemas.microsoft.com/office/powerpoint/2010/main" val="175444165"/>
+      </p:ext>
+    </p:extLst>
+  </p:cSld>
+  <p:clrMapOvr>
+    <a:masterClrMapping/>
+  </p:clrMapOvr>
+</p:sld>
+</file>
+
+<file path=ppt/slides/slide9.xml><?xml version="1.0" encoding="utf-8"?>
+<p:sld xmlns:a="http://schemas.openxmlformats.org/drawingml/2006/main" xmlns:r="http://schemas.openxmlformats.org/officeDocument/2006/relationships" xmlns:p="http://schemas.openxmlformats.org/presentationml/2006/main">
+  <p:cSld>
+    <p:spTree>
+      <p:nvGrpSpPr>
+        <p:cNvPr id="1" name="">
+          <a:extLst>
+            <a:ext uri="{FF2B5EF4-FFF2-40B4-BE49-F238E27FC236}">
+              <a16:creationId xmlns:a16="http://schemas.microsoft.com/office/drawing/2014/main" id="{EC9D5E28-A2BD-0C6C-6D8D-693811EDA565}"/>
+            </a:ext>
+          </a:extLst>
+        </p:cNvPr>
+        <p:cNvGrpSpPr/>
+        <p:nvPr/>
+      </p:nvGrpSpPr>
+      <p:grpSpPr>
+        <a:xfrm>
+          <a:off x="0" y="0"/>
+          <a:ext cx="0" cy="0"/>
+          <a:chOff x="0" y="0"/>
+          <a:chExt cx="0" cy="0"/>
+        </a:xfrm>
+      </p:grpSpPr>
+      <p:pic>
+        <p:nvPicPr>
+          <p:cNvPr id="4" name="Content Placeholder 3">
+            <a:extLst>
+              <a:ext uri="{FF2B5EF4-FFF2-40B4-BE49-F238E27FC236}">
+                <a16:creationId xmlns:a16="http://schemas.microsoft.com/office/drawing/2014/main" id="{00BCF266-429B-A1E0-E8F1-D360C0B9EFF4}"/>
+              </a:ext>
+            </a:extLst>
+          </p:cNvPr>
+          <p:cNvPicPr>
+            <a:picLocks noGrp="1" noChangeAspect="1"/>
+          </p:cNvPicPr>
+          <p:nvPr>
+            <p:ph idx="1"/>
+          </p:nvPr>
+        </p:nvPicPr>
+        <p:blipFill>
+          <a:blip r:link="rId2"/>
+          <a:srcRect/>
+          <a:stretch>
+            <a:fillRect/>
+          </a:stretch>
+        </p:blipFill>
+        <p:spPr>
+          <a:xfrm>
+            <a:off x="439948" y="-422692"/>
+            <a:ext cx="7556740" cy="7556740"/>
+          </a:xfrm>
+        </p:spPr>
+      </p:pic>
+      <p:sp>
+        <p:nvSpPr>
+          <p:cNvPr id="3" name="TextBox 2">
+            <a:extLst>
+              <a:ext uri="{FF2B5EF4-FFF2-40B4-BE49-F238E27FC236}">
+                <a16:creationId xmlns:a16="http://schemas.microsoft.com/office/drawing/2014/main" id="{F0DEF13E-F33D-36AB-DCD8-BD2386B2638E}"/>
+              </a:ext>
+            </a:extLst>
+          </p:cNvPr>
+          <p:cNvSpPr txBox="1"/>
+          <p:nvPr/>
+        </p:nvSpPr>
+        <p:spPr>
+          <a:xfrm>
+            <a:off x="8547652" y="153348"/>
+            <a:ext cx="3475855" cy="923330"/>
+          </a:xfrm>
+          <a:prstGeom prst="rect">
+            <a:avLst/>
+          </a:prstGeom>
+          <a:noFill/>
+        </p:spPr>
+        <p:txBody>
+          <a:bodyPr wrap="square" rtlCol="0">
+            <a:spAutoFit/>
+          </a:bodyPr>
+          <a:lstStyle/>
+          <a:p>
+            <a:r>
+              <a:rPr lang="en-US" dirty="0">
+                <a:solidFill>
+                  <a:schemeClr val="bg1"/>
+                </a:solidFill>
+              </a:rPr>
+              <a:t>Ein </a:t>
+            </a:r>
+            <a:r>
+              <a:rPr lang="en-US" dirty="0" err="1">
+                <a:solidFill>
+                  <a:schemeClr val="bg1"/>
+                </a:solidFill>
+              </a:rPr>
+              <a:t>Ereignis</a:t>
+            </a:r>
+            <a:r>
+              <a:rPr lang="en-US" dirty="0">
+                <a:solidFill>
+                  <a:schemeClr val="bg1"/>
+                </a:solidFill>
+              </a:rPr>
+              <a:t> </a:t>
+            </a:r>
+            <a:r>
+              <a:rPr lang="en-US" dirty="0" err="1">
+                <a:solidFill>
+                  <a:schemeClr val="bg1"/>
+                </a:solidFill>
+              </a:rPr>
+              <a:t>mit</a:t>
+            </a:r>
+            <a:r>
+              <a:rPr lang="en-US" dirty="0">
+                <a:solidFill>
+                  <a:schemeClr val="bg1"/>
+                </a:solidFill>
+              </a:rPr>
+              <a:t> Ort und </a:t>
+            </a:r>
+            <a:r>
+              <a:rPr lang="en-US" dirty="0" err="1">
+                <a:solidFill>
+                  <a:schemeClr val="bg1"/>
+                </a:solidFill>
+              </a:rPr>
+              <a:t>Zeitpunkt</a:t>
+            </a:r>
+            <a:endParaRPr lang="en-US" dirty="0">
+              <a:solidFill>
+                <a:schemeClr val="bg1"/>
+              </a:solidFill>
+            </a:endParaRPr>
+          </a:p>
+          <a:p>
+            <a:r>
+              <a:rPr lang="en-US" dirty="0">
+                <a:solidFill>
+                  <a:schemeClr val="bg1"/>
+                </a:solidFill>
+              </a:rPr>
+              <a:t>z 	= 1</a:t>
+            </a:r>
+          </a:p>
+          <a:p>
+            <a:r>
+              <a:rPr lang="en-US" dirty="0" err="1">
+                <a:solidFill>
+                  <a:schemeClr val="bg1"/>
+                </a:solidFill>
+              </a:rPr>
+              <a:t>ct</a:t>
+            </a:r>
+            <a:r>
+              <a:rPr lang="en-US" dirty="0">
+                <a:solidFill>
+                  <a:schemeClr val="bg1"/>
+                </a:solidFill>
+              </a:rPr>
+              <a:t>	= 2</a:t>
+            </a:r>
+            <a:endParaRPr lang="en-CH" dirty="0">
+              <a:solidFill>
+                <a:schemeClr val="bg1"/>
+              </a:solidFill>
+            </a:endParaRPr>
+          </a:p>
+        </p:txBody>
+      </p:sp>
+      <p:sp>
+        <p:nvSpPr>
+          <p:cNvPr id="5" name="TextBox 4">
+            <a:extLst>
+              <a:ext uri="{FF2B5EF4-FFF2-40B4-BE49-F238E27FC236}">
+                <a16:creationId xmlns:a16="http://schemas.microsoft.com/office/drawing/2014/main" id="{4186A8A3-4DB8-397A-4F80-5F9DEE0504B7}"/>
+              </a:ext>
+            </a:extLst>
+          </p:cNvPr>
+          <p:cNvSpPr txBox="1"/>
+          <p:nvPr/>
+        </p:nvSpPr>
+        <p:spPr>
+          <a:xfrm>
+            <a:off x="8547652" y="153348"/>
+            <a:ext cx="3475855" cy="3970318"/>
+          </a:xfrm>
+          <a:prstGeom prst="rect">
+            <a:avLst/>
+          </a:prstGeom>
+          <a:noFill/>
+        </p:spPr>
+        <p:txBody>
+          <a:bodyPr wrap="square" rtlCol="0">
+            <a:spAutoFit/>
+          </a:bodyPr>
+          <a:lstStyle/>
+          <a:p>
+            <a:r>
+              <a:rPr lang="en-US" dirty="0">
+                <a:solidFill>
+                  <a:schemeClr val="bg1"/>
+                </a:solidFill>
+              </a:rPr>
+              <a:t>Ein </a:t>
+            </a:r>
+            <a:r>
+              <a:rPr lang="en-US" dirty="0" err="1">
+                <a:solidFill>
+                  <a:schemeClr val="bg1"/>
+                </a:solidFill>
+              </a:rPr>
+              <a:t>Ereignis</a:t>
+            </a:r>
+            <a:r>
+              <a:rPr lang="en-US" dirty="0">
+                <a:solidFill>
+                  <a:schemeClr val="bg1"/>
+                </a:solidFill>
+              </a:rPr>
+              <a:t> </a:t>
+            </a:r>
+            <a:r>
+              <a:rPr lang="en-US" dirty="0" err="1">
+                <a:solidFill>
+                  <a:schemeClr val="bg1"/>
+                </a:solidFill>
+              </a:rPr>
+              <a:t>mit</a:t>
+            </a:r>
+            <a:r>
+              <a:rPr lang="en-US" dirty="0">
+                <a:solidFill>
+                  <a:schemeClr val="bg1"/>
+                </a:solidFill>
+              </a:rPr>
+              <a:t> Ort und </a:t>
+            </a:r>
+            <a:r>
+              <a:rPr lang="en-US" dirty="0" err="1">
+                <a:solidFill>
+                  <a:schemeClr val="bg1"/>
+                </a:solidFill>
+              </a:rPr>
+              <a:t>Zeitpunkt</a:t>
+            </a:r>
+            <a:r>
+              <a:rPr lang="en-US" dirty="0">
+                <a:solidFill>
+                  <a:schemeClr val="bg1"/>
+                </a:solidFill>
+              </a:rPr>
+              <a:t>:</a:t>
+            </a:r>
+          </a:p>
+          <a:p>
+            <a:r>
+              <a:rPr lang="en-US" dirty="0">
+                <a:solidFill>
+                  <a:schemeClr val="bg1"/>
+                </a:solidFill>
+              </a:rPr>
+              <a:t>z 	= 1</a:t>
+            </a:r>
+          </a:p>
+          <a:p>
+            <a:r>
+              <a:rPr lang="en-US" dirty="0" err="1">
+                <a:solidFill>
+                  <a:schemeClr val="bg1"/>
+                </a:solidFill>
+              </a:rPr>
+              <a:t>ct</a:t>
+            </a:r>
+            <a:r>
+              <a:rPr lang="en-US" dirty="0">
+                <a:solidFill>
+                  <a:schemeClr val="bg1"/>
+                </a:solidFill>
+              </a:rPr>
+              <a:t>	= 2</a:t>
+            </a:r>
+          </a:p>
+          <a:p>
+            <a:endParaRPr lang="en-US" dirty="0">
+              <a:solidFill>
+                <a:schemeClr val="bg1"/>
+              </a:solidFill>
+            </a:endParaRPr>
+          </a:p>
+          <a:p>
+            <a:r>
+              <a:rPr lang="en-US" dirty="0">
+                <a:solidFill>
+                  <a:schemeClr val="bg1"/>
+                </a:solidFill>
+              </a:rPr>
+              <a:t>Ein </a:t>
+            </a:r>
+            <a:r>
+              <a:rPr lang="en-US" dirty="0" err="1">
+                <a:solidFill>
+                  <a:schemeClr val="bg1"/>
+                </a:solidFill>
+              </a:rPr>
+              <a:t>zeites</a:t>
+            </a:r>
+            <a:r>
+              <a:rPr lang="en-US" dirty="0">
+                <a:solidFill>
+                  <a:schemeClr val="bg1"/>
+                </a:solidFill>
+              </a:rPr>
+              <a:t> </a:t>
+            </a:r>
+            <a:r>
+              <a:rPr lang="en-US" dirty="0" err="1">
+                <a:solidFill>
+                  <a:schemeClr val="bg1"/>
+                </a:solidFill>
+              </a:rPr>
+              <a:t>Ereignis</a:t>
+            </a:r>
+            <a:r>
+              <a:rPr lang="en-US" dirty="0">
+                <a:solidFill>
+                  <a:schemeClr val="bg1"/>
+                </a:solidFill>
+              </a:rPr>
+              <a:t> </a:t>
+            </a:r>
+            <a:r>
+              <a:rPr lang="en-US" dirty="0" err="1">
+                <a:solidFill>
+                  <a:schemeClr val="bg1"/>
+                </a:solidFill>
+              </a:rPr>
+              <a:t>mit</a:t>
+            </a:r>
+            <a:r>
+              <a:rPr lang="en-US" dirty="0">
+                <a:solidFill>
+                  <a:schemeClr val="bg1"/>
+                </a:solidFill>
+              </a:rPr>
+              <a:t> Ort und </a:t>
+            </a:r>
+            <a:r>
+              <a:rPr lang="en-US" dirty="0" err="1">
+                <a:solidFill>
+                  <a:schemeClr val="bg1"/>
+                </a:solidFill>
+              </a:rPr>
+              <a:t>Zeitpunkt</a:t>
+            </a:r>
+            <a:r>
+              <a:rPr lang="en-US" dirty="0">
+                <a:solidFill>
+                  <a:schemeClr val="bg1"/>
+                </a:solidFill>
+              </a:rPr>
+              <a:t>:</a:t>
+            </a:r>
+          </a:p>
+          <a:p>
+            <a:r>
+              <a:rPr lang="en-US" dirty="0">
+                <a:solidFill>
+                  <a:schemeClr val="bg1"/>
+                </a:solidFill>
+              </a:rPr>
+              <a:t>z 	= 3</a:t>
+            </a:r>
+          </a:p>
+          <a:p>
+            <a:r>
+              <a:rPr lang="en-US" dirty="0" err="1">
+                <a:solidFill>
+                  <a:schemeClr val="bg1"/>
+                </a:solidFill>
+              </a:rPr>
+              <a:t>ct</a:t>
+            </a:r>
+            <a:r>
+              <a:rPr lang="en-US" dirty="0">
+                <a:solidFill>
+                  <a:schemeClr val="bg1"/>
+                </a:solidFill>
+              </a:rPr>
+              <a:t>	= 1</a:t>
+            </a:r>
+          </a:p>
+          <a:p>
+            <a:endParaRPr lang="en-US" dirty="0">
+              <a:solidFill>
+                <a:schemeClr val="bg1"/>
+              </a:solidFill>
+            </a:endParaRPr>
+          </a:p>
+          <a:p>
+            <a:r>
+              <a:rPr lang="en-US" dirty="0" err="1">
+                <a:solidFill>
+                  <a:schemeClr val="bg1"/>
+                </a:solidFill>
+              </a:rPr>
+              <a:t>Verbindung</a:t>
+            </a:r>
+            <a:r>
+              <a:rPr lang="en-US" dirty="0">
+                <a:solidFill>
+                  <a:schemeClr val="bg1"/>
+                </a:solidFill>
+              </a:rPr>
+              <a:t> </a:t>
+            </a:r>
+            <a:r>
+              <a:rPr lang="en-US" dirty="0" err="1">
+                <a:solidFill>
+                  <a:schemeClr val="bg1"/>
+                </a:solidFill>
+              </a:rPr>
+              <a:t>zu</a:t>
+            </a:r>
+            <a:r>
+              <a:rPr lang="en-US" dirty="0">
+                <a:solidFill>
+                  <a:schemeClr val="bg1"/>
+                </a:solidFill>
+              </a:rPr>
+              <a:t> den </a:t>
+            </a:r>
+            <a:r>
+              <a:rPr lang="en-US" dirty="0" err="1">
+                <a:solidFill>
+                  <a:schemeClr val="bg1"/>
+                </a:solidFill>
+              </a:rPr>
+              <a:t>Koordinaten</a:t>
+            </a:r>
+            <a:r>
+              <a:rPr lang="en-US" dirty="0">
+                <a:solidFill>
+                  <a:schemeClr val="bg1"/>
+                </a:solidFill>
+              </a:rPr>
+              <a:t>- </a:t>
+            </a:r>
+            <a:r>
+              <a:rPr lang="en-US" dirty="0" err="1">
+                <a:solidFill>
+                  <a:schemeClr val="bg1"/>
+                </a:solidFill>
+              </a:rPr>
+              <a:t>achsen</a:t>
+            </a:r>
+            <a:r>
+              <a:rPr lang="en-US" dirty="0">
+                <a:solidFill>
+                  <a:schemeClr val="bg1"/>
+                </a:solidFill>
+              </a:rPr>
+              <a:t> </a:t>
+            </a:r>
+            <a:r>
+              <a:rPr lang="en-US" dirty="0" err="1">
+                <a:solidFill>
+                  <a:schemeClr val="bg1"/>
+                </a:solidFill>
+              </a:rPr>
+              <a:t>zum</a:t>
+            </a:r>
+            <a:r>
+              <a:rPr lang="en-US" dirty="0">
+                <a:solidFill>
+                  <a:schemeClr val="bg1"/>
+                </a:solidFill>
+              </a:rPr>
+              <a:t> </a:t>
+            </a:r>
+            <a:r>
+              <a:rPr lang="en-US" dirty="0" err="1">
+                <a:solidFill>
+                  <a:schemeClr val="bg1"/>
+                </a:solidFill>
+              </a:rPr>
+              <a:t>Ablesen</a:t>
+            </a:r>
+            <a:r>
+              <a:rPr lang="en-US" dirty="0">
+                <a:solidFill>
+                  <a:schemeClr val="bg1"/>
+                </a:solidFill>
+              </a:rPr>
+              <a:t> der </a:t>
+            </a:r>
+            <a:r>
+              <a:rPr lang="en-US" dirty="0" err="1">
+                <a:solidFill>
+                  <a:schemeClr val="bg1"/>
+                </a:solidFill>
+              </a:rPr>
+              <a:t>Werte</a:t>
+            </a:r>
+            <a:endParaRPr lang="en-US" dirty="0">
+              <a:solidFill>
+                <a:schemeClr val="bg1"/>
+              </a:solidFill>
+            </a:endParaRPr>
+          </a:p>
+          <a:p>
+            <a:endParaRPr lang="en-US" dirty="0">
+              <a:solidFill>
+                <a:schemeClr val="bg1"/>
+              </a:solidFill>
+            </a:endParaRPr>
+          </a:p>
+          <a:p>
+            <a:r>
+              <a:rPr lang="en-US" dirty="0" err="1">
+                <a:solidFill>
+                  <a:schemeClr val="bg1"/>
+                </a:solidFill>
+              </a:rPr>
+              <a:t>Messung</a:t>
+            </a:r>
+            <a:r>
+              <a:rPr lang="en-US" dirty="0">
+                <a:solidFill>
+                  <a:schemeClr val="bg1"/>
+                </a:solidFill>
+              </a:rPr>
+              <a:t> der </a:t>
+            </a:r>
+            <a:r>
+              <a:rPr lang="en-US" dirty="0" err="1">
+                <a:solidFill>
+                  <a:schemeClr val="bg1"/>
+                </a:solidFill>
+              </a:rPr>
+              <a:t>Entfernung</a:t>
+            </a:r>
+            <a:r>
+              <a:rPr lang="en-US" dirty="0">
+                <a:solidFill>
+                  <a:schemeClr val="bg1"/>
+                </a:solidFill>
+              </a:rPr>
+              <a:t> </a:t>
+            </a:r>
+            <a:r>
+              <a:rPr lang="en-US" dirty="0" err="1">
+                <a:solidFill>
+                  <a:schemeClr val="bg1"/>
+                </a:solidFill>
+              </a:rPr>
+              <a:t>zum</a:t>
+            </a:r>
+            <a:r>
+              <a:rPr lang="en-US" dirty="0">
+                <a:solidFill>
+                  <a:schemeClr val="bg1"/>
+                </a:solidFill>
+              </a:rPr>
+              <a:t> Ursprung</a:t>
+            </a:r>
+            <a:endParaRPr lang="en-CH" dirty="0">
+              <a:solidFill>
+                <a:schemeClr val="bg1"/>
+              </a:solidFill>
+            </a:endParaRPr>
+          </a:p>
+        </p:txBody>
+      </p:sp>
+    </p:spTree>
+    <p:extLst>
+      <p:ext uri="{BB962C8B-B14F-4D97-AF65-F5344CB8AC3E}">
+        <p14:creationId xmlns:p14="http://schemas.microsoft.com/office/powerpoint/2010/main" val="3197391370"/>
       </p:ext>
     </p:extLst>
   </p:cSld>

</xml_diff>

<commit_message>
introduced past and future
</commit_message>
<xml_diff>
--- a/slides/minkowski.pptx
+++ b/slides/minkowski.pptx
@@ -6,7 +6,7 @@
     <p:sldMasterId id="2147483798" r:id="rId2"/>
   </p:sldMasterIdLst>
   <p:notesMasterIdLst>
-    <p:notesMasterId r:id="rId15"/>
+    <p:notesMasterId r:id="rId18"/>
   </p:notesMasterIdLst>
   <p:sldIdLst>
     <p:sldId id="256" r:id="rId3"/>
@@ -21,6 +21,9 @@
     <p:sldId id="266" r:id="rId12"/>
     <p:sldId id="267" r:id="rId13"/>
     <p:sldId id="259" r:id="rId14"/>
+    <p:sldId id="270" r:id="rId15"/>
+    <p:sldId id="268" r:id="rId16"/>
+    <p:sldId id="269" r:id="rId17"/>
   </p:sldIdLst>
   <p:sldSz cx="12192000" cy="6858000"/>
   <p:notesSz cx="6858000" cy="9144000"/>
@@ -6088,8 +6091,8 @@
           </a:xfrm>
         </p:spPr>
       </p:pic>
-      <mc:AlternateContent xmlns:mc="http://schemas.openxmlformats.org/markup-compatibility/2006">
-        <mc:Choice xmlns:a14="http://schemas.microsoft.com/office/drawing/2010/main" Requires="a14">
+      <mc:AlternateContent xmlns:mc="http://schemas.openxmlformats.org/markup-compatibility/2006" xmlns:a14="http://schemas.microsoft.com/office/drawing/2010/main">
+        <mc:Choice Requires="a14">
           <p:sp>
             <p:nvSpPr>
               <p:cNvPr id="2" name="TextBox 1">
@@ -6538,7 +6541,7 @@
             </p:txBody>
           </p:sp>
         </mc:Choice>
-        <mc:Fallback>
+        <mc:Fallback xmlns="">
           <p:sp>
             <p:nvSpPr>
               <p:cNvPr id="2" name="TextBox 1">
@@ -6619,8 +6622,8 @@
           <a:chExt cx="0" cy="0"/>
         </a:xfrm>
       </p:grpSpPr>
-      <mc:AlternateContent xmlns:mc="http://schemas.openxmlformats.org/markup-compatibility/2006">
-        <mc:Choice xmlns:a14="http://schemas.microsoft.com/office/drawing/2010/main" Requires="a14">
+      <mc:AlternateContent xmlns:mc="http://schemas.openxmlformats.org/markup-compatibility/2006" xmlns:a14="http://schemas.microsoft.com/office/drawing/2010/main">
+        <mc:Choice Requires="a14">
           <p:sp>
             <p:nvSpPr>
               <p:cNvPr id="5" name="TextBox 4">
@@ -7191,7 +7194,6 @@
                 </a:endParaRPr>
               </a:p>
               <a:p>
-                <a:pPr/>
                 <a:r>
                   <a:rPr lang="en-US" b="0" dirty="0">
                     <a:solidFill>
@@ -7243,7 +7245,7 @@
             </p:txBody>
           </p:sp>
         </mc:Choice>
-        <mc:Fallback>
+        <mc:Fallback xmlns="">
           <p:sp>
             <p:nvSpPr>
               <p:cNvPr id="5" name="TextBox 4">
@@ -7384,10 +7386,2700 @@
           </a:xfrm>
         </p:spPr>
       </p:pic>
+      <mc:AlternateContent xmlns:mc="http://schemas.openxmlformats.org/markup-compatibility/2006">
+        <mc:Choice xmlns:a14="http://schemas.microsoft.com/office/drawing/2010/main" Requires="a14">
+          <p:sp>
+            <p:nvSpPr>
+              <p:cNvPr id="2" name="TextBox 1">
+                <a:extLst>
+                  <a:ext uri="{FF2B5EF4-FFF2-40B4-BE49-F238E27FC236}">
+                    <a16:creationId xmlns:a16="http://schemas.microsoft.com/office/drawing/2014/main" id="{94B87BA9-FAF2-990C-39C3-DA932358E7F1}"/>
+                  </a:ext>
+                </a:extLst>
+              </p:cNvPr>
+              <p:cNvSpPr txBox="1"/>
+              <p:nvPr/>
+            </p:nvSpPr>
+            <p:spPr>
+              <a:xfrm>
+                <a:off x="8547652" y="153348"/>
+                <a:ext cx="3475855" cy="1200329"/>
+              </a:xfrm>
+              <a:prstGeom prst="rect">
+                <a:avLst/>
+              </a:prstGeom>
+              <a:noFill/>
+            </p:spPr>
+            <p:txBody>
+              <a:bodyPr wrap="square" rtlCol="0">
+                <a:spAutoFit/>
+              </a:bodyPr>
+              <a:lstStyle/>
+              <a:p>
+                <a:r>
+                  <a:rPr lang="en-US" dirty="0">
+                    <a:solidFill>
+                      <a:schemeClr val="bg1"/>
+                    </a:solidFill>
+                  </a:rPr>
+                  <a:t>Bei Licht gilt </a:t>
+                </a:r>
+                <a14:m>
+                  <m:oMath xmlns:m="http://schemas.openxmlformats.org/officeDocument/2006/math">
+                    <m:r>
+                      <m:rPr>
+                        <m:sty m:val="p"/>
+                      </m:rPr>
+                      <a:rPr lang="en-US" b="0" i="0" smtClean="0">
+                        <a:solidFill>
+                          <a:schemeClr val="bg1"/>
+                        </a:solidFill>
+                        <a:latin typeface="Cambria Math" panose="02040503050406030204" pitchFamily="18" charset="0"/>
+                      </a:rPr>
+                      <m:t>Δ</m:t>
+                    </m:r>
+                    <m:r>
+                      <a:rPr lang="en-US" b="0" i="1" smtClean="0">
+                        <a:solidFill>
+                          <a:schemeClr val="bg1"/>
+                        </a:solidFill>
+                        <a:latin typeface="Cambria Math" panose="02040503050406030204" pitchFamily="18" charset="0"/>
+                      </a:rPr>
+                      <m:t>𝑧</m:t>
+                    </m:r>
+                    <m:r>
+                      <a:rPr lang="en-US" b="0" i="1" smtClean="0">
+                        <a:solidFill>
+                          <a:schemeClr val="bg1"/>
+                        </a:solidFill>
+                        <a:latin typeface="Cambria Math" panose="02040503050406030204" pitchFamily="18" charset="0"/>
+                      </a:rPr>
+                      <m:t>=</m:t>
+                    </m:r>
+                    <m:r>
+                      <m:rPr>
+                        <m:nor/>
+                      </m:rPr>
+                      <a:rPr lang="en-US" dirty="0">
+                        <a:solidFill>
+                          <a:schemeClr val="bg1"/>
+                        </a:solidFill>
+                      </a:rPr>
+                      <m:t>c</m:t>
+                    </m:r>
+                    <m:r>
+                      <m:rPr>
+                        <m:sty m:val="p"/>
+                      </m:rPr>
+                      <a:rPr lang="en-US">
+                        <a:solidFill>
+                          <a:schemeClr val="bg1"/>
+                        </a:solidFill>
+                        <a:latin typeface="Cambria Math" panose="02040503050406030204" pitchFamily="18" charset="0"/>
+                      </a:rPr>
+                      <m:t>Δ</m:t>
+                    </m:r>
+                    <m:r>
+                      <a:rPr lang="en-US" i="1">
+                        <a:solidFill>
+                          <a:schemeClr val="bg1"/>
+                        </a:solidFill>
+                        <a:latin typeface="Cambria Math" panose="02040503050406030204" pitchFamily="18" charset="0"/>
+                      </a:rPr>
+                      <m:t>𝑡</m:t>
+                    </m:r>
+                  </m:oMath>
+                </a14:m>
+                <a:endParaRPr lang="en-US" dirty="0">
+                  <a:solidFill>
+                    <a:schemeClr val="bg1"/>
+                  </a:solidFill>
+                </a:endParaRPr>
+              </a:p>
+              <a:p>
+                <a:endParaRPr lang="en-US" dirty="0">
+                  <a:solidFill>
+                    <a:schemeClr val="bg1"/>
+                  </a:solidFill>
+                </a:endParaRPr>
+              </a:p>
+              <a:p>
+                <a:r>
+                  <a:rPr lang="en-US" dirty="0" err="1">
+                    <a:solidFill>
+                      <a:schemeClr val="bg1"/>
+                    </a:solidFill>
+                  </a:rPr>
+                  <a:t>Dadurch</a:t>
+                </a:r>
+                <a:r>
+                  <a:rPr lang="en-US" dirty="0">
+                    <a:solidFill>
+                      <a:schemeClr val="bg1"/>
+                    </a:solidFill>
+                  </a:rPr>
+                  <a:t> </a:t>
+                </a:r>
+                <a:r>
+                  <a:rPr lang="en-US" dirty="0" err="1">
+                    <a:solidFill>
+                      <a:schemeClr val="bg1"/>
+                    </a:solidFill>
+                  </a:rPr>
+                  <a:t>entstehen</a:t>
+                </a:r>
+                <a:r>
+                  <a:rPr lang="en-US" dirty="0">
+                    <a:solidFill>
+                      <a:schemeClr val="bg1"/>
+                    </a:solidFill>
+                  </a:rPr>
+                  <a:t> </a:t>
+                </a:r>
+                <a:r>
+                  <a:rPr lang="en-US" dirty="0" err="1">
+                    <a:solidFill>
+                      <a:schemeClr val="bg1"/>
+                    </a:solidFill>
+                  </a:rPr>
+                  <a:t>Diagonalen</a:t>
+                </a:r>
+                <a:r>
+                  <a:rPr lang="en-US" dirty="0">
+                    <a:solidFill>
+                      <a:schemeClr val="bg1"/>
+                    </a:solidFill>
+                  </a:rPr>
+                  <a:t> </a:t>
+                </a:r>
+                <a:r>
+                  <a:rPr lang="en-US" dirty="0" err="1">
+                    <a:solidFill>
+                      <a:schemeClr val="bg1"/>
+                    </a:solidFill>
+                  </a:rPr>
+                  <a:t>im</a:t>
+                </a:r>
+                <a:r>
+                  <a:rPr lang="en-US" dirty="0">
+                    <a:solidFill>
+                      <a:schemeClr val="bg1"/>
+                    </a:solidFill>
+                  </a:rPr>
+                  <a:t> Minkowski-</a:t>
+                </a:r>
+                <a:r>
+                  <a:rPr lang="en-US" dirty="0" err="1">
+                    <a:solidFill>
+                      <a:schemeClr val="bg1"/>
+                    </a:solidFill>
+                  </a:rPr>
+                  <a:t>Diagramm</a:t>
+                </a:r>
+                <a:endParaRPr lang="en-US" dirty="0">
+                  <a:solidFill>
+                    <a:schemeClr val="bg1"/>
+                  </a:solidFill>
+                </a:endParaRPr>
+              </a:p>
+            </p:txBody>
+          </p:sp>
+        </mc:Choice>
+        <mc:Fallback>
+          <p:sp>
+            <p:nvSpPr>
+              <p:cNvPr id="2" name="TextBox 1">
+                <a:extLst>
+                  <a:ext uri="{FF2B5EF4-FFF2-40B4-BE49-F238E27FC236}">
+                    <a16:creationId xmlns:a16="http://schemas.microsoft.com/office/drawing/2014/main" id="{94B87BA9-FAF2-990C-39C3-DA932358E7F1}"/>
+                  </a:ext>
+                </a:extLst>
+              </p:cNvPr>
+              <p:cNvSpPr txBox="1">
+                <a:spLocks noRot="1" noChangeAspect="1" noMove="1" noResize="1" noEditPoints="1" noAdjustHandles="1" noChangeArrowheads="1" noChangeShapeType="1" noTextEdit="1"/>
+              </p:cNvSpPr>
+              <p:nvPr/>
+            </p:nvSpPr>
+            <p:spPr>
+              <a:xfrm>
+                <a:off x="8547652" y="153348"/>
+                <a:ext cx="3475855" cy="1200329"/>
+              </a:xfrm>
+              <a:prstGeom prst="rect">
+                <a:avLst/>
+              </a:prstGeom>
+              <a:blipFill>
+                <a:blip r:embed="rId3"/>
+                <a:stretch>
+                  <a:fillRect l="-1404" t="-2538" b="-7107"/>
+                </a:stretch>
+              </a:blipFill>
+            </p:spPr>
+            <p:txBody>
+              <a:bodyPr/>
+              <a:lstStyle/>
+              <a:p>
+                <a:r>
+                  <a:rPr lang="en-CH">
+                    <a:noFill/>
+                  </a:rPr>
+                  <a:t> </a:t>
+                </a:r>
+              </a:p>
+            </p:txBody>
+          </p:sp>
+        </mc:Fallback>
+      </mc:AlternateContent>
     </p:spTree>
     <p:extLst>
       <p:ext uri="{BB962C8B-B14F-4D97-AF65-F5344CB8AC3E}">
         <p14:creationId xmlns:p14="http://schemas.microsoft.com/office/powerpoint/2010/main" val="4206889277"/>
+      </p:ext>
+    </p:extLst>
+  </p:cSld>
+  <p:clrMapOvr>
+    <a:masterClrMapping/>
+  </p:clrMapOvr>
+</p:sld>
+</file>
+
+<file path=ppt/slides/slide13.xml><?xml version="1.0" encoding="utf-8"?>
+<p:sld xmlns:a="http://schemas.openxmlformats.org/drawingml/2006/main" xmlns:r="http://schemas.openxmlformats.org/officeDocument/2006/relationships" xmlns:p="http://schemas.openxmlformats.org/presentationml/2006/main">
+  <p:cSld>
+    <p:spTree>
+      <p:nvGrpSpPr>
+        <p:cNvPr id="1" name="">
+          <a:extLst>
+            <a:ext uri="{FF2B5EF4-FFF2-40B4-BE49-F238E27FC236}">
+              <a16:creationId xmlns:a16="http://schemas.microsoft.com/office/drawing/2014/main" id="{C0AF8EDC-C61C-B4DE-F823-5F8AB0BEFD82}"/>
+            </a:ext>
+          </a:extLst>
+        </p:cNvPr>
+        <p:cNvGrpSpPr/>
+        <p:nvPr/>
+      </p:nvGrpSpPr>
+      <p:grpSpPr>
+        <a:xfrm>
+          <a:off x="0" y="0"/>
+          <a:ext cx="0" cy="0"/>
+          <a:chOff x="0" y="0"/>
+          <a:chExt cx="0" cy="0"/>
+        </a:xfrm>
+      </p:grpSpPr>
+      <p:pic>
+        <p:nvPicPr>
+          <p:cNvPr id="4" name="Content Placeholder 3">
+            <a:extLst>
+              <a:ext uri="{FF2B5EF4-FFF2-40B4-BE49-F238E27FC236}">
+                <a16:creationId xmlns:a16="http://schemas.microsoft.com/office/drawing/2014/main" id="{50E54EA0-3A4A-39F2-4AF6-663D0C2648C9}"/>
+              </a:ext>
+            </a:extLst>
+          </p:cNvPr>
+          <p:cNvPicPr>
+            <a:picLocks noGrp="1" noChangeAspect="1"/>
+          </p:cNvPicPr>
+          <p:nvPr>
+            <p:ph idx="1"/>
+          </p:nvPr>
+        </p:nvPicPr>
+        <p:blipFill>
+          <a:blip r:link="rId2"/>
+          <a:srcRect/>
+          <a:stretch>
+            <a:fillRect/>
+          </a:stretch>
+        </p:blipFill>
+        <p:spPr>
+          <a:xfrm>
+            <a:off x="439948" y="-422692"/>
+            <a:ext cx="7556740" cy="7556740"/>
+          </a:xfrm>
+        </p:spPr>
+      </p:pic>
+      <mc:AlternateContent xmlns:mc="http://schemas.openxmlformats.org/markup-compatibility/2006">
+        <mc:Choice xmlns:a14="http://schemas.microsoft.com/office/drawing/2010/main" Requires="a14">
+          <p:sp>
+            <p:nvSpPr>
+              <p:cNvPr id="2" name="TextBox 1">
+                <a:extLst>
+                  <a:ext uri="{FF2B5EF4-FFF2-40B4-BE49-F238E27FC236}">
+                    <a16:creationId xmlns:a16="http://schemas.microsoft.com/office/drawing/2014/main" id="{CD40440C-0188-F5D7-BA2B-6C65310FA518}"/>
+                  </a:ext>
+                </a:extLst>
+              </p:cNvPr>
+              <p:cNvSpPr txBox="1"/>
+              <p:nvPr/>
+            </p:nvSpPr>
+            <p:spPr>
+              <a:xfrm>
+                <a:off x="8547652" y="153348"/>
+                <a:ext cx="3475855" cy="2308324"/>
+              </a:xfrm>
+              <a:prstGeom prst="rect">
+                <a:avLst/>
+              </a:prstGeom>
+              <a:noFill/>
+            </p:spPr>
+            <p:txBody>
+              <a:bodyPr wrap="square" rtlCol="0">
+                <a:spAutoFit/>
+              </a:bodyPr>
+              <a:lstStyle/>
+              <a:p>
+                <a:r>
+                  <a:rPr lang="en-US" dirty="0">
+                    <a:solidFill>
+                      <a:schemeClr val="bg1"/>
+                    </a:solidFill>
+                  </a:rPr>
+                  <a:t>Bei Licht gilt </a:t>
+                </a:r>
+                <a14:m>
+                  <m:oMath xmlns:m="http://schemas.openxmlformats.org/officeDocument/2006/math">
+                    <m:r>
+                      <m:rPr>
+                        <m:sty m:val="p"/>
+                      </m:rPr>
+                      <a:rPr lang="en-US" b="0" i="0" smtClean="0">
+                        <a:solidFill>
+                          <a:schemeClr val="bg1"/>
+                        </a:solidFill>
+                        <a:latin typeface="Cambria Math" panose="02040503050406030204" pitchFamily="18" charset="0"/>
+                      </a:rPr>
+                      <m:t>Δ</m:t>
+                    </m:r>
+                    <m:r>
+                      <a:rPr lang="en-US" b="0" i="1" smtClean="0">
+                        <a:solidFill>
+                          <a:schemeClr val="bg1"/>
+                        </a:solidFill>
+                        <a:latin typeface="Cambria Math" panose="02040503050406030204" pitchFamily="18" charset="0"/>
+                      </a:rPr>
+                      <m:t>𝑧</m:t>
+                    </m:r>
+                    <m:r>
+                      <a:rPr lang="en-US" b="0" i="1" smtClean="0">
+                        <a:solidFill>
+                          <a:schemeClr val="bg1"/>
+                        </a:solidFill>
+                        <a:latin typeface="Cambria Math" panose="02040503050406030204" pitchFamily="18" charset="0"/>
+                      </a:rPr>
+                      <m:t>=</m:t>
+                    </m:r>
+                    <m:r>
+                      <m:rPr>
+                        <m:nor/>
+                      </m:rPr>
+                      <a:rPr lang="en-US" dirty="0">
+                        <a:solidFill>
+                          <a:schemeClr val="bg1"/>
+                        </a:solidFill>
+                      </a:rPr>
+                      <m:t>c</m:t>
+                    </m:r>
+                    <m:r>
+                      <m:rPr>
+                        <m:sty m:val="p"/>
+                      </m:rPr>
+                      <a:rPr lang="en-US">
+                        <a:solidFill>
+                          <a:schemeClr val="bg1"/>
+                        </a:solidFill>
+                        <a:latin typeface="Cambria Math" panose="02040503050406030204" pitchFamily="18" charset="0"/>
+                      </a:rPr>
+                      <m:t>Δ</m:t>
+                    </m:r>
+                    <m:r>
+                      <a:rPr lang="en-US" i="1">
+                        <a:solidFill>
+                          <a:schemeClr val="bg1"/>
+                        </a:solidFill>
+                        <a:latin typeface="Cambria Math" panose="02040503050406030204" pitchFamily="18" charset="0"/>
+                      </a:rPr>
+                      <m:t>𝑡</m:t>
+                    </m:r>
+                  </m:oMath>
+                </a14:m>
+                <a:endParaRPr lang="en-US" dirty="0">
+                  <a:solidFill>
+                    <a:schemeClr val="bg1"/>
+                  </a:solidFill>
+                </a:endParaRPr>
+              </a:p>
+              <a:p>
+                <a:endParaRPr lang="en-US" dirty="0">
+                  <a:solidFill>
+                    <a:schemeClr val="bg1"/>
+                  </a:solidFill>
+                </a:endParaRPr>
+              </a:p>
+              <a:p>
+                <a:r>
+                  <a:rPr lang="en-US" dirty="0" err="1">
+                    <a:solidFill>
+                      <a:schemeClr val="bg1"/>
+                    </a:solidFill>
+                  </a:rPr>
+                  <a:t>Dadurch</a:t>
+                </a:r>
+                <a:r>
+                  <a:rPr lang="en-US" dirty="0">
+                    <a:solidFill>
+                      <a:schemeClr val="bg1"/>
+                    </a:solidFill>
+                  </a:rPr>
+                  <a:t> </a:t>
+                </a:r>
+                <a:r>
+                  <a:rPr lang="en-US" dirty="0" err="1">
+                    <a:solidFill>
+                      <a:schemeClr val="bg1"/>
+                    </a:solidFill>
+                  </a:rPr>
+                  <a:t>entstehen</a:t>
+                </a:r>
+                <a:r>
+                  <a:rPr lang="en-US" dirty="0">
+                    <a:solidFill>
+                      <a:schemeClr val="bg1"/>
+                    </a:solidFill>
+                  </a:rPr>
+                  <a:t> </a:t>
+                </a:r>
+                <a:r>
+                  <a:rPr lang="en-US" dirty="0" err="1">
+                    <a:solidFill>
+                      <a:schemeClr val="bg1"/>
+                    </a:solidFill>
+                  </a:rPr>
+                  <a:t>Diagonalen</a:t>
+                </a:r>
+                <a:r>
+                  <a:rPr lang="en-US" dirty="0">
+                    <a:solidFill>
+                      <a:schemeClr val="bg1"/>
+                    </a:solidFill>
+                  </a:rPr>
+                  <a:t> </a:t>
+                </a:r>
+                <a:r>
+                  <a:rPr lang="en-US" dirty="0" err="1">
+                    <a:solidFill>
+                      <a:schemeClr val="bg1"/>
+                    </a:solidFill>
+                  </a:rPr>
+                  <a:t>im</a:t>
+                </a:r>
+                <a:r>
+                  <a:rPr lang="en-US" dirty="0">
+                    <a:solidFill>
+                      <a:schemeClr val="bg1"/>
+                    </a:solidFill>
+                  </a:rPr>
+                  <a:t> Minkowski-</a:t>
+                </a:r>
+                <a:r>
+                  <a:rPr lang="en-US" dirty="0" err="1">
+                    <a:solidFill>
+                      <a:schemeClr val="bg1"/>
+                    </a:solidFill>
+                  </a:rPr>
+                  <a:t>Diagramm</a:t>
+                </a:r>
+                <a:endParaRPr lang="en-US" dirty="0">
+                  <a:solidFill>
+                    <a:schemeClr val="bg1"/>
+                  </a:solidFill>
+                </a:endParaRPr>
+              </a:p>
+              <a:p>
+                <a:endParaRPr lang="en-US" dirty="0">
+                  <a:solidFill>
+                    <a:schemeClr val="bg1"/>
+                  </a:solidFill>
+                </a:endParaRPr>
+              </a:p>
+              <a:p>
+                <a:r>
+                  <a:rPr lang="en-US" dirty="0">
+                    <a:solidFill>
+                      <a:schemeClr val="bg1"/>
+                    </a:solidFill>
+                  </a:rPr>
+                  <a:t>Wir </a:t>
+                </a:r>
+                <a:r>
+                  <a:rPr lang="en-US" dirty="0" err="1">
+                    <a:solidFill>
+                      <a:schemeClr val="bg1"/>
+                    </a:solidFill>
+                  </a:rPr>
+                  <a:t>können</a:t>
+                </a:r>
+                <a:r>
+                  <a:rPr lang="en-US" dirty="0">
+                    <a:solidFill>
+                      <a:schemeClr val="bg1"/>
+                    </a:solidFill>
+                  </a:rPr>
+                  <a:t> in </a:t>
+                </a:r>
+                <a:r>
+                  <a:rPr lang="en-US" dirty="0" err="1">
+                    <a:solidFill>
+                      <a:schemeClr val="bg1"/>
+                    </a:solidFill>
+                  </a:rPr>
+                  <a:t>zeitartige</a:t>
+                </a:r>
+                <a:r>
+                  <a:rPr lang="en-US" dirty="0">
+                    <a:solidFill>
+                      <a:schemeClr val="bg1"/>
+                    </a:solidFill>
+                  </a:rPr>
+                  <a:t> und </a:t>
+                </a:r>
+                <a:r>
+                  <a:rPr lang="en-US" dirty="0" err="1">
+                    <a:solidFill>
+                      <a:schemeClr val="bg1"/>
+                    </a:solidFill>
+                  </a:rPr>
+                  <a:t>raumsartige</a:t>
+                </a:r>
+                <a:r>
+                  <a:rPr lang="en-US" dirty="0">
+                    <a:solidFill>
+                      <a:schemeClr val="bg1"/>
+                    </a:solidFill>
+                  </a:rPr>
+                  <a:t> </a:t>
+                </a:r>
+                <a:r>
+                  <a:rPr lang="en-US" dirty="0" err="1">
+                    <a:solidFill>
+                      <a:schemeClr val="bg1"/>
+                    </a:solidFill>
+                  </a:rPr>
+                  <a:t>Vektoren</a:t>
+                </a:r>
+                <a:r>
+                  <a:rPr lang="en-US" dirty="0">
+                    <a:solidFill>
+                      <a:schemeClr val="bg1"/>
+                    </a:solidFill>
+                  </a:rPr>
+                  <a:t> </a:t>
+                </a:r>
+                <a:r>
+                  <a:rPr lang="en-US" dirty="0" err="1">
+                    <a:solidFill>
+                      <a:schemeClr val="bg1"/>
+                    </a:solidFill>
+                  </a:rPr>
+                  <a:t>unterteilen</a:t>
+                </a:r>
+                <a:r>
+                  <a:rPr lang="en-US" dirty="0">
+                    <a:solidFill>
+                      <a:schemeClr val="bg1"/>
+                    </a:solidFill>
+                  </a:rPr>
+                  <a:t>.</a:t>
+                </a:r>
+              </a:p>
+              <a:p>
+                <a:endParaRPr lang="en-US" dirty="0">
+                  <a:solidFill>
+                    <a:schemeClr val="bg1"/>
+                  </a:solidFill>
+                </a:endParaRPr>
+              </a:p>
+            </p:txBody>
+          </p:sp>
+        </mc:Choice>
+        <mc:Fallback>
+          <p:sp>
+            <p:nvSpPr>
+              <p:cNvPr id="2" name="TextBox 1">
+                <a:extLst>
+                  <a:ext uri="{FF2B5EF4-FFF2-40B4-BE49-F238E27FC236}">
+                    <a16:creationId xmlns:a16="http://schemas.microsoft.com/office/drawing/2014/main" id="{CD40440C-0188-F5D7-BA2B-6C65310FA518}"/>
+                  </a:ext>
+                </a:extLst>
+              </p:cNvPr>
+              <p:cNvSpPr txBox="1">
+                <a:spLocks noRot="1" noChangeAspect="1" noMove="1" noResize="1" noEditPoints="1" noAdjustHandles="1" noChangeArrowheads="1" noChangeShapeType="1" noTextEdit="1"/>
+              </p:cNvSpPr>
+              <p:nvPr/>
+            </p:nvSpPr>
+            <p:spPr>
+              <a:xfrm>
+                <a:off x="8547652" y="153348"/>
+                <a:ext cx="3475855" cy="2308324"/>
+              </a:xfrm>
+              <a:prstGeom prst="rect">
+                <a:avLst/>
+              </a:prstGeom>
+              <a:blipFill>
+                <a:blip r:embed="rId3"/>
+                <a:stretch>
+                  <a:fillRect l="-1404" t="-1319"/>
+                </a:stretch>
+              </a:blipFill>
+            </p:spPr>
+            <p:txBody>
+              <a:bodyPr/>
+              <a:lstStyle/>
+              <a:p>
+                <a:r>
+                  <a:rPr lang="en-CH">
+                    <a:noFill/>
+                  </a:rPr>
+                  <a:t> </a:t>
+                </a:r>
+              </a:p>
+            </p:txBody>
+          </p:sp>
+        </mc:Fallback>
+      </mc:AlternateContent>
+    </p:spTree>
+    <p:extLst>
+      <p:ext uri="{BB962C8B-B14F-4D97-AF65-F5344CB8AC3E}">
+        <p14:creationId xmlns:p14="http://schemas.microsoft.com/office/powerpoint/2010/main" val="2789995781"/>
+      </p:ext>
+    </p:extLst>
+  </p:cSld>
+  <p:clrMapOvr>
+    <a:masterClrMapping/>
+  </p:clrMapOvr>
+</p:sld>
+</file>
+
+<file path=ppt/slides/slide14.xml><?xml version="1.0" encoding="utf-8"?>
+<p:sld xmlns:a="http://schemas.openxmlformats.org/drawingml/2006/main" xmlns:r="http://schemas.openxmlformats.org/officeDocument/2006/relationships" xmlns:p="http://schemas.openxmlformats.org/presentationml/2006/main">
+  <p:cSld>
+    <p:spTree>
+      <p:nvGrpSpPr>
+        <p:cNvPr id="1" name="">
+          <a:extLst>
+            <a:ext uri="{FF2B5EF4-FFF2-40B4-BE49-F238E27FC236}">
+              <a16:creationId xmlns:a16="http://schemas.microsoft.com/office/drawing/2014/main" id="{305C2737-508E-1DFE-098B-3EEDD4765276}"/>
+            </a:ext>
+          </a:extLst>
+        </p:cNvPr>
+        <p:cNvGrpSpPr/>
+        <p:nvPr/>
+      </p:nvGrpSpPr>
+      <p:grpSpPr>
+        <a:xfrm>
+          <a:off x="0" y="0"/>
+          <a:ext cx="0" cy="0"/>
+          <a:chOff x="0" y="0"/>
+          <a:chExt cx="0" cy="0"/>
+        </a:xfrm>
+      </p:grpSpPr>
+      <p:pic>
+        <p:nvPicPr>
+          <p:cNvPr id="4" name="Content Placeholder 3">
+            <a:extLst>
+              <a:ext uri="{FF2B5EF4-FFF2-40B4-BE49-F238E27FC236}">
+                <a16:creationId xmlns:a16="http://schemas.microsoft.com/office/drawing/2014/main" id="{886035E4-E344-612B-BB59-387DDF10D9AB}"/>
+              </a:ext>
+            </a:extLst>
+          </p:cNvPr>
+          <p:cNvPicPr>
+            <a:picLocks noGrp="1" noChangeAspect="1"/>
+          </p:cNvPicPr>
+          <p:nvPr>
+            <p:ph idx="1"/>
+          </p:nvPr>
+        </p:nvPicPr>
+        <p:blipFill>
+          <a:blip r:link="rId2"/>
+          <a:srcRect/>
+          <a:stretch>
+            <a:fillRect/>
+          </a:stretch>
+        </p:blipFill>
+        <p:spPr>
+          <a:xfrm>
+            <a:off x="439948" y="-422692"/>
+            <a:ext cx="7556740" cy="7556740"/>
+          </a:xfrm>
+        </p:spPr>
+      </p:pic>
+      <mc:AlternateContent xmlns:mc="http://schemas.openxmlformats.org/markup-compatibility/2006">
+        <mc:Choice xmlns:a14="http://schemas.microsoft.com/office/drawing/2010/main" Requires="a14">
+          <p:sp>
+            <p:nvSpPr>
+              <p:cNvPr id="2" name="TextBox 1">
+                <a:extLst>
+                  <a:ext uri="{FF2B5EF4-FFF2-40B4-BE49-F238E27FC236}">
+                    <a16:creationId xmlns:a16="http://schemas.microsoft.com/office/drawing/2014/main" id="{FF0478EB-DE3B-0BA7-447C-A94ADD0B44AF}"/>
+                  </a:ext>
+                </a:extLst>
+              </p:cNvPr>
+              <p:cNvSpPr txBox="1"/>
+              <p:nvPr/>
+            </p:nvSpPr>
+            <p:spPr>
+              <a:xfrm>
+                <a:off x="8547652" y="153348"/>
+                <a:ext cx="3475855" cy="3970318"/>
+              </a:xfrm>
+              <a:prstGeom prst="rect">
+                <a:avLst/>
+              </a:prstGeom>
+              <a:noFill/>
+            </p:spPr>
+            <p:txBody>
+              <a:bodyPr wrap="square" rtlCol="0">
+                <a:spAutoFit/>
+              </a:bodyPr>
+              <a:lstStyle/>
+              <a:p>
+                <a:r>
+                  <a:rPr lang="en-US" dirty="0">
+                    <a:solidFill>
+                      <a:schemeClr val="bg1"/>
+                    </a:solidFill>
+                  </a:rPr>
+                  <a:t>Bei Licht gilt </a:t>
+                </a:r>
+                <a14:m>
+                  <m:oMath xmlns:m="http://schemas.openxmlformats.org/officeDocument/2006/math">
+                    <m:r>
+                      <m:rPr>
+                        <m:sty m:val="p"/>
+                      </m:rPr>
+                      <a:rPr lang="en-US" b="0" i="0" smtClean="0">
+                        <a:solidFill>
+                          <a:schemeClr val="bg1"/>
+                        </a:solidFill>
+                        <a:latin typeface="Cambria Math" panose="02040503050406030204" pitchFamily="18" charset="0"/>
+                      </a:rPr>
+                      <m:t>Δ</m:t>
+                    </m:r>
+                    <m:r>
+                      <a:rPr lang="en-US" b="0" i="1" smtClean="0">
+                        <a:solidFill>
+                          <a:schemeClr val="bg1"/>
+                        </a:solidFill>
+                        <a:latin typeface="Cambria Math" panose="02040503050406030204" pitchFamily="18" charset="0"/>
+                      </a:rPr>
+                      <m:t>𝑧</m:t>
+                    </m:r>
+                    <m:r>
+                      <a:rPr lang="en-US" b="0" i="1" smtClean="0">
+                        <a:solidFill>
+                          <a:schemeClr val="bg1"/>
+                        </a:solidFill>
+                        <a:latin typeface="Cambria Math" panose="02040503050406030204" pitchFamily="18" charset="0"/>
+                      </a:rPr>
+                      <m:t>=</m:t>
+                    </m:r>
+                    <m:r>
+                      <m:rPr>
+                        <m:nor/>
+                      </m:rPr>
+                      <a:rPr lang="en-US" dirty="0">
+                        <a:solidFill>
+                          <a:schemeClr val="bg1"/>
+                        </a:solidFill>
+                      </a:rPr>
+                      <m:t>c</m:t>
+                    </m:r>
+                    <m:r>
+                      <m:rPr>
+                        <m:sty m:val="p"/>
+                      </m:rPr>
+                      <a:rPr lang="en-US">
+                        <a:solidFill>
+                          <a:schemeClr val="bg1"/>
+                        </a:solidFill>
+                        <a:latin typeface="Cambria Math" panose="02040503050406030204" pitchFamily="18" charset="0"/>
+                      </a:rPr>
+                      <m:t>Δ</m:t>
+                    </m:r>
+                    <m:r>
+                      <a:rPr lang="en-US" i="1">
+                        <a:solidFill>
+                          <a:schemeClr val="bg1"/>
+                        </a:solidFill>
+                        <a:latin typeface="Cambria Math" panose="02040503050406030204" pitchFamily="18" charset="0"/>
+                      </a:rPr>
+                      <m:t>𝑡</m:t>
+                    </m:r>
+                  </m:oMath>
+                </a14:m>
+                <a:endParaRPr lang="en-US" dirty="0">
+                  <a:solidFill>
+                    <a:schemeClr val="bg1"/>
+                  </a:solidFill>
+                </a:endParaRPr>
+              </a:p>
+              <a:p>
+                <a:endParaRPr lang="en-US" dirty="0">
+                  <a:solidFill>
+                    <a:schemeClr val="bg1"/>
+                  </a:solidFill>
+                </a:endParaRPr>
+              </a:p>
+              <a:p>
+                <a:r>
+                  <a:rPr lang="en-US" dirty="0" err="1">
+                    <a:solidFill>
+                      <a:schemeClr val="bg1"/>
+                    </a:solidFill>
+                  </a:rPr>
+                  <a:t>Dadurch</a:t>
+                </a:r>
+                <a:r>
+                  <a:rPr lang="en-US" dirty="0">
+                    <a:solidFill>
+                      <a:schemeClr val="bg1"/>
+                    </a:solidFill>
+                  </a:rPr>
+                  <a:t> </a:t>
+                </a:r>
+                <a:r>
+                  <a:rPr lang="en-US" dirty="0" err="1">
+                    <a:solidFill>
+                      <a:schemeClr val="bg1"/>
+                    </a:solidFill>
+                  </a:rPr>
+                  <a:t>entstehen</a:t>
+                </a:r>
+                <a:r>
+                  <a:rPr lang="en-US" dirty="0">
+                    <a:solidFill>
+                      <a:schemeClr val="bg1"/>
+                    </a:solidFill>
+                  </a:rPr>
+                  <a:t> </a:t>
+                </a:r>
+                <a:r>
+                  <a:rPr lang="en-US" dirty="0" err="1">
+                    <a:solidFill>
+                      <a:schemeClr val="bg1"/>
+                    </a:solidFill>
+                  </a:rPr>
+                  <a:t>Diagonalen</a:t>
+                </a:r>
+                <a:r>
+                  <a:rPr lang="en-US" dirty="0">
+                    <a:solidFill>
+                      <a:schemeClr val="bg1"/>
+                    </a:solidFill>
+                  </a:rPr>
+                  <a:t> </a:t>
+                </a:r>
+                <a:r>
+                  <a:rPr lang="en-US" dirty="0" err="1">
+                    <a:solidFill>
+                      <a:schemeClr val="bg1"/>
+                    </a:solidFill>
+                  </a:rPr>
+                  <a:t>im</a:t>
+                </a:r>
+                <a:r>
+                  <a:rPr lang="en-US" dirty="0">
+                    <a:solidFill>
+                      <a:schemeClr val="bg1"/>
+                    </a:solidFill>
+                  </a:rPr>
+                  <a:t> Minkowski-</a:t>
+                </a:r>
+                <a:r>
+                  <a:rPr lang="en-US" dirty="0" err="1">
+                    <a:solidFill>
+                      <a:schemeClr val="bg1"/>
+                    </a:solidFill>
+                  </a:rPr>
+                  <a:t>Diagramm</a:t>
+                </a:r>
+                <a:endParaRPr lang="en-US" dirty="0">
+                  <a:solidFill>
+                    <a:schemeClr val="bg1"/>
+                  </a:solidFill>
+                </a:endParaRPr>
+              </a:p>
+              <a:p>
+                <a:endParaRPr lang="en-US" dirty="0">
+                  <a:solidFill>
+                    <a:schemeClr val="bg1"/>
+                  </a:solidFill>
+                </a:endParaRPr>
+              </a:p>
+              <a:p>
+                <a:r>
+                  <a:rPr lang="en-US" dirty="0">
+                    <a:solidFill>
+                      <a:schemeClr val="bg1"/>
+                    </a:solidFill>
+                  </a:rPr>
+                  <a:t>Wir </a:t>
+                </a:r>
+                <a:r>
+                  <a:rPr lang="en-US" dirty="0" err="1">
+                    <a:solidFill>
+                      <a:schemeClr val="bg1"/>
+                    </a:solidFill>
+                  </a:rPr>
+                  <a:t>können</a:t>
+                </a:r>
+                <a:r>
+                  <a:rPr lang="en-US" dirty="0">
+                    <a:solidFill>
+                      <a:schemeClr val="bg1"/>
+                    </a:solidFill>
+                  </a:rPr>
+                  <a:t> in </a:t>
+                </a:r>
+                <a:r>
+                  <a:rPr lang="en-US" dirty="0" err="1">
+                    <a:solidFill>
+                      <a:schemeClr val="bg1"/>
+                    </a:solidFill>
+                  </a:rPr>
+                  <a:t>zeitartige</a:t>
+                </a:r>
+                <a:r>
+                  <a:rPr lang="en-US" dirty="0">
+                    <a:solidFill>
+                      <a:schemeClr val="bg1"/>
+                    </a:solidFill>
+                  </a:rPr>
+                  <a:t> und </a:t>
+                </a:r>
+                <a:r>
+                  <a:rPr lang="en-US" dirty="0" err="1">
+                    <a:solidFill>
+                      <a:schemeClr val="bg1"/>
+                    </a:solidFill>
+                  </a:rPr>
+                  <a:t>raumsartige</a:t>
+                </a:r>
+                <a:r>
+                  <a:rPr lang="en-US" dirty="0">
+                    <a:solidFill>
+                      <a:schemeClr val="bg1"/>
+                    </a:solidFill>
+                  </a:rPr>
+                  <a:t> </a:t>
+                </a:r>
+                <a:r>
+                  <a:rPr lang="en-US" dirty="0" err="1">
+                    <a:solidFill>
+                      <a:schemeClr val="bg1"/>
+                    </a:solidFill>
+                  </a:rPr>
+                  <a:t>Vektoren</a:t>
+                </a:r>
+                <a:r>
+                  <a:rPr lang="en-US" dirty="0">
+                    <a:solidFill>
+                      <a:schemeClr val="bg1"/>
+                    </a:solidFill>
+                  </a:rPr>
+                  <a:t> </a:t>
+                </a:r>
+                <a:r>
+                  <a:rPr lang="en-US" dirty="0" err="1">
+                    <a:solidFill>
+                      <a:schemeClr val="bg1"/>
+                    </a:solidFill>
+                  </a:rPr>
+                  <a:t>unterteilen</a:t>
+                </a:r>
+                <a:r>
+                  <a:rPr lang="en-US" dirty="0">
+                    <a:solidFill>
+                      <a:schemeClr val="bg1"/>
+                    </a:solidFill>
+                  </a:rPr>
+                  <a:t>.</a:t>
+                </a:r>
+              </a:p>
+              <a:p>
+                <a:endParaRPr lang="en-US" dirty="0">
+                  <a:solidFill>
+                    <a:schemeClr val="bg1"/>
+                  </a:solidFill>
+                </a:endParaRPr>
+              </a:p>
+              <a:p>
+                <a:r>
+                  <a:rPr lang="en-US" dirty="0">
+                    <a:solidFill>
+                      <a:schemeClr val="bg1"/>
+                    </a:solidFill>
+                  </a:rPr>
+                  <a:t>Falls </a:t>
+                </a:r>
+                <a14:m>
+                  <m:oMath xmlns:m="http://schemas.openxmlformats.org/officeDocument/2006/math">
+                    <m:r>
+                      <m:rPr>
+                        <m:sty m:val="p"/>
+                      </m:rPr>
+                      <a:rPr lang="en-US" b="0" i="0" smtClean="0">
+                        <a:solidFill>
+                          <a:schemeClr val="bg1"/>
+                        </a:solidFill>
+                        <a:latin typeface="Cambria Math" panose="02040503050406030204" pitchFamily="18" charset="0"/>
+                      </a:rPr>
+                      <m:t>c</m:t>
+                    </m:r>
+                    <m:r>
+                      <a:rPr lang="en-US" b="0" i="1" smtClean="0">
+                        <a:solidFill>
+                          <a:schemeClr val="bg1"/>
+                        </a:solidFill>
+                        <a:latin typeface="Cambria Math" panose="02040503050406030204" pitchFamily="18" charset="0"/>
+                      </a:rPr>
+                      <m:t> </m:t>
+                    </m:r>
+                    <m:d>
+                      <m:dPr>
+                        <m:begChr m:val="|"/>
+                        <m:endChr m:val="|"/>
+                        <m:ctrlPr>
+                          <a:rPr lang="en-US" b="0" i="1" smtClean="0">
+                            <a:solidFill>
+                              <a:schemeClr val="bg1"/>
+                            </a:solidFill>
+                            <a:latin typeface="Cambria Math" panose="02040503050406030204" pitchFamily="18" charset="0"/>
+                          </a:rPr>
+                        </m:ctrlPr>
+                      </m:dPr>
+                      <m:e>
+                        <m:r>
+                          <m:rPr>
+                            <m:sty m:val="p"/>
+                          </m:rPr>
+                          <a:rPr lang="en-US" b="0" i="0" smtClean="0">
+                            <a:solidFill>
+                              <a:schemeClr val="bg1"/>
+                            </a:solidFill>
+                            <a:latin typeface="Cambria Math" panose="02040503050406030204" pitchFamily="18" charset="0"/>
+                          </a:rPr>
+                          <m:t>Δ</m:t>
+                        </m:r>
+                        <m:r>
+                          <a:rPr lang="en-US" b="0" i="1" smtClean="0">
+                            <a:solidFill>
+                              <a:schemeClr val="bg1"/>
+                            </a:solidFill>
+                            <a:latin typeface="Cambria Math" panose="02040503050406030204" pitchFamily="18" charset="0"/>
+                          </a:rPr>
+                          <m:t>𝑡</m:t>
+                        </m:r>
+                      </m:e>
+                    </m:d>
+                    <m:r>
+                      <a:rPr lang="en-US" b="0" i="1" smtClean="0">
+                        <a:solidFill>
+                          <a:schemeClr val="bg1"/>
+                        </a:solidFill>
+                        <a:latin typeface="Cambria Math" panose="02040503050406030204" pitchFamily="18" charset="0"/>
+                      </a:rPr>
+                      <m:t>&gt;|</m:t>
+                    </m:r>
+                    <m:r>
+                      <m:rPr>
+                        <m:sty m:val="p"/>
+                      </m:rPr>
+                      <a:rPr lang="en-US" b="0" i="0" smtClean="0">
+                        <a:solidFill>
+                          <a:schemeClr val="bg1"/>
+                        </a:solidFill>
+                        <a:latin typeface="Cambria Math" panose="02040503050406030204" pitchFamily="18" charset="0"/>
+                      </a:rPr>
+                      <m:t>Δ</m:t>
+                    </m:r>
+                    <m:r>
+                      <a:rPr lang="en-US" b="0" i="1" smtClean="0">
+                        <a:solidFill>
+                          <a:schemeClr val="bg1"/>
+                        </a:solidFill>
+                        <a:latin typeface="Cambria Math" panose="02040503050406030204" pitchFamily="18" charset="0"/>
+                      </a:rPr>
+                      <m:t>𝑧</m:t>
+                    </m:r>
+                    <m:r>
+                      <a:rPr lang="en-US" b="0" i="1" smtClean="0">
+                        <a:solidFill>
+                          <a:schemeClr val="bg1"/>
+                        </a:solidFill>
+                        <a:latin typeface="Cambria Math" panose="02040503050406030204" pitchFamily="18" charset="0"/>
+                      </a:rPr>
+                      <m:t>|</m:t>
+                    </m:r>
+                  </m:oMath>
+                </a14:m>
+                <a:r>
+                  <a:rPr lang="en-US" dirty="0">
+                    <a:solidFill>
+                      <a:schemeClr val="bg1"/>
+                    </a:solidFill>
+                  </a:rPr>
+                  <a:t> so </a:t>
+                </a:r>
+                <a:r>
+                  <a:rPr lang="en-US" dirty="0" err="1">
+                    <a:solidFill>
+                      <a:schemeClr val="bg1"/>
+                    </a:solidFill>
+                  </a:rPr>
+                  <a:t>ist</a:t>
+                </a:r>
+                <a:r>
+                  <a:rPr lang="en-US" dirty="0">
+                    <a:solidFill>
+                      <a:schemeClr val="bg1"/>
+                    </a:solidFill>
+                  </a:rPr>
+                  <a:t> es </a:t>
+                </a:r>
+                <a:r>
+                  <a:rPr lang="en-US" dirty="0" err="1">
+                    <a:solidFill>
+                      <a:schemeClr val="bg1"/>
+                    </a:solidFill>
+                  </a:rPr>
+                  <a:t>ein</a:t>
+                </a:r>
+                <a:endParaRPr lang="en-US" dirty="0">
+                  <a:solidFill>
+                    <a:schemeClr val="bg1"/>
+                  </a:solidFill>
+                </a:endParaRPr>
+              </a:p>
+              <a:p>
+                <a:r>
+                  <a:rPr lang="en-US" dirty="0" err="1">
+                    <a:solidFill>
+                      <a:schemeClr val="bg1"/>
+                    </a:solidFill>
+                  </a:rPr>
+                  <a:t>zeitartiger</a:t>
+                </a:r>
+                <a:r>
+                  <a:rPr lang="en-US" dirty="0">
+                    <a:solidFill>
+                      <a:schemeClr val="bg1"/>
+                    </a:solidFill>
+                  </a:rPr>
+                  <a:t> Vektor </a:t>
+                </a:r>
+                <a14:m>
+                  <m:oMath xmlns:m="http://schemas.openxmlformats.org/officeDocument/2006/math">
+                    <m:d>
+                      <m:dPr>
+                        <m:ctrlPr>
+                          <a:rPr lang="en-US" b="0" i="1" smtClean="0">
+                            <a:solidFill>
+                              <a:schemeClr val="bg1"/>
+                            </a:solidFill>
+                            <a:latin typeface="Cambria Math" panose="02040503050406030204" pitchFamily="18" charset="0"/>
+                          </a:rPr>
+                        </m:ctrlPr>
+                      </m:dPr>
+                      <m:e>
+                        <m:r>
+                          <m:rPr>
+                            <m:sty m:val="p"/>
+                          </m:rPr>
+                          <a:rPr lang="en-US">
+                            <a:solidFill>
+                              <a:schemeClr val="bg1"/>
+                            </a:solidFill>
+                            <a:latin typeface="Cambria Math" panose="02040503050406030204" pitchFamily="18" charset="0"/>
+                          </a:rPr>
+                          <m:t>Δ</m:t>
+                        </m:r>
+                        <m:sSup>
+                          <m:sSupPr>
+                            <m:ctrlPr>
+                              <a:rPr lang="en-US" i="1">
+                                <a:solidFill>
+                                  <a:schemeClr val="bg1"/>
+                                </a:solidFill>
+                                <a:latin typeface="Cambria Math" panose="02040503050406030204" pitchFamily="18" charset="0"/>
+                              </a:rPr>
+                            </m:ctrlPr>
+                          </m:sSupPr>
+                          <m:e>
+                            <m:r>
+                              <a:rPr lang="en-US" i="1">
+                                <a:solidFill>
+                                  <a:schemeClr val="bg1"/>
+                                </a:solidFill>
+                                <a:latin typeface="Cambria Math" panose="02040503050406030204" pitchFamily="18" charset="0"/>
+                              </a:rPr>
+                              <m:t>𝑠</m:t>
+                            </m:r>
+                          </m:e>
+                          <m:sup>
+                            <m:r>
+                              <a:rPr lang="en-US" i="1">
+                                <a:solidFill>
+                                  <a:schemeClr val="bg1"/>
+                                </a:solidFill>
+                                <a:latin typeface="Cambria Math" panose="02040503050406030204" pitchFamily="18" charset="0"/>
+                              </a:rPr>
+                              <m:t>2</m:t>
+                            </m:r>
+                          </m:sup>
+                        </m:sSup>
+                        <m:r>
+                          <a:rPr lang="en-US" i="1">
+                            <a:solidFill>
+                              <a:schemeClr val="bg1"/>
+                            </a:solidFill>
+                            <a:latin typeface="Cambria Math" panose="02040503050406030204" pitchFamily="18" charset="0"/>
+                          </a:rPr>
+                          <m:t>&gt;0</m:t>
+                        </m:r>
+                      </m:e>
+                    </m:d>
+                  </m:oMath>
+                </a14:m>
+                <a:endParaRPr lang="en-US" dirty="0">
+                  <a:solidFill>
+                    <a:schemeClr val="bg1"/>
+                  </a:solidFill>
+                </a:endParaRPr>
+              </a:p>
+              <a:p>
+                <a:endParaRPr lang="en-US" dirty="0">
+                  <a:solidFill>
+                    <a:schemeClr val="bg1"/>
+                  </a:solidFill>
+                </a:endParaRPr>
+              </a:p>
+              <a:p>
+                <a:r>
+                  <a:rPr lang="en-US" dirty="0" err="1">
+                    <a:solidFill>
+                      <a:schemeClr val="bg1"/>
+                    </a:solidFill>
+                  </a:rPr>
+                  <a:t>Diese</a:t>
+                </a:r>
+                <a:r>
+                  <a:rPr lang="en-US" dirty="0">
+                    <a:solidFill>
+                      <a:schemeClr val="bg1"/>
+                    </a:solidFill>
+                  </a:rPr>
+                  <a:t> </a:t>
+                </a:r>
+                <a:r>
+                  <a:rPr lang="en-US" dirty="0" err="1">
+                    <a:solidFill>
+                      <a:schemeClr val="bg1"/>
+                    </a:solidFill>
+                  </a:rPr>
+                  <a:t>liegen</a:t>
+                </a:r>
+                <a:r>
+                  <a:rPr lang="en-US" dirty="0">
+                    <a:solidFill>
+                      <a:schemeClr val="bg1"/>
+                    </a:solidFill>
+                  </a:rPr>
+                  <a:t> in der Zukunft </a:t>
+                </a:r>
+                <a:r>
+                  <a:rPr lang="en-US" dirty="0" err="1">
+                    <a:solidFill>
+                      <a:schemeClr val="bg1"/>
+                    </a:solidFill>
+                  </a:rPr>
+                  <a:t>oder</a:t>
+                </a:r>
+                <a:r>
+                  <a:rPr lang="en-US" dirty="0">
+                    <a:solidFill>
+                      <a:schemeClr val="bg1"/>
+                    </a:solidFill>
+                  </a:rPr>
+                  <a:t> der </a:t>
+                </a:r>
+                <a:r>
+                  <a:rPr lang="en-US" dirty="0" err="1">
+                    <a:solidFill>
+                      <a:schemeClr val="bg1"/>
+                    </a:solidFill>
+                  </a:rPr>
+                  <a:t>Vergangenheit</a:t>
+                </a:r>
+                <a:r>
+                  <a:rPr lang="en-US" dirty="0">
+                    <a:solidFill>
+                      <a:schemeClr val="bg1"/>
+                    </a:solidFill>
+                  </a:rPr>
+                  <a:t> und </a:t>
+                </a:r>
+                <a:r>
+                  <a:rPr lang="en-US" dirty="0" err="1">
+                    <a:solidFill>
+                      <a:schemeClr val="bg1"/>
+                    </a:solidFill>
+                  </a:rPr>
+                  <a:t>können</a:t>
+                </a:r>
+                <a:r>
+                  <a:rPr lang="en-US" dirty="0">
+                    <a:solidFill>
+                      <a:schemeClr val="bg1"/>
+                    </a:solidFill>
+                  </a:rPr>
+                  <a:t> </a:t>
+                </a:r>
+                <a:r>
+                  <a:rPr lang="en-US" dirty="0" err="1">
+                    <a:solidFill>
+                      <a:schemeClr val="bg1"/>
+                    </a:solidFill>
+                  </a:rPr>
+                  <a:t>beeinflusst</a:t>
+                </a:r>
+                <a:r>
+                  <a:rPr lang="en-US" dirty="0">
+                    <a:solidFill>
+                      <a:schemeClr val="bg1"/>
+                    </a:solidFill>
+                  </a:rPr>
+                  <a:t> </a:t>
+                </a:r>
+                <a:r>
+                  <a:rPr lang="en-US" dirty="0" err="1">
+                    <a:solidFill>
+                      <a:schemeClr val="bg1"/>
+                    </a:solidFill>
+                  </a:rPr>
+                  <a:t>werden</a:t>
+                </a:r>
+                <a:endParaRPr lang="en-US" dirty="0">
+                  <a:solidFill>
+                    <a:schemeClr val="bg1"/>
+                  </a:solidFill>
+                </a:endParaRPr>
+              </a:p>
+            </p:txBody>
+          </p:sp>
+        </mc:Choice>
+        <mc:Fallback>
+          <p:sp>
+            <p:nvSpPr>
+              <p:cNvPr id="2" name="TextBox 1">
+                <a:extLst>
+                  <a:ext uri="{FF2B5EF4-FFF2-40B4-BE49-F238E27FC236}">
+                    <a16:creationId xmlns:a16="http://schemas.microsoft.com/office/drawing/2014/main" id="{FF0478EB-DE3B-0BA7-447C-A94ADD0B44AF}"/>
+                  </a:ext>
+                </a:extLst>
+              </p:cNvPr>
+              <p:cNvSpPr txBox="1">
+                <a:spLocks noRot="1" noChangeAspect="1" noMove="1" noResize="1" noEditPoints="1" noAdjustHandles="1" noChangeArrowheads="1" noChangeShapeType="1" noTextEdit="1"/>
+              </p:cNvSpPr>
+              <p:nvPr/>
+            </p:nvSpPr>
+            <p:spPr>
+              <a:xfrm>
+                <a:off x="8547652" y="153348"/>
+                <a:ext cx="3475855" cy="3970318"/>
+              </a:xfrm>
+              <a:prstGeom prst="rect">
+                <a:avLst/>
+              </a:prstGeom>
+              <a:blipFill>
+                <a:blip r:embed="rId3"/>
+                <a:stretch>
+                  <a:fillRect l="-1404" t="-768" b="-1536"/>
+                </a:stretch>
+              </a:blipFill>
+            </p:spPr>
+            <p:txBody>
+              <a:bodyPr/>
+              <a:lstStyle/>
+              <a:p>
+                <a:r>
+                  <a:rPr lang="en-CH">
+                    <a:noFill/>
+                  </a:rPr>
+                  <a:t> </a:t>
+                </a:r>
+              </a:p>
+            </p:txBody>
+          </p:sp>
+        </mc:Fallback>
+      </mc:AlternateContent>
+    </p:spTree>
+    <p:extLst>
+      <p:ext uri="{BB962C8B-B14F-4D97-AF65-F5344CB8AC3E}">
+        <p14:creationId xmlns:p14="http://schemas.microsoft.com/office/powerpoint/2010/main" val="2731311529"/>
+      </p:ext>
+    </p:extLst>
+  </p:cSld>
+  <p:clrMapOvr>
+    <a:masterClrMapping/>
+  </p:clrMapOvr>
+</p:sld>
+</file>
+
+<file path=ppt/slides/slide15.xml><?xml version="1.0" encoding="utf-8"?>
+<p:sld xmlns:a="http://schemas.openxmlformats.org/drawingml/2006/main" xmlns:r="http://schemas.openxmlformats.org/officeDocument/2006/relationships" xmlns:p="http://schemas.openxmlformats.org/presentationml/2006/main">
+  <p:cSld>
+    <p:spTree>
+      <p:nvGrpSpPr>
+        <p:cNvPr id="1" name="">
+          <a:extLst>
+            <a:ext uri="{FF2B5EF4-FFF2-40B4-BE49-F238E27FC236}">
+              <a16:creationId xmlns:a16="http://schemas.microsoft.com/office/drawing/2014/main" id="{5608AEE6-5D23-2B62-BDD5-AB1A3B1E4CF1}"/>
+            </a:ext>
+          </a:extLst>
+        </p:cNvPr>
+        <p:cNvGrpSpPr/>
+        <p:nvPr/>
+      </p:nvGrpSpPr>
+      <p:grpSpPr>
+        <a:xfrm>
+          <a:off x="0" y="0"/>
+          <a:ext cx="0" cy="0"/>
+          <a:chOff x="0" y="0"/>
+          <a:chExt cx="0" cy="0"/>
+        </a:xfrm>
+      </p:grpSpPr>
+      <p:pic>
+        <p:nvPicPr>
+          <p:cNvPr id="4" name="Content Placeholder 3">
+            <a:extLst>
+              <a:ext uri="{FF2B5EF4-FFF2-40B4-BE49-F238E27FC236}">
+                <a16:creationId xmlns:a16="http://schemas.microsoft.com/office/drawing/2014/main" id="{47CBB087-56D6-CFD6-C696-B79B53B935CE}"/>
+              </a:ext>
+            </a:extLst>
+          </p:cNvPr>
+          <p:cNvPicPr>
+            <a:picLocks noGrp="1" noChangeAspect="1"/>
+          </p:cNvPicPr>
+          <p:nvPr>
+            <p:ph idx="1"/>
+          </p:nvPr>
+        </p:nvPicPr>
+        <p:blipFill>
+          <a:blip r:link="rId2"/>
+          <a:srcRect/>
+          <a:stretch>
+            <a:fillRect/>
+          </a:stretch>
+        </p:blipFill>
+        <p:spPr>
+          <a:xfrm>
+            <a:off x="439948" y="-422692"/>
+            <a:ext cx="7556740" cy="7556740"/>
+          </a:xfrm>
+        </p:spPr>
+      </p:pic>
+      <mc:AlternateContent xmlns:mc="http://schemas.openxmlformats.org/markup-compatibility/2006">
+        <mc:Choice xmlns:a14="http://schemas.microsoft.com/office/drawing/2010/main" Requires="a14">
+          <p:sp>
+            <p:nvSpPr>
+              <p:cNvPr id="2" name="TextBox 1">
+                <a:extLst>
+                  <a:ext uri="{FF2B5EF4-FFF2-40B4-BE49-F238E27FC236}">
+                    <a16:creationId xmlns:a16="http://schemas.microsoft.com/office/drawing/2014/main" id="{F0EA46D7-D23D-2740-10E1-B7751F23036B}"/>
+                  </a:ext>
+                </a:extLst>
+              </p:cNvPr>
+              <p:cNvSpPr txBox="1"/>
+              <p:nvPr/>
+            </p:nvSpPr>
+            <p:spPr>
+              <a:xfrm>
+                <a:off x="8547652" y="153348"/>
+                <a:ext cx="3475855" cy="6186309"/>
+              </a:xfrm>
+              <a:prstGeom prst="rect">
+                <a:avLst/>
+              </a:prstGeom>
+              <a:noFill/>
+            </p:spPr>
+            <p:txBody>
+              <a:bodyPr wrap="square" rtlCol="0">
+                <a:spAutoFit/>
+              </a:bodyPr>
+              <a:lstStyle/>
+              <a:p>
+                <a:r>
+                  <a:rPr lang="en-US" dirty="0">
+                    <a:solidFill>
+                      <a:schemeClr val="bg1"/>
+                    </a:solidFill>
+                  </a:rPr>
+                  <a:t>Bei Licht gilt </a:t>
+                </a:r>
+                <a14:m>
+                  <m:oMath xmlns:m="http://schemas.openxmlformats.org/officeDocument/2006/math">
+                    <m:r>
+                      <m:rPr>
+                        <m:sty m:val="p"/>
+                      </m:rPr>
+                      <a:rPr lang="en-US" b="0" i="0" smtClean="0">
+                        <a:solidFill>
+                          <a:schemeClr val="bg1"/>
+                        </a:solidFill>
+                        <a:latin typeface="Cambria Math" panose="02040503050406030204" pitchFamily="18" charset="0"/>
+                      </a:rPr>
+                      <m:t>Δ</m:t>
+                    </m:r>
+                    <m:r>
+                      <a:rPr lang="en-US" b="0" i="1" smtClean="0">
+                        <a:solidFill>
+                          <a:schemeClr val="bg1"/>
+                        </a:solidFill>
+                        <a:latin typeface="Cambria Math" panose="02040503050406030204" pitchFamily="18" charset="0"/>
+                      </a:rPr>
+                      <m:t>𝑧</m:t>
+                    </m:r>
+                    <m:r>
+                      <a:rPr lang="en-US" b="0" i="1" smtClean="0">
+                        <a:solidFill>
+                          <a:schemeClr val="bg1"/>
+                        </a:solidFill>
+                        <a:latin typeface="Cambria Math" panose="02040503050406030204" pitchFamily="18" charset="0"/>
+                      </a:rPr>
+                      <m:t>=</m:t>
+                    </m:r>
+                    <m:r>
+                      <m:rPr>
+                        <m:nor/>
+                      </m:rPr>
+                      <a:rPr lang="en-US" dirty="0">
+                        <a:solidFill>
+                          <a:schemeClr val="bg1"/>
+                        </a:solidFill>
+                      </a:rPr>
+                      <m:t>c</m:t>
+                    </m:r>
+                    <m:r>
+                      <m:rPr>
+                        <m:sty m:val="p"/>
+                      </m:rPr>
+                      <a:rPr lang="en-US">
+                        <a:solidFill>
+                          <a:schemeClr val="bg1"/>
+                        </a:solidFill>
+                        <a:latin typeface="Cambria Math" panose="02040503050406030204" pitchFamily="18" charset="0"/>
+                      </a:rPr>
+                      <m:t>Δ</m:t>
+                    </m:r>
+                    <m:r>
+                      <a:rPr lang="en-US" i="1">
+                        <a:solidFill>
+                          <a:schemeClr val="bg1"/>
+                        </a:solidFill>
+                        <a:latin typeface="Cambria Math" panose="02040503050406030204" pitchFamily="18" charset="0"/>
+                      </a:rPr>
+                      <m:t>𝑡</m:t>
+                    </m:r>
+                  </m:oMath>
+                </a14:m>
+                <a:endParaRPr lang="en-US" dirty="0">
+                  <a:solidFill>
+                    <a:schemeClr val="bg1"/>
+                  </a:solidFill>
+                </a:endParaRPr>
+              </a:p>
+              <a:p>
+                <a:endParaRPr lang="en-US" dirty="0">
+                  <a:solidFill>
+                    <a:schemeClr val="bg1"/>
+                  </a:solidFill>
+                </a:endParaRPr>
+              </a:p>
+              <a:p>
+                <a:r>
+                  <a:rPr lang="en-US" dirty="0" err="1">
+                    <a:solidFill>
+                      <a:schemeClr val="bg1"/>
+                    </a:solidFill>
+                  </a:rPr>
+                  <a:t>Dadurch</a:t>
+                </a:r>
+                <a:r>
+                  <a:rPr lang="en-US" dirty="0">
+                    <a:solidFill>
+                      <a:schemeClr val="bg1"/>
+                    </a:solidFill>
+                  </a:rPr>
+                  <a:t> </a:t>
+                </a:r>
+                <a:r>
+                  <a:rPr lang="en-US" dirty="0" err="1">
+                    <a:solidFill>
+                      <a:schemeClr val="bg1"/>
+                    </a:solidFill>
+                  </a:rPr>
+                  <a:t>entstehen</a:t>
+                </a:r>
+                <a:r>
+                  <a:rPr lang="en-US" dirty="0">
+                    <a:solidFill>
+                      <a:schemeClr val="bg1"/>
+                    </a:solidFill>
+                  </a:rPr>
+                  <a:t> </a:t>
+                </a:r>
+                <a:r>
+                  <a:rPr lang="en-US" dirty="0" err="1">
+                    <a:solidFill>
+                      <a:schemeClr val="bg1"/>
+                    </a:solidFill>
+                  </a:rPr>
+                  <a:t>Diagonalen</a:t>
+                </a:r>
+                <a:r>
+                  <a:rPr lang="en-US" dirty="0">
+                    <a:solidFill>
+                      <a:schemeClr val="bg1"/>
+                    </a:solidFill>
+                  </a:rPr>
+                  <a:t> </a:t>
+                </a:r>
+                <a:r>
+                  <a:rPr lang="en-US" dirty="0" err="1">
+                    <a:solidFill>
+                      <a:schemeClr val="bg1"/>
+                    </a:solidFill>
+                  </a:rPr>
+                  <a:t>im</a:t>
+                </a:r>
+                <a:r>
+                  <a:rPr lang="en-US" dirty="0">
+                    <a:solidFill>
+                      <a:schemeClr val="bg1"/>
+                    </a:solidFill>
+                  </a:rPr>
+                  <a:t> Minkowski-</a:t>
+                </a:r>
+                <a:r>
+                  <a:rPr lang="en-US" dirty="0" err="1">
+                    <a:solidFill>
+                      <a:schemeClr val="bg1"/>
+                    </a:solidFill>
+                  </a:rPr>
+                  <a:t>Diagramm</a:t>
+                </a:r>
+                <a:endParaRPr lang="en-US" dirty="0">
+                  <a:solidFill>
+                    <a:schemeClr val="bg1"/>
+                  </a:solidFill>
+                </a:endParaRPr>
+              </a:p>
+              <a:p>
+                <a:endParaRPr lang="en-US" dirty="0">
+                  <a:solidFill>
+                    <a:schemeClr val="bg1"/>
+                  </a:solidFill>
+                </a:endParaRPr>
+              </a:p>
+              <a:p>
+                <a:r>
+                  <a:rPr lang="en-US" dirty="0">
+                    <a:solidFill>
+                      <a:schemeClr val="bg1"/>
+                    </a:solidFill>
+                  </a:rPr>
+                  <a:t>Wir </a:t>
+                </a:r>
+                <a:r>
+                  <a:rPr lang="en-US" dirty="0" err="1">
+                    <a:solidFill>
+                      <a:schemeClr val="bg1"/>
+                    </a:solidFill>
+                  </a:rPr>
+                  <a:t>können</a:t>
+                </a:r>
+                <a:r>
+                  <a:rPr lang="en-US" dirty="0">
+                    <a:solidFill>
+                      <a:schemeClr val="bg1"/>
+                    </a:solidFill>
+                  </a:rPr>
+                  <a:t> in </a:t>
+                </a:r>
+                <a:r>
+                  <a:rPr lang="en-US" dirty="0" err="1">
+                    <a:solidFill>
+                      <a:schemeClr val="bg1"/>
+                    </a:solidFill>
+                  </a:rPr>
+                  <a:t>zeitartige</a:t>
+                </a:r>
+                <a:r>
+                  <a:rPr lang="en-US" dirty="0">
+                    <a:solidFill>
+                      <a:schemeClr val="bg1"/>
+                    </a:solidFill>
+                  </a:rPr>
+                  <a:t> und </a:t>
+                </a:r>
+                <a:r>
+                  <a:rPr lang="en-US" dirty="0" err="1">
+                    <a:solidFill>
+                      <a:schemeClr val="bg1"/>
+                    </a:solidFill>
+                  </a:rPr>
+                  <a:t>raumsartige</a:t>
+                </a:r>
+                <a:r>
+                  <a:rPr lang="en-US" dirty="0">
+                    <a:solidFill>
+                      <a:schemeClr val="bg1"/>
+                    </a:solidFill>
+                  </a:rPr>
+                  <a:t> </a:t>
+                </a:r>
+                <a:r>
+                  <a:rPr lang="en-US" dirty="0" err="1">
+                    <a:solidFill>
+                      <a:schemeClr val="bg1"/>
+                    </a:solidFill>
+                  </a:rPr>
+                  <a:t>Vektoren</a:t>
+                </a:r>
+                <a:r>
+                  <a:rPr lang="en-US" dirty="0">
+                    <a:solidFill>
+                      <a:schemeClr val="bg1"/>
+                    </a:solidFill>
+                  </a:rPr>
+                  <a:t> </a:t>
+                </a:r>
+                <a:r>
+                  <a:rPr lang="en-US" dirty="0" err="1">
+                    <a:solidFill>
+                      <a:schemeClr val="bg1"/>
+                    </a:solidFill>
+                  </a:rPr>
+                  <a:t>unterteilen</a:t>
+                </a:r>
+                <a:r>
+                  <a:rPr lang="en-US" dirty="0">
+                    <a:solidFill>
+                      <a:schemeClr val="bg1"/>
+                    </a:solidFill>
+                  </a:rPr>
+                  <a:t>.</a:t>
+                </a:r>
+              </a:p>
+              <a:p>
+                <a:endParaRPr lang="en-US" dirty="0">
+                  <a:solidFill>
+                    <a:schemeClr val="bg1"/>
+                  </a:solidFill>
+                </a:endParaRPr>
+              </a:p>
+              <a:p>
+                <a:r>
+                  <a:rPr lang="en-US" dirty="0">
+                    <a:solidFill>
+                      <a:schemeClr val="bg1"/>
+                    </a:solidFill>
+                  </a:rPr>
+                  <a:t>Falls </a:t>
+                </a:r>
+                <a14:m>
+                  <m:oMath xmlns:m="http://schemas.openxmlformats.org/officeDocument/2006/math">
+                    <m:r>
+                      <m:rPr>
+                        <m:sty m:val="p"/>
+                      </m:rPr>
+                      <a:rPr lang="en-US" b="0" i="0" smtClean="0">
+                        <a:solidFill>
+                          <a:schemeClr val="bg1"/>
+                        </a:solidFill>
+                        <a:latin typeface="Cambria Math" panose="02040503050406030204" pitchFamily="18" charset="0"/>
+                      </a:rPr>
+                      <m:t>c</m:t>
+                    </m:r>
+                    <m:r>
+                      <a:rPr lang="en-US" b="0" i="1" smtClean="0">
+                        <a:solidFill>
+                          <a:schemeClr val="bg1"/>
+                        </a:solidFill>
+                        <a:latin typeface="Cambria Math" panose="02040503050406030204" pitchFamily="18" charset="0"/>
+                      </a:rPr>
+                      <m:t> </m:t>
+                    </m:r>
+                    <m:d>
+                      <m:dPr>
+                        <m:begChr m:val="|"/>
+                        <m:endChr m:val="|"/>
+                        <m:ctrlPr>
+                          <a:rPr lang="en-US" b="0" i="1" smtClean="0">
+                            <a:solidFill>
+                              <a:schemeClr val="bg1"/>
+                            </a:solidFill>
+                            <a:latin typeface="Cambria Math" panose="02040503050406030204" pitchFamily="18" charset="0"/>
+                          </a:rPr>
+                        </m:ctrlPr>
+                      </m:dPr>
+                      <m:e>
+                        <m:r>
+                          <m:rPr>
+                            <m:sty m:val="p"/>
+                          </m:rPr>
+                          <a:rPr lang="en-US" b="0" i="0" smtClean="0">
+                            <a:solidFill>
+                              <a:schemeClr val="bg1"/>
+                            </a:solidFill>
+                            <a:latin typeface="Cambria Math" panose="02040503050406030204" pitchFamily="18" charset="0"/>
+                          </a:rPr>
+                          <m:t>Δ</m:t>
+                        </m:r>
+                        <m:r>
+                          <a:rPr lang="en-US" b="0" i="1" smtClean="0">
+                            <a:solidFill>
+                              <a:schemeClr val="bg1"/>
+                            </a:solidFill>
+                            <a:latin typeface="Cambria Math" panose="02040503050406030204" pitchFamily="18" charset="0"/>
+                          </a:rPr>
+                          <m:t>𝑡</m:t>
+                        </m:r>
+                      </m:e>
+                    </m:d>
+                    <m:r>
+                      <a:rPr lang="en-US" b="0" i="1" smtClean="0">
+                        <a:solidFill>
+                          <a:schemeClr val="bg1"/>
+                        </a:solidFill>
+                        <a:latin typeface="Cambria Math" panose="02040503050406030204" pitchFamily="18" charset="0"/>
+                      </a:rPr>
+                      <m:t>&gt;|</m:t>
+                    </m:r>
+                    <m:r>
+                      <m:rPr>
+                        <m:sty m:val="p"/>
+                      </m:rPr>
+                      <a:rPr lang="en-US" b="0" i="0" smtClean="0">
+                        <a:solidFill>
+                          <a:schemeClr val="bg1"/>
+                        </a:solidFill>
+                        <a:latin typeface="Cambria Math" panose="02040503050406030204" pitchFamily="18" charset="0"/>
+                      </a:rPr>
+                      <m:t>Δ</m:t>
+                    </m:r>
+                    <m:r>
+                      <a:rPr lang="en-US" b="0" i="1" smtClean="0">
+                        <a:solidFill>
+                          <a:schemeClr val="bg1"/>
+                        </a:solidFill>
+                        <a:latin typeface="Cambria Math" panose="02040503050406030204" pitchFamily="18" charset="0"/>
+                      </a:rPr>
+                      <m:t>𝑧</m:t>
+                    </m:r>
+                    <m:r>
+                      <a:rPr lang="en-US" b="0" i="1" smtClean="0">
+                        <a:solidFill>
+                          <a:schemeClr val="bg1"/>
+                        </a:solidFill>
+                        <a:latin typeface="Cambria Math" panose="02040503050406030204" pitchFamily="18" charset="0"/>
+                      </a:rPr>
+                      <m:t>|</m:t>
+                    </m:r>
+                  </m:oMath>
+                </a14:m>
+                <a:r>
+                  <a:rPr lang="en-US" dirty="0">
+                    <a:solidFill>
+                      <a:schemeClr val="bg1"/>
+                    </a:solidFill>
+                  </a:rPr>
+                  <a:t> so </a:t>
+                </a:r>
+                <a:r>
+                  <a:rPr lang="en-US" dirty="0" err="1">
+                    <a:solidFill>
+                      <a:schemeClr val="bg1"/>
+                    </a:solidFill>
+                  </a:rPr>
+                  <a:t>ist</a:t>
+                </a:r>
+                <a:r>
+                  <a:rPr lang="en-US" dirty="0">
+                    <a:solidFill>
+                      <a:schemeClr val="bg1"/>
+                    </a:solidFill>
+                  </a:rPr>
+                  <a:t> es </a:t>
+                </a:r>
+                <a:r>
+                  <a:rPr lang="en-US" dirty="0" err="1">
+                    <a:solidFill>
+                      <a:schemeClr val="bg1"/>
+                    </a:solidFill>
+                  </a:rPr>
+                  <a:t>ein</a:t>
+                </a:r>
+                <a:endParaRPr lang="en-US" dirty="0">
+                  <a:solidFill>
+                    <a:schemeClr val="bg1"/>
+                  </a:solidFill>
+                </a:endParaRPr>
+              </a:p>
+              <a:p>
+                <a:r>
+                  <a:rPr lang="en-US" dirty="0" err="1">
+                    <a:solidFill>
+                      <a:schemeClr val="bg1"/>
+                    </a:solidFill>
+                  </a:rPr>
+                  <a:t>zeitartiger</a:t>
+                </a:r>
+                <a:r>
+                  <a:rPr lang="en-US" dirty="0">
+                    <a:solidFill>
+                      <a:schemeClr val="bg1"/>
+                    </a:solidFill>
+                  </a:rPr>
+                  <a:t> Vektor </a:t>
+                </a:r>
+                <a14:m>
+                  <m:oMath xmlns:m="http://schemas.openxmlformats.org/officeDocument/2006/math">
+                    <m:d>
+                      <m:dPr>
+                        <m:ctrlPr>
+                          <a:rPr lang="en-US" b="0" i="1" smtClean="0">
+                            <a:solidFill>
+                              <a:schemeClr val="bg1"/>
+                            </a:solidFill>
+                            <a:latin typeface="Cambria Math" panose="02040503050406030204" pitchFamily="18" charset="0"/>
+                          </a:rPr>
+                        </m:ctrlPr>
+                      </m:dPr>
+                      <m:e>
+                        <m:r>
+                          <m:rPr>
+                            <m:sty m:val="p"/>
+                          </m:rPr>
+                          <a:rPr lang="en-US">
+                            <a:solidFill>
+                              <a:schemeClr val="bg1"/>
+                            </a:solidFill>
+                            <a:latin typeface="Cambria Math" panose="02040503050406030204" pitchFamily="18" charset="0"/>
+                          </a:rPr>
+                          <m:t>Δ</m:t>
+                        </m:r>
+                        <m:sSup>
+                          <m:sSupPr>
+                            <m:ctrlPr>
+                              <a:rPr lang="en-US" i="1">
+                                <a:solidFill>
+                                  <a:schemeClr val="bg1"/>
+                                </a:solidFill>
+                                <a:latin typeface="Cambria Math" panose="02040503050406030204" pitchFamily="18" charset="0"/>
+                              </a:rPr>
+                            </m:ctrlPr>
+                          </m:sSupPr>
+                          <m:e>
+                            <m:r>
+                              <a:rPr lang="en-US" i="1">
+                                <a:solidFill>
+                                  <a:schemeClr val="bg1"/>
+                                </a:solidFill>
+                                <a:latin typeface="Cambria Math" panose="02040503050406030204" pitchFamily="18" charset="0"/>
+                              </a:rPr>
+                              <m:t>𝑠</m:t>
+                            </m:r>
+                          </m:e>
+                          <m:sup>
+                            <m:r>
+                              <a:rPr lang="en-US" i="1">
+                                <a:solidFill>
+                                  <a:schemeClr val="bg1"/>
+                                </a:solidFill>
+                                <a:latin typeface="Cambria Math" panose="02040503050406030204" pitchFamily="18" charset="0"/>
+                              </a:rPr>
+                              <m:t>2</m:t>
+                            </m:r>
+                          </m:sup>
+                        </m:sSup>
+                        <m:r>
+                          <a:rPr lang="en-US" i="1">
+                            <a:solidFill>
+                              <a:schemeClr val="bg1"/>
+                            </a:solidFill>
+                            <a:latin typeface="Cambria Math" panose="02040503050406030204" pitchFamily="18" charset="0"/>
+                          </a:rPr>
+                          <m:t>&gt;0</m:t>
+                        </m:r>
+                      </m:e>
+                    </m:d>
+                  </m:oMath>
+                </a14:m>
+                <a:endParaRPr lang="en-US" dirty="0">
+                  <a:solidFill>
+                    <a:schemeClr val="bg1"/>
+                  </a:solidFill>
+                </a:endParaRPr>
+              </a:p>
+              <a:p>
+                <a:endParaRPr lang="en-US" dirty="0">
+                  <a:solidFill>
+                    <a:schemeClr val="bg1"/>
+                  </a:solidFill>
+                </a:endParaRPr>
+              </a:p>
+              <a:p>
+                <a:r>
+                  <a:rPr lang="en-US" dirty="0" err="1">
+                    <a:solidFill>
+                      <a:schemeClr val="bg1"/>
+                    </a:solidFill>
+                  </a:rPr>
+                  <a:t>Diese</a:t>
+                </a:r>
+                <a:r>
+                  <a:rPr lang="en-US" dirty="0">
+                    <a:solidFill>
+                      <a:schemeClr val="bg1"/>
+                    </a:solidFill>
+                  </a:rPr>
+                  <a:t> </a:t>
+                </a:r>
+                <a:r>
+                  <a:rPr lang="en-US" dirty="0" err="1">
+                    <a:solidFill>
+                      <a:schemeClr val="bg1"/>
+                    </a:solidFill>
+                  </a:rPr>
+                  <a:t>liegen</a:t>
+                </a:r>
+                <a:r>
+                  <a:rPr lang="en-US" dirty="0">
+                    <a:solidFill>
+                      <a:schemeClr val="bg1"/>
+                    </a:solidFill>
+                  </a:rPr>
+                  <a:t> in der Zukunft </a:t>
+                </a:r>
+                <a:r>
+                  <a:rPr lang="en-US" dirty="0" err="1">
+                    <a:solidFill>
+                      <a:schemeClr val="bg1"/>
+                    </a:solidFill>
+                  </a:rPr>
+                  <a:t>oder</a:t>
+                </a:r>
+                <a:r>
+                  <a:rPr lang="en-US" dirty="0">
+                    <a:solidFill>
+                      <a:schemeClr val="bg1"/>
+                    </a:solidFill>
+                  </a:rPr>
+                  <a:t> der </a:t>
+                </a:r>
+                <a:r>
+                  <a:rPr lang="en-US" dirty="0" err="1">
+                    <a:solidFill>
+                      <a:schemeClr val="bg1"/>
+                    </a:solidFill>
+                  </a:rPr>
+                  <a:t>Vergangenheit</a:t>
+                </a:r>
+                <a:r>
+                  <a:rPr lang="en-US" dirty="0">
+                    <a:solidFill>
+                      <a:schemeClr val="bg1"/>
+                    </a:solidFill>
+                  </a:rPr>
+                  <a:t> und </a:t>
+                </a:r>
+                <a:r>
+                  <a:rPr lang="en-US" dirty="0" err="1">
+                    <a:solidFill>
+                      <a:schemeClr val="bg1"/>
+                    </a:solidFill>
+                  </a:rPr>
+                  <a:t>können</a:t>
+                </a:r>
+                <a:r>
+                  <a:rPr lang="en-US" dirty="0">
+                    <a:solidFill>
+                      <a:schemeClr val="bg1"/>
+                    </a:solidFill>
+                  </a:rPr>
+                  <a:t> </a:t>
+                </a:r>
+                <a:r>
+                  <a:rPr lang="en-US" dirty="0" err="1">
+                    <a:solidFill>
+                      <a:schemeClr val="bg1"/>
+                    </a:solidFill>
+                  </a:rPr>
+                  <a:t>beeinflusst</a:t>
+                </a:r>
+                <a:r>
+                  <a:rPr lang="en-US" dirty="0">
+                    <a:solidFill>
+                      <a:schemeClr val="bg1"/>
+                    </a:solidFill>
+                  </a:rPr>
+                  <a:t> </a:t>
+                </a:r>
+                <a:r>
+                  <a:rPr lang="en-US" dirty="0" err="1">
+                    <a:solidFill>
+                      <a:schemeClr val="bg1"/>
+                    </a:solidFill>
+                  </a:rPr>
+                  <a:t>werden</a:t>
+                </a:r>
+                <a:r>
+                  <a:rPr lang="en-US" dirty="0">
+                    <a:solidFill>
+                      <a:schemeClr val="bg1"/>
+                    </a:solidFill>
+                  </a:rPr>
+                  <a:t>.</a:t>
+                </a:r>
+              </a:p>
+              <a:p>
+                <a:endParaRPr lang="en-US" dirty="0">
+                  <a:solidFill>
+                    <a:schemeClr val="bg1"/>
+                  </a:solidFill>
+                </a:endParaRPr>
+              </a:p>
+              <a:p>
+                <a:r>
+                  <a:rPr lang="en-US" dirty="0">
+                    <a:solidFill>
+                      <a:schemeClr val="bg1"/>
+                    </a:solidFill>
+                  </a:rPr>
+                  <a:t>Falls </a:t>
+                </a:r>
+                <a14:m>
+                  <m:oMath xmlns:m="http://schemas.openxmlformats.org/officeDocument/2006/math">
+                    <m:r>
+                      <m:rPr>
+                        <m:sty m:val="p"/>
+                      </m:rPr>
+                      <a:rPr lang="en-US" b="0" i="0" smtClean="0">
+                        <a:solidFill>
+                          <a:schemeClr val="bg1"/>
+                        </a:solidFill>
+                        <a:latin typeface="Cambria Math" panose="02040503050406030204" pitchFamily="18" charset="0"/>
+                      </a:rPr>
+                      <m:t>c</m:t>
+                    </m:r>
+                    <m:r>
+                      <a:rPr lang="en-US" b="0" i="1" smtClean="0">
+                        <a:solidFill>
+                          <a:schemeClr val="bg1"/>
+                        </a:solidFill>
+                        <a:latin typeface="Cambria Math" panose="02040503050406030204" pitchFamily="18" charset="0"/>
+                      </a:rPr>
+                      <m:t> </m:t>
+                    </m:r>
+                    <m:d>
+                      <m:dPr>
+                        <m:begChr m:val="|"/>
+                        <m:endChr m:val="|"/>
+                        <m:ctrlPr>
+                          <a:rPr lang="en-US" b="0" i="1" smtClean="0">
+                            <a:solidFill>
+                              <a:schemeClr val="bg1"/>
+                            </a:solidFill>
+                            <a:latin typeface="Cambria Math" panose="02040503050406030204" pitchFamily="18" charset="0"/>
+                          </a:rPr>
+                        </m:ctrlPr>
+                      </m:dPr>
+                      <m:e>
+                        <m:r>
+                          <m:rPr>
+                            <m:sty m:val="p"/>
+                          </m:rPr>
+                          <a:rPr lang="en-US" b="0" i="0" smtClean="0">
+                            <a:solidFill>
+                              <a:schemeClr val="bg1"/>
+                            </a:solidFill>
+                            <a:latin typeface="Cambria Math" panose="02040503050406030204" pitchFamily="18" charset="0"/>
+                          </a:rPr>
+                          <m:t>Δ</m:t>
+                        </m:r>
+                        <m:r>
+                          <a:rPr lang="en-US" b="0" i="1" smtClean="0">
+                            <a:solidFill>
+                              <a:schemeClr val="bg1"/>
+                            </a:solidFill>
+                            <a:latin typeface="Cambria Math" panose="02040503050406030204" pitchFamily="18" charset="0"/>
+                          </a:rPr>
+                          <m:t>𝑡</m:t>
+                        </m:r>
+                      </m:e>
+                    </m:d>
+                    <m:r>
+                      <a:rPr lang="en-US" b="0" i="1" smtClean="0">
+                        <a:solidFill>
+                          <a:schemeClr val="bg1"/>
+                        </a:solidFill>
+                        <a:latin typeface="Cambria Math" panose="02040503050406030204" pitchFamily="18" charset="0"/>
+                      </a:rPr>
+                      <m:t>&lt;</m:t>
+                    </m:r>
+                    <m:r>
+                      <a:rPr lang="en-US" b="0" i="1" smtClean="0">
+                        <a:solidFill>
+                          <a:schemeClr val="bg1"/>
+                        </a:solidFill>
+                        <a:latin typeface="Cambria Math" panose="02040503050406030204" pitchFamily="18" charset="0"/>
+                      </a:rPr>
+                      <m:t>|</m:t>
+                    </m:r>
+                    <m:r>
+                      <m:rPr>
+                        <m:sty m:val="p"/>
+                      </m:rPr>
+                      <a:rPr lang="en-US" b="0" i="0" smtClean="0">
+                        <a:solidFill>
+                          <a:schemeClr val="bg1"/>
+                        </a:solidFill>
+                        <a:latin typeface="Cambria Math" panose="02040503050406030204" pitchFamily="18" charset="0"/>
+                      </a:rPr>
+                      <m:t>Δ</m:t>
+                    </m:r>
+                    <m:r>
+                      <a:rPr lang="en-US" b="0" i="1" smtClean="0">
+                        <a:solidFill>
+                          <a:schemeClr val="bg1"/>
+                        </a:solidFill>
+                        <a:latin typeface="Cambria Math" panose="02040503050406030204" pitchFamily="18" charset="0"/>
+                      </a:rPr>
+                      <m:t>𝑧</m:t>
+                    </m:r>
+                    <m:r>
+                      <a:rPr lang="en-US" b="0" i="1" smtClean="0">
+                        <a:solidFill>
+                          <a:schemeClr val="bg1"/>
+                        </a:solidFill>
+                        <a:latin typeface="Cambria Math" panose="02040503050406030204" pitchFamily="18" charset="0"/>
+                      </a:rPr>
+                      <m:t>|</m:t>
+                    </m:r>
+                  </m:oMath>
+                </a14:m>
+                <a:r>
+                  <a:rPr lang="en-US" dirty="0">
+                    <a:solidFill>
+                      <a:schemeClr val="bg1"/>
+                    </a:solidFill>
+                  </a:rPr>
+                  <a:t> so </a:t>
+                </a:r>
+                <a:r>
+                  <a:rPr lang="en-US" dirty="0" err="1">
+                    <a:solidFill>
+                      <a:schemeClr val="bg1"/>
+                    </a:solidFill>
+                  </a:rPr>
+                  <a:t>ist</a:t>
+                </a:r>
+                <a:r>
+                  <a:rPr lang="en-US" dirty="0">
+                    <a:solidFill>
+                      <a:schemeClr val="bg1"/>
+                    </a:solidFill>
+                  </a:rPr>
+                  <a:t> es </a:t>
+                </a:r>
+                <a:r>
+                  <a:rPr lang="en-US" dirty="0" err="1">
+                    <a:solidFill>
+                      <a:schemeClr val="bg1"/>
+                    </a:solidFill>
+                  </a:rPr>
+                  <a:t>ein</a:t>
+                </a:r>
+                <a:endParaRPr lang="en-US" dirty="0">
+                  <a:solidFill>
+                    <a:schemeClr val="bg1"/>
+                  </a:solidFill>
+                </a:endParaRPr>
+              </a:p>
+              <a:p>
+                <a:r>
+                  <a:rPr lang="en-US" dirty="0" err="1">
+                    <a:solidFill>
+                      <a:schemeClr val="bg1"/>
+                    </a:solidFill>
+                  </a:rPr>
+                  <a:t>raumartiger</a:t>
+                </a:r>
+                <a:r>
+                  <a:rPr lang="en-US" dirty="0">
+                    <a:solidFill>
+                      <a:schemeClr val="bg1"/>
+                    </a:solidFill>
+                  </a:rPr>
+                  <a:t> Vektor </a:t>
+                </a:r>
+                <a14:m>
+                  <m:oMath xmlns:m="http://schemas.openxmlformats.org/officeDocument/2006/math">
+                    <m:d>
+                      <m:dPr>
+                        <m:ctrlPr>
+                          <a:rPr lang="en-US" b="0" i="1" smtClean="0">
+                            <a:solidFill>
+                              <a:schemeClr val="bg1"/>
+                            </a:solidFill>
+                            <a:latin typeface="Cambria Math" panose="02040503050406030204" pitchFamily="18" charset="0"/>
+                          </a:rPr>
+                        </m:ctrlPr>
+                      </m:dPr>
+                      <m:e>
+                        <m:r>
+                          <m:rPr>
+                            <m:sty m:val="p"/>
+                          </m:rPr>
+                          <a:rPr lang="en-US">
+                            <a:solidFill>
+                              <a:schemeClr val="bg1"/>
+                            </a:solidFill>
+                            <a:latin typeface="Cambria Math" panose="02040503050406030204" pitchFamily="18" charset="0"/>
+                          </a:rPr>
+                          <m:t>Δ</m:t>
+                        </m:r>
+                        <m:sSup>
+                          <m:sSupPr>
+                            <m:ctrlPr>
+                              <a:rPr lang="en-US" i="1">
+                                <a:solidFill>
+                                  <a:schemeClr val="bg1"/>
+                                </a:solidFill>
+                                <a:latin typeface="Cambria Math" panose="02040503050406030204" pitchFamily="18" charset="0"/>
+                              </a:rPr>
+                            </m:ctrlPr>
+                          </m:sSupPr>
+                          <m:e>
+                            <m:r>
+                              <a:rPr lang="en-US" i="1">
+                                <a:solidFill>
+                                  <a:schemeClr val="bg1"/>
+                                </a:solidFill>
+                                <a:latin typeface="Cambria Math" panose="02040503050406030204" pitchFamily="18" charset="0"/>
+                              </a:rPr>
+                              <m:t>𝑠</m:t>
+                            </m:r>
+                          </m:e>
+                          <m:sup>
+                            <m:r>
+                              <a:rPr lang="en-US" i="1">
+                                <a:solidFill>
+                                  <a:schemeClr val="bg1"/>
+                                </a:solidFill>
+                                <a:latin typeface="Cambria Math" panose="02040503050406030204" pitchFamily="18" charset="0"/>
+                              </a:rPr>
+                              <m:t>2</m:t>
+                            </m:r>
+                          </m:sup>
+                        </m:sSup>
+                        <m:r>
+                          <a:rPr lang="en-US" b="0" i="1" smtClean="0">
+                            <a:solidFill>
+                              <a:schemeClr val="bg1"/>
+                            </a:solidFill>
+                            <a:latin typeface="Cambria Math" panose="02040503050406030204" pitchFamily="18" charset="0"/>
+                          </a:rPr>
+                          <m:t>&lt;</m:t>
+                        </m:r>
+                        <m:r>
+                          <a:rPr lang="en-US" i="1">
+                            <a:solidFill>
+                              <a:schemeClr val="bg1"/>
+                            </a:solidFill>
+                            <a:latin typeface="Cambria Math" panose="02040503050406030204" pitchFamily="18" charset="0"/>
+                          </a:rPr>
+                          <m:t>0</m:t>
+                        </m:r>
+                      </m:e>
+                    </m:d>
+                  </m:oMath>
+                </a14:m>
+                <a:endParaRPr lang="en-US" dirty="0">
+                  <a:solidFill>
+                    <a:schemeClr val="bg1"/>
+                  </a:solidFill>
+                </a:endParaRPr>
+              </a:p>
+              <a:p>
+                <a:endParaRPr lang="en-US" dirty="0">
+                  <a:solidFill>
+                    <a:schemeClr val="bg1"/>
+                  </a:solidFill>
+                </a:endParaRPr>
+              </a:p>
+              <a:p>
+                <a:r>
+                  <a:rPr lang="en-US" dirty="0" err="1">
+                    <a:solidFill>
+                      <a:schemeClr val="bg1"/>
+                    </a:solidFill>
+                  </a:rPr>
+                  <a:t>Diese</a:t>
+                </a:r>
+                <a:r>
+                  <a:rPr lang="en-US" dirty="0">
+                    <a:solidFill>
+                      <a:schemeClr val="bg1"/>
+                    </a:solidFill>
+                  </a:rPr>
+                  <a:t> </a:t>
+                </a:r>
+                <a:r>
+                  <a:rPr lang="en-US" dirty="0" err="1">
+                    <a:solidFill>
+                      <a:schemeClr val="bg1"/>
+                    </a:solidFill>
+                  </a:rPr>
+                  <a:t>Ereignisse</a:t>
+                </a:r>
+                <a:r>
+                  <a:rPr lang="en-US" dirty="0">
+                    <a:solidFill>
+                      <a:schemeClr val="bg1"/>
+                    </a:solidFill>
+                  </a:rPr>
+                  <a:t> </a:t>
+                </a:r>
+                <a:r>
+                  <a:rPr lang="en-US" dirty="0" err="1">
+                    <a:solidFill>
+                      <a:schemeClr val="bg1"/>
+                    </a:solidFill>
+                  </a:rPr>
+                  <a:t>können</a:t>
+                </a:r>
+                <a:r>
+                  <a:rPr lang="en-US" dirty="0">
+                    <a:solidFill>
+                      <a:schemeClr val="bg1"/>
+                    </a:solidFill>
+                  </a:rPr>
+                  <a:t> </a:t>
+                </a:r>
+                <a:r>
+                  <a:rPr lang="en-US" dirty="0" err="1">
+                    <a:solidFill>
+                      <a:schemeClr val="bg1"/>
+                    </a:solidFill>
+                  </a:rPr>
+                  <a:t>keinen</a:t>
+                </a:r>
+                <a:r>
+                  <a:rPr lang="en-US" dirty="0">
+                    <a:solidFill>
+                      <a:schemeClr val="bg1"/>
+                    </a:solidFill>
+                  </a:rPr>
+                  <a:t> </a:t>
+                </a:r>
+                <a:r>
+                  <a:rPr lang="en-US" dirty="0" err="1">
+                    <a:solidFill>
+                      <a:schemeClr val="bg1"/>
+                    </a:solidFill>
+                  </a:rPr>
+                  <a:t>Einfluss</a:t>
+                </a:r>
+                <a:r>
+                  <a:rPr lang="en-US" dirty="0">
+                    <a:solidFill>
+                      <a:schemeClr val="bg1"/>
+                    </a:solidFill>
+                  </a:rPr>
+                  <a:t> auf </a:t>
+                </a:r>
+                <a:r>
+                  <a:rPr lang="en-US" dirty="0" err="1">
+                    <a:solidFill>
+                      <a:schemeClr val="bg1"/>
+                    </a:solidFill>
+                  </a:rPr>
+                  <a:t>uns</a:t>
+                </a:r>
+                <a:r>
+                  <a:rPr lang="en-US" dirty="0">
+                    <a:solidFill>
+                      <a:schemeClr val="bg1"/>
+                    </a:solidFill>
+                  </a:rPr>
+                  <a:t> </a:t>
+                </a:r>
+                <a:r>
+                  <a:rPr lang="en-US" dirty="0" err="1">
+                    <a:solidFill>
+                      <a:schemeClr val="bg1"/>
+                    </a:solidFill>
+                  </a:rPr>
+                  <a:t>haben</a:t>
+                </a:r>
+                <a:r>
+                  <a:rPr lang="en-US" dirty="0">
+                    <a:solidFill>
+                      <a:schemeClr val="bg1"/>
+                    </a:solidFill>
+                  </a:rPr>
+                  <a:t> und </a:t>
+                </a:r>
+                <a:r>
+                  <a:rPr lang="en-US" dirty="0" err="1">
+                    <a:solidFill>
+                      <a:schemeClr val="bg1"/>
+                    </a:solidFill>
+                  </a:rPr>
+                  <a:t>wir</a:t>
+                </a:r>
+                <a:r>
+                  <a:rPr lang="en-US" dirty="0">
+                    <a:solidFill>
+                      <a:schemeClr val="bg1"/>
+                    </a:solidFill>
+                  </a:rPr>
+                  <a:t> </a:t>
+                </a:r>
+                <a:r>
+                  <a:rPr lang="en-US" dirty="0" err="1">
+                    <a:solidFill>
+                      <a:schemeClr val="bg1"/>
+                    </a:solidFill>
+                  </a:rPr>
+                  <a:t>keinen</a:t>
+                </a:r>
+                <a:r>
+                  <a:rPr lang="en-US" dirty="0">
+                    <a:solidFill>
+                      <a:schemeClr val="bg1"/>
+                    </a:solidFill>
+                  </a:rPr>
+                  <a:t> </a:t>
+                </a:r>
+                <a:r>
+                  <a:rPr lang="en-US" dirty="0" err="1">
+                    <a:solidFill>
+                      <a:schemeClr val="bg1"/>
+                    </a:solidFill>
+                  </a:rPr>
+                  <a:t>Einfluss</a:t>
+                </a:r>
+                <a:r>
+                  <a:rPr lang="en-US" dirty="0">
+                    <a:solidFill>
+                      <a:schemeClr val="bg1"/>
+                    </a:solidFill>
+                  </a:rPr>
+                  <a:t> auf </a:t>
+                </a:r>
+                <a:r>
+                  <a:rPr lang="en-US" dirty="0" err="1">
+                    <a:solidFill>
+                      <a:schemeClr val="bg1"/>
+                    </a:solidFill>
+                  </a:rPr>
+                  <a:t>diese</a:t>
+                </a:r>
+                <a:r>
+                  <a:rPr lang="en-US" dirty="0">
+                    <a:solidFill>
+                      <a:schemeClr val="bg1"/>
+                    </a:solidFill>
+                  </a:rPr>
+                  <a:t> </a:t>
+                </a:r>
+                <a:r>
+                  <a:rPr lang="en-US" dirty="0" err="1">
+                    <a:solidFill>
+                      <a:schemeClr val="bg1"/>
+                    </a:solidFill>
+                  </a:rPr>
+                  <a:t>Ereignisse</a:t>
+                </a:r>
+                <a:r>
+                  <a:rPr lang="en-US" dirty="0">
+                    <a:solidFill>
+                      <a:schemeClr val="bg1"/>
+                    </a:solidFill>
+                  </a:rPr>
+                  <a:t>.</a:t>
+                </a:r>
+              </a:p>
+              <a:p>
+                <a:endParaRPr lang="en-US" dirty="0">
+                  <a:solidFill>
+                    <a:schemeClr val="bg1"/>
+                  </a:solidFill>
+                </a:endParaRPr>
+              </a:p>
+            </p:txBody>
+          </p:sp>
+        </mc:Choice>
+        <mc:Fallback>
+          <p:sp>
+            <p:nvSpPr>
+              <p:cNvPr id="2" name="TextBox 1">
+                <a:extLst>
+                  <a:ext uri="{FF2B5EF4-FFF2-40B4-BE49-F238E27FC236}">
+                    <a16:creationId xmlns:a16="http://schemas.microsoft.com/office/drawing/2014/main" id="{F0EA46D7-D23D-2740-10E1-B7751F23036B}"/>
+                  </a:ext>
+                </a:extLst>
+              </p:cNvPr>
+              <p:cNvSpPr txBox="1">
+                <a:spLocks noRot="1" noChangeAspect="1" noMove="1" noResize="1" noEditPoints="1" noAdjustHandles="1" noChangeArrowheads="1" noChangeShapeType="1" noTextEdit="1"/>
+              </p:cNvSpPr>
+              <p:nvPr/>
+            </p:nvSpPr>
+            <p:spPr>
+              <a:xfrm>
+                <a:off x="8547652" y="153348"/>
+                <a:ext cx="3475855" cy="6186309"/>
+              </a:xfrm>
+              <a:prstGeom prst="rect">
+                <a:avLst/>
+              </a:prstGeom>
+              <a:blipFill>
+                <a:blip r:embed="rId3"/>
+                <a:stretch>
+                  <a:fillRect l="-1404" t="-493" r="-175"/>
+                </a:stretch>
+              </a:blipFill>
+            </p:spPr>
+            <p:txBody>
+              <a:bodyPr/>
+              <a:lstStyle/>
+              <a:p>
+                <a:r>
+                  <a:rPr lang="en-CH">
+                    <a:noFill/>
+                  </a:rPr>
+                  <a:t> </a:t>
+                </a:r>
+              </a:p>
+            </p:txBody>
+          </p:sp>
+        </mc:Fallback>
+      </mc:AlternateContent>
+    </p:spTree>
+    <p:extLst>
+      <p:ext uri="{BB962C8B-B14F-4D97-AF65-F5344CB8AC3E}">
+        <p14:creationId xmlns:p14="http://schemas.microsoft.com/office/powerpoint/2010/main" val="2201207689"/>
       </p:ext>
     </p:extLst>
   </p:cSld>
@@ -7455,8 +10147,8 @@
           </a:p>
         </p:txBody>
       </p:sp>
-      <mc:AlternateContent xmlns:mc="http://schemas.openxmlformats.org/markup-compatibility/2006">
-        <mc:Choice xmlns:a14="http://schemas.microsoft.com/office/drawing/2010/main" Requires="a14">
+      <mc:AlternateContent xmlns:mc="http://schemas.openxmlformats.org/markup-compatibility/2006" xmlns:a14="http://schemas.microsoft.com/office/drawing/2010/main">
+        <mc:Choice Requires="a14">
           <p:sp>
             <p:nvSpPr>
               <p:cNvPr id="8" name="Content Placeholder 7">
@@ -8191,7 +10883,7 @@
             </p:txBody>
           </p:sp>
         </mc:Choice>
-        <mc:Fallback>
+        <mc:Fallback xmlns="">
           <p:sp>
             <p:nvSpPr>
               <p:cNvPr id="8" name="Content Placeholder 7">
@@ -8477,8 +11169,8 @@
           </a:xfrm>
         </p:spPr>
       </p:pic>
-      <mc:AlternateContent xmlns:mc="http://schemas.openxmlformats.org/markup-compatibility/2006">
-        <mc:Choice xmlns:a14="http://schemas.microsoft.com/office/drawing/2010/main" Requires="a14">
+      <mc:AlternateContent xmlns:mc="http://schemas.openxmlformats.org/markup-compatibility/2006" xmlns:a14="http://schemas.microsoft.com/office/drawing/2010/main">
+        <mc:Choice Requires="a14">
           <p:sp>
             <p:nvSpPr>
               <p:cNvPr id="3" name="TextBox 2">
@@ -8646,7 +11338,7 @@
             </p:txBody>
           </p:sp>
         </mc:Choice>
-        <mc:Fallback>
+        <mc:Fallback xmlns="">
           <p:sp>
             <p:nvSpPr>
               <p:cNvPr id="3" name="TextBox 2">
@@ -8757,8 +11449,8 @@
           </a:xfrm>
         </p:spPr>
       </p:pic>
-      <mc:AlternateContent xmlns:mc="http://schemas.openxmlformats.org/markup-compatibility/2006">
-        <mc:Choice xmlns:a14="http://schemas.microsoft.com/office/drawing/2010/main" Requires="a14">
+      <mc:AlternateContent xmlns:mc="http://schemas.openxmlformats.org/markup-compatibility/2006" xmlns:a14="http://schemas.microsoft.com/office/drawing/2010/main">
+        <mc:Choice Requires="a14">
           <p:sp>
             <p:nvSpPr>
               <p:cNvPr id="2" name="TextBox 1">
@@ -9044,7 +11736,7 @@
             </p:txBody>
           </p:sp>
         </mc:Choice>
-        <mc:Fallback>
+        <mc:Fallback xmlns="">
           <p:sp>
             <p:nvSpPr>
               <p:cNvPr id="2" name="TextBox 1">
@@ -9155,8 +11847,8 @@
           </a:xfrm>
         </p:spPr>
       </p:pic>
-      <mc:AlternateContent xmlns:mc="http://schemas.openxmlformats.org/markup-compatibility/2006">
-        <mc:Choice xmlns:a14="http://schemas.microsoft.com/office/drawing/2010/main" Requires="a14">
+      <mc:AlternateContent xmlns:mc="http://schemas.openxmlformats.org/markup-compatibility/2006" xmlns:a14="http://schemas.microsoft.com/office/drawing/2010/main">
+        <mc:Choice Requires="a14">
           <p:sp>
             <p:nvSpPr>
               <p:cNvPr id="2" name="TextBox 1">
@@ -9504,7 +12196,7 @@
             </p:txBody>
           </p:sp>
         </mc:Choice>
-        <mc:Fallback>
+        <mc:Fallback xmlns="">
           <p:sp>
             <p:nvSpPr>
               <p:cNvPr id="2" name="TextBox 1">
@@ -9615,8 +12307,8 @@
           </a:xfrm>
         </p:spPr>
       </p:pic>
-      <mc:AlternateContent xmlns:mc="http://schemas.openxmlformats.org/markup-compatibility/2006">
-        <mc:Choice xmlns:a14="http://schemas.microsoft.com/office/drawing/2010/main" Requires="a14">
+      <mc:AlternateContent xmlns:mc="http://schemas.openxmlformats.org/markup-compatibility/2006" xmlns:a14="http://schemas.microsoft.com/office/drawing/2010/main">
+        <mc:Choice Requires="a14">
           <p:sp>
             <p:nvSpPr>
               <p:cNvPr id="2" name="TextBox 1">
@@ -9944,7 +12636,7 @@
             </p:txBody>
           </p:sp>
         </mc:Choice>
-        <mc:Fallback>
+        <mc:Fallback xmlns="">
           <p:sp>
             <p:nvSpPr>
               <p:cNvPr id="2" name="TextBox 1">
@@ -10055,8 +12747,8 @@
           </a:xfrm>
         </p:spPr>
       </p:pic>
-      <mc:AlternateContent xmlns:mc="http://schemas.openxmlformats.org/markup-compatibility/2006">
-        <mc:Choice xmlns:a14="http://schemas.microsoft.com/office/drawing/2010/main" Requires="a14">
+      <mc:AlternateContent xmlns:mc="http://schemas.openxmlformats.org/markup-compatibility/2006" xmlns:a14="http://schemas.microsoft.com/office/drawing/2010/main">
+        <mc:Choice Requires="a14">
           <p:sp>
             <p:nvSpPr>
               <p:cNvPr id="2" name="TextBox 1">
@@ -10502,7 +13194,7 @@
             </p:txBody>
           </p:sp>
         </mc:Choice>
-        <mc:Fallback>
+        <mc:Fallback xmlns="">
           <p:sp>
             <p:nvSpPr>
               <p:cNvPr id="2" name="TextBox 1">
@@ -10613,8 +13305,8 @@
           </a:xfrm>
         </p:spPr>
       </p:pic>
-      <mc:AlternateContent xmlns:mc="http://schemas.openxmlformats.org/markup-compatibility/2006">
-        <mc:Choice xmlns:a14="http://schemas.microsoft.com/office/drawing/2010/main" Requires="a14">
+      <mc:AlternateContent xmlns:mc="http://schemas.openxmlformats.org/markup-compatibility/2006" xmlns:a14="http://schemas.microsoft.com/office/drawing/2010/main">
+        <mc:Choice Requires="a14">
           <p:sp>
             <p:nvSpPr>
               <p:cNvPr id="6" name="TextBox 5">
@@ -11122,7 +13814,7 @@
             </p:txBody>
           </p:sp>
         </mc:Choice>
-        <mc:Fallback>
+        <mc:Fallback xmlns="">
           <p:sp>
             <p:nvSpPr>
               <p:cNvPr id="6" name="TextBox 5">

</xml_diff>